<commit_message>
Correct published repository links
</commit_message>
<xml_diff>
--- a/outputs/comm-ai-safety-pitch.pptx
+++ b/outputs/comm-ai-safety-pitch.pptx
@@ -2,17 +2,17 @@
 <file path=ppt/presentation.xml><?xml version="1.0" encoding="utf-8"?>
 <p:presentation xmlns:p="http://schemas.openxmlformats.org/presentationml/2006/main">
   <p:sldMasterIdLst>
-    <p:sldMasterId xmlns:r="http://schemas.openxmlformats.org/officeDocument/2006/relationships" id="2147483648" r:id="R646274c3771b4c55"/>
+    <p:sldMasterId xmlns:r="http://schemas.openxmlformats.org/officeDocument/2006/relationships" id="2147483648" r:id="Ra463183c85244ee7"/>
   </p:sldMasterIdLst>
   <p:notesMasterIdLst>
-    <p:notesMasterId xmlns:r="http://schemas.openxmlformats.org/officeDocument/2006/relationships" r:id="Rea30f640dbdc46a8"/>
+    <p:notesMasterId xmlns:r="http://schemas.openxmlformats.org/officeDocument/2006/relationships" r:id="R97bc31b1f2b24b74"/>
   </p:notesMasterIdLst>
   <p:sldIdLst>
-    <p:sldId xmlns:r="http://schemas.openxmlformats.org/officeDocument/2006/relationships" id="256" r:id="R505c64d6a8a54434"/>
-    <p:sldId xmlns:r="http://schemas.openxmlformats.org/officeDocument/2006/relationships" id="257" r:id="Rb24403c913304fb6"/>
-    <p:sldId xmlns:r="http://schemas.openxmlformats.org/officeDocument/2006/relationships" id="258" r:id="R66aa676970dd41d1"/>
-    <p:sldId xmlns:r="http://schemas.openxmlformats.org/officeDocument/2006/relationships" id="259" r:id="Ra0896b9e70ab4ff5"/>
-    <p:sldId xmlns:r="http://schemas.openxmlformats.org/officeDocument/2006/relationships" id="260" r:id="Ree1637f82d8246cd"/>
+    <p:sldId xmlns:r="http://schemas.openxmlformats.org/officeDocument/2006/relationships" id="256" r:id="R3849e11f6d9f40c6"/>
+    <p:sldId xmlns:r="http://schemas.openxmlformats.org/officeDocument/2006/relationships" id="257" r:id="Rf0c8634899c4428c"/>
+    <p:sldId xmlns:r="http://schemas.openxmlformats.org/officeDocument/2006/relationships" id="258" r:id="Rf474cc8f2cc142e1"/>
+    <p:sldId xmlns:r="http://schemas.openxmlformats.org/officeDocument/2006/relationships" id="259" r:id="R1a0025e69b7f4922"/>
+    <p:sldId xmlns:r="http://schemas.openxmlformats.org/officeDocument/2006/relationships" id="260" r:id="Raa67a947fc0748e2"/>
   </p:sldIdLst>
   <p:sldSz cx="12192000" cy="6858000"/>
   <p:notesSz cx="6858000" cy="9144000"/>
@@ -869,7 +869,7 @@
   </p:cSld>
   <p:clrMap bg1="lt1" tx1="dk1" bg2="lt2" tx2="dk2" accent1="accent1" accent2="accent2" accent3="accent3" accent4="accent4" accent5="accent5" accent6="accent6" hlink="hlink" folHlink="folHlink"/>
   <p:sldLayoutIdLst>
-    <p:sldLayoutId xmlns:r="http://schemas.openxmlformats.org/officeDocument/2006/relationships" id="2147483649" r:id="R5ead1ff873114d5b"/>
+    <p:sldLayoutId xmlns:r="http://schemas.openxmlformats.org/officeDocument/2006/relationships" id="2147483649" r:id="R3a6362d114124b95"/>
   </p:sldLayoutIdLst>
   <p:txStyles>
     <p:titleStyle>
@@ -1413,7 +1413,7 @@
           <p:cNvPr id="4" name="Title-3-1">
             <a:extLst xmlns:a="http://schemas.openxmlformats.org/drawingml/2006/main">
               <a:ext uri="{FF2B5EF4-FFF2-40B4-BE49-F238E27FC236}">
-                <a16:creationId xmlns:a16="http://schemas.microsoft.com/office/drawing/2014/main" id="{B60A08C0-AA7D-43A4-A21F-7516E290F7AC}"/>
+                <a16:creationId xmlns:a16="http://schemas.microsoft.com/office/drawing/2014/main" id="{7232E4E7-E515-4832-8427-BDD0B440D750}"/>
               </a:ext>
             </a:extLst>
           </p:cNvPr>
@@ -1466,7 +1466,7 @@
           <p:cNvPr id="2" name="Subtitle-4-2">
             <a:extLst xmlns:a="http://schemas.openxmlformats.org/drawingml/2006/main">
               <a:ext uri="{FF2B5EF4-FFF2-40B4-BE49-F238E27FC236}">
-                <a16:creationId xmlns:a16="http://schemas.microsoft.com/office/drawing/2014/main" id="{532AFF79-5971-4AEC-8A0B-9C3B8F4F7DA4}"/>
+                <a16:creationId xmlns:a16="http://schemas.microsoft.com/office/drawing/2014/main" id="{3565CA87-B0F5-43EF-B582-027AA73DC9EC}"/>
               </a:ext>
             </a:extLst>
           </p:cNvPr>
@@ -1519,7 +1519,7 @@
           <p:cNvPr id="3" name="Subtitle-4-3">
             <a:extLst xmlns:a="http://schemas.openxmlformats.org/drawingml/2006/main">
               <a:ext uri="{FF2B5EF4-FFF2-40B4-BE49-F238E27FC236}">
-                <a16:creationId xmlns:a16="http://schemas.microsoft.com/office/drawing/2014/main" id="{4E4772C6-6B96-4C00-A41A-C9063E60AC0D}"/>
+                <a16:creationId xmlns:a16="http://schemas.microsoft.com/office/drawing/2014/main" id="{C146D75E-91D2-4350-9A73-8D88C465B33F}"/>
               </a:ext>
             </a:extLst>
           </p:cNvPr>
@@ -1570,7 +1570,7 @@
     </p:spTree>
     <p:extLst>
       <p:ext uri="{BB962C8B-B14F-4D97-AF65-F5344CB8AC3E}">
-        <p14:creationId xmlns:p14="http://schemas.microsoft.com/office/powerpoint/2010/main" val="1184409867"/>
+        <p14:creationId xmlns:p14="http://schemas.microsoft.com/office/powerpoint/2010/main" val="1915495473"/>
       </p:ext>
     </p:extLst>
   </p:cSld>
@@ -1594,7 +1594,7 @@
           <p:cNvPr id="16" name="Slide-Number-Placeholder-3-2">
             <a:extLst xmlns:a="http://schemas.openxmlformats.org/drawingml/2006/main">
               <a:ext uri="{FF2B5EF4-FFF2-40B4-BE49-F238E27FC236}">
-                <a16:creationId xmlns:a16="http://schemas.microsoft.com/office/drawing/2014/main" id="{818F424F-DC70-4BE1-90A7-61945CC02D47}"/>
+                <a16:creationId xmlns:a16="http://schemas.microsoft.com/office/drawing/2014/main" id="{0995A587-66DE-407C-A4FE-FC9F45E4F611}"/>
               </a:ext>
             </a:extLst>
           </p:cNvPr>
@@ -1645,7 +1645,7 @@
           <p:cNvPr id="2" name="Title-10-3">
             <a:extLst xmlns:a="http://schemas.openxmlformats.org/drawingml/2006/main">
               <a:ext uri="{FF2B5EF4-FFF2-40B4-BE49-F238E27FC236}">
-                <a16:creationId xmlns:a16="http://schemas.microsoft.com/office/drawing/2014/main" id="{3ABD9A44-6150-47A0-B5C8-1B5D7BF83079}"/>
+                <a16:creationId xmlns:a16="http://schemas.microsoft.com/office/drawing/2014/main" id="{1D970D1F-910A-4DB5-B21E-44976C2EE12A}"/>
               </a:ext>
             </a:extLst>
           </p:cNvPr>
@@ -1720,7 +1720,7 @@
           <p:cNvPr id="4" name="Google-Shape-2260-p159-5">
             <a:extLst xmlns:a="http://schemas.openxmlformats.org/drawingml/2006/main">
               <a:ext uri="{FF2B5EF4-FFF2-40B4-BE49-F238E27FC236}">
-                <a16:creationId xmlns:a16="http://schemas.microsoft.com/office/drawing/2014/main" id="{281486C9-742C-4161-8817-520253C868B5}"/>
+                <a16:creationId xmlns:a16="http://schemas.microsoft.com/office/drawing/2014/main" id="{CB629F96-D250-45E8-9799-D843578B8FFC}"/>
               </a:ext>
             </a:extLst>
           </p:cNvPr>
@@ -1747,7 +1747,7 @@
           <p:cNvPr id="5" name="Google-Shape-2261-p159-6">
             <a:extLst xmlns:a="http://schemas.openxmlformats.org/drawingml/2006/main">
               <a:ext uri="{FF2B5EF4-FFF2-40B4-BE49-F238E27FC236}">
-                <a16:creationId xmlns:a16="http://schemas.microsoft.com/office/drawing/2014/main" id="{4FA2EAEF-4FB0-40AB-B43E-532C5B9D2B01}"/>
+                <a16:creationId xmlns:a16="http://schemas.microsoft.com/office/drawing/2014/main" id="{8313F4CE-02F8-4F1D-9FF2-2A24496008FA}"/>
               </a:ext>
             </a:extLst>
           </p:cNvPr>
@@ -1774,7 +1774,7 @@
           <p:cNvPr id="6" name="Google-Shape-2262-p159-7">
             <a:extLst xmlns:a="http://schemas.openxmlformats.org/drawingml/2006/main">
               <a:ext uri="{FF2B5EF4-FFF2-40B4-BE49-F238E27FC236}">
-                <a16:creationId xmlns:a16="http://schemas.microsoft.com/office/drawing/2014/main" id="{3FD6D392-2F96-4DF2-AD28-6BBAA5D91C0A}"/>
+                <a16:creationId xmlns:a16="http://schemas.microsoft.com/office/drawing/2014/main" id="{4504EB02-246E-4101-8628-2687FDD3115D}"/>
               </a:ext>
             </a:extLst>
           </p:cNvPr>
@@ -1801,7 +1801,7 @@
           <p:cNvPr id="7" name="Rounded-Rectangle-19-8">
             <a:extLst xmlns:a="http://schemas.openxmlformats.org/drawingml/2006/main">
               <a:ext uri="{FF2B5EF4-FFF2-40B4-BE49-F238E27FC236}">
-                <a16:creationId xmlns:a16="http://schemas.microsoft.com/office/drawing/2014/main" id="{1A595440-1354-40ED-9E54-07E72C8AFFC2}"/>
+                <a16:creationId xmlns:a16="http://schemas.microsoft.com/office/drawing/2014/main" id="{104693EC-1858-4FDE-85EC-E7C9063F46C5}"/>
               </a:ext>
             </a:extLst>
           </p:cNvPr>
@@ -1830,7 +1830,7 @@
           <p:cNvPr id="8" name="Content-Placeholder-8-9">
             <a:extLst xmlns:a="http://schemas.openxmlformats.org/drawingml/2006/main">
               <a:ext uri="{FF2B5EF4-FFF2-40B4-BE49-F238E27FC236}">
-                <a16:creationId xmlns:a16="http://schemas.microsoft.com/office/drawing/2014/main" id="{93899F6B-39C1-41EC-8D17-203FB9732760}"/>
+                <a16:creationId xmlns:a16="http://schemas.microsoft.com/office/drawing/2014/main" id="{1DDF0D07-5FB1-4ED1-B225-A0C38F5BFD12}"/>
               </a:ext>
             </a:extLst>
           </p:cNvPr>
@@ -1906,7 +1906,7 @@
           <p:cNvPr id="9" name="Rounded-Rectangle-21-10">
             <a:extLst xmlns:a="http://schemas.openxmlformats.org/drawingml/2006/main">
               <a:ext uri="{FF2B5EF4-FFF2-40B4-BE49-F238E27FC236}">
-                <a16:creationId xmlns:a16="http://schemas.microsoft.com/office/drawing/2014/main" id="{DDF4ACF4-2646-4EE3-8673-1E0203A687A0}"/>
+                <a16:creationId xmlns:a16="http://schemas.microsoft.com/office/drawing/2014/main" id="{1FB5218B-2AD3-4595-BC8E-F88AD5C914D9}"/>
               </a:ext>
             </a:extLst>
           </p:cNvPr>
@@ -1935,7 +1935,7 @@
           <p:cNvPr id="10" name="Content-Placeholder-8-11">
             <a:extLst xmlns:a="http://schemas.openxmlformats.org/drawingml/2006/main">
               <a:ext uri="{FF2B5EF4-FFF2-40B4-BE49-F238E27FC236}">
-                <a16:creationId xmlns:a16="http://schemas.microsoft.com/office/drawing/2014/main" id="{3566BA3D-DE51-493D-B485-7A587606AE26}"/>
+                <a16:creationId xmlns:a16="http://schemas.microsoft.com/office/drawing/2014/main" id="{9E793E20-2472-484D-B356-49586470E861}"/>
               </a:ext>
             </a:extLst>
           </p:cNvPr>
@@ -2011,7 +2011,7 @@
           <p:cNvPr id="11" name="Rounded-Rectangle-23-12">
             <a:extLst xmlns:a="http://schemas.openxmlformats.org/drawingml/2006/main">
               <a:ext uri="{FF2B5EF4-FFF2-40B4-BE49-F238E27FC236}">
-                <a16:creationId xmlns:a16="http://schemas.microsoft.com/office/drawing/2014/main" id="{7115DF8F-4BAF-4CB3-BD94-BB299D40E813}"/>
+                <a16:creationId xmlns:a16="http://schemas.microsoft.com/office/drawing/2014/main" id="{98995313-8447-4C0F-8A44-6BA449B0FCD6}"/>
               </a:ext>
             </a:extLst>
           </p:cNvPr>
@@ -2040,7 +2040,7 @@
           <p:cNvPr id="12" name="Content-Placeholder-8-13">
             <a:extLst xmlns:a="http://schemas.openxmlformats.org/drawingml/2006/main">
               <a:ext uri="{FF2B5EF4-FFF2-40B4-BE49-F238E27FC236}">
-                <a16:creationId xmlns:a16="http://schemas.microsoft.com/office/drawing/2014/main" id="{17856222-EC88-430F-B123-E99D8572DB76}"/>
+                <a16:creationId xmlns:a16="http://schemas.microsoft.com/office/drawing/2014/main" id="{841F4ED4-5506-45C9-B597-FC0419E51481}"/>
               </a:ext>
             </a:extLst>
           </p:cNvPr>
@@ -2116,7 +2116,7 @@
           <p:cNvPr id="13" name="Text-Placeholder-16-14">
             <a:extLst xmlns:a="http://schemas.openxmlformats.org/drawingml/2006/main">
               <a:ext uri="{FF2B5EF4-FFF2-40B4-BE49-F238E27FC236}">
-                <a16:creationId xmlns:a16="http://schemas.microsoft.com/office/drawing/2014/main" id="{80E95FDF-15E5-4FED-97FF-244A5C1F7167}"/>
+                <a16:creationId xmlns:a16="http://schemas.microsoft.com/office/drawing/2014/main" id="{8DA9A747-B800-4165-BC21-FA246C7BCCD8}"/>
               </a:ext>
             </a:extLst>
           </p:cNvPr>
@@ -2169,7 +2169,7 @@
           <p:cNvPr id="14" name="Text-Placeholder-16-15">
             <a:extLst xmlns:a="http://schemas.openxmlformats.org/drawingml/2006/main">
               <a:ext uri="{FF2B5EF4-FFF2-40B4-BE49-F238E27FC236}">
-                <a16:creationId xmlns:a16="http://schemas.microsoft.com/office/drawing/2014/main" id="{1AE6273F-922E-4A3D-81AA-F863047BE2A5}"/>
+                <a16:creationId xmlns:a16="http://schemas.microsoft.com/office/drawing/2014/main" id="{FCE864B9-59FC-4569-B52C-0015FDFB06C7}"/>
               </a:ext>
             </a:extLst>
           </p:cNvPr>
@@ -2222,7 +2222,7 @@
           <p:cNvPr id="15" name="Text-Placeholder-16-16">
             <a:extLst xmlns:a="http://schemas.openxmlformats.org/drawingml/2006/main">
               <a:ext uri="{FF2B5EF4-FFF2-40B4-BE49-F238E27FC236}">
-                <a16:creationId xmlns:a16="http://schemas.microsoft.com/office/drawing/2014/main" id="{121C0406-C692-48EB-98B1-F50CBC864528}"/>
+                <a16:creationId xmlns:a16="http://schemas.microsoft.com/office/drawing/2014/main" id="{9AD7B9B2-2DB0-47E6-972B-302CCDCC7057}"/>
               </a:ext>
             </a:extLst>
           </p:cNvPr>
@@ -2273,7 +2273,7 @@
     </p:spTree>
     <p:extLst>
       <p:ext uri="{BB962C8B-B14F-4D97-AF65-F5344CB8AC3E}">
-        <p14:creationId xmlns:p14="http://schemas.microsoft.com/office/powerpoint/2010/main" val="1497284916"/>
+        <p14:creationId xmlns:p14="http://schemas.microsoft.com/office/powerpoint/2010/main" val="1555477717"/>
       </p:ext>
     </p:extLst>
   </p:cSld>
@@ -2297,7 +2297,7 @@
           <p:cNvPr id="16" name="Slide-Number-Placeholder-3-2">
             <a:extLst xmlns:a="http://schemas.openxmlformats.org/drawingml/2006/main">
               <a:ext uri="{FF2B5EF4-FFF2-40B4-BE49-F238E27FC236}">
-                <a16:creationId xmlns:a16="http://schemas.microsoft.com/office/drawing/2014/main" id="{4DB0676B-9E69-49F0-8FFD-91F6D315F204}"/>
+                <a16:creationId xmlns:a16="http://schemas.microsoft.com/office/drawing/2014/main" id="{C74B42EF-4A35-4AEA-AED0-FAC87F9E9551}"/>
               </a:ext>
             </a:extLst>
           </p:cNvPr>
@@ -2348,7 +2348,7 @@
           <p:cNvPr id="2" name="Title-10-3">
             <a:extLst xmlns:a="http://schemas.openxmlformats.org/drawingml/2006/main">
               <a:ext uri="{FF2B5EF4-FFF2-40B4-BE49-F238E27FC236}">
-                <a16:creationId xmlns:a16="http://schemas.microsoft.com/office/drawing/2014/main" id="{6F0A4952-F1F0-426D-B722-A05831EC48A3}"/>
+                <a16:creationId xmlns:a16="http://schemas.microsoft.com/office/drawing/2014/main" id="{12BB2D75-B347-4FC5-A7DC-1E22FF5618EE}"/>
               </a:ext>
             </a:extLst>
           </p:cNvPr>
@@ -2423,7 +2423,7 @@
           <p:cNvPr id="4" name="Google-Shape-2260-p159-5">
             <a:extLst xmlns:a="http://schemas.openxmlformats.org/drawingml/2006/main">
               <a:ext uri="{FF2B5EF4-FFF2-40B4-BE49-F238E27FC236}">
-                <a16:creationId xmlns:a16="http://schemas.microsoft.com/office/drawing/2014/main" id="{5C86F75A-6E03-4ECC-A4CD-C5B679F2307C}"/>
+                <a16:creationId xmlns:a16="http://schemas.microsoft.com/office/drawing/2014/main" id="{B7E4087A-2E07-45A0-949C-E1AD9B01002A}"/>
               </a:ext>
             </a:extLst>
           </p:cNvPr>
@@ -2450,7 +2450,7 @@
           <p:cNvPr id="5" name="Google-Shape-2261-p159-6">
             <a:extLst xmlns:a="http://schemas.openxmlformats.org/drawingml/2006/main">
               <a:ext uri="{FF2B5EF4-FFF2-40B4-BE49-F238E27FC236}">
-                <a16:creationId xmlns:a16="http://schemas.microsoft.com/office/drawing/2014/main" id="{7C278E14-D9A5-4B2B-A266-0419C426C8AC}"/>
+                <a16:creationId xmlns:a16="http://schemas.microsoft.com/office/drawing/2014/main" id="{09339FD9-4AA7-40C3-AEF6-5CE5ECD92DA9}"/>
               </a:ext>
             </a:extLst>
           </p:cNvPr>
@@ -2477,7 +2477,7 @@
           <p:cNvPr id="6" name="Google-Shape-2262-p159-7">
             <a:extLst xmlns:a="http://schemas.openxmlformats.org/drawingml/2006/main">
               <a:ext uri="{FF2B5EF4-FFF2-40B4-BE49-F238E27FC236}">
-                <a16:creationId xmlns:a16="http://schemas.microsoft.com/office/drawing/2014/main" id="{5E724001-B311-49C7-A9D4-0AEAB8B29405}"/>
+                <a16:creationId xmlns:a16="http://schemas.microsoft.com/office/drawing/2014/main" id="{B7191A4F-8452-458E-849E-9B9C2BE00C33}"/>
               </a:ext>
             </a:extLst>
           </p:cNvPr>
@@ -2504,7 +2504,7 @@
           <p:cNvPr id="7" name="Rounded-Rectangle-19-8">
             <a:extLst xmlns:a="http://schemas.openxmlformats.org/drawingml/2006/main">
               <a:ext uri="{FF2B5EF4-FFF2-40B4-BE49-F238E27FC236}">
-                <a16:creationId xmlns:a16="http://schemas.microsoft.com/office/drawing/2014/main" id="{2BFBC34D-7EC5-4FBE-B2FD-07067B1A12BB}"/>
+                <a16:creationId xmlns:a16="http://schemas.microsoft.com/office/drawing/2014/main" id="{0AE2296D-4697-4EDD-9EAD-3D96C6D51F46}"/>
               </a:ext>
             </a:extLst>
           </p:cNvPr>
@@ -2533,7 +2533,7 @@
           <p:cNvPr id="8" name="Content-Placeholder-8-9">
             <a:extLst xmlns:a="http://schemas.openxmlformats.org/drawingml/2006/main">
               <a:ext uri="{FF2B5EF4-FFF2-40B4-BE49-F238E27FC236}">
-                <a16:creationId xmlns:a16="http://schemas.microsoft.com/office/drawing/2014/main" id="{01951E19-3D95-40CA-8E0D-A1876684BB6B}"/>
+                <a16:creationId xmlns:a16="http://schemas.microsoft.com/office/drawing/2014/main" id="{7C621F43-F085-4522-9E78-70D929ABBB8F}"/>
               </a:ext>
             </a:extLst>
           </p:cNvPr>
@@ -2609,7 +2609,7 @@
           <p:cNvPr id="9" name="Rounded-Rectangle-21-10">
             <a:extLst xmlns:a="http://schemas.openxmlformats.org/drawingml/2006/main">
               <a:ext uri="{FF2B5EF4-FFF2-40B4-BE49-F238E27FC236}">
-                <a16:creationId xmlns:a16="http://schemas.microsoft.com/office/drawing/2014/main" id="{79365177-7BBD-4CAA-9192-969F7E8A4D1C}"/>
+                <a16:creationId xmlns:a16="http://schemas.microsoft.com/office/drawing/2014/main" id="{4F5CA201-8DA8-4D18-B6D2-442309F81091}"/>
               </a:ext>
             </a:extLst>
           </p:cNvPr>
@@ -2638,7 +2638,7 @@
           <p:cNvPr id="10" name="Content-Placeholder-8-11">
             <a:extLst xmlns:a="http://schemas.openxmlformats.org/drawingml/2006/main">
               <a:ext uri="{FF2B5EF4-FFF2-40B4-BE49-F238E27FC236}">
-                <a16:creationId xmlns:a16="http://schemas.microsoft.com/office/drawing/2014/main" id="{C6BDAD01-F92D-4CF5-A88C-5037BF3EC7D5}"/>
+                <a16:creationId xmlns:a16="http://schemas.microsoft.com/office/drawing/2014/main" id="{8048AAF4-1EE2-4C0D-BBEA-C0F6B83A0307}"/>
               </a:ext>
             </a:extLst>
           </p:cNvPr>
@@ -2714,7 +2714,7 @@
           <p:cNvPr id="11" name="Rounded-Rectangle-23-12">
             <a:extLst xmlns:a="http://schemas.openxmlformats.org/drawingml/2006/main">
               <a:ext uri="{FF2B5EF4-FFF2-40B4-BE49-F238E27FC236}">
-                <a16:creationId xmlns:a16="http://schemas.microsoft.com/office/drawing/2014/main" id="{66B66F33-55F6-494A-8D46-7667F9095449}"/>
+                <a16:creationId xmlns:a16="http://schemas.microsoft.com/office/drawing/2014/main" id="{EE07F9C8-EBAE-4DC8-B034-41BE64AEDB67}"/>
               </a:ext>
             </a:extLst>
           </p:cNvPr>
@@ -2743,7 +2743,7 @@
           <p:cNvPr id="12" name="Content-Placeholder-8-13">
             <a:extLst xmlns:a="http://schemas.openxmlformats.org/drawingml/2006/main">
               <a:ext uri="{FF2B5EF4-FFF2-40B4-BE49-F238E27FC236}">
-                <a16:creationId xmlns:a16="http://schemas.microsoft.com/office/drawing/2014/main" id="{6C3CA84D-C234-4626-AFF7-FD8A1E5FC3FF}"/>
+                <a16:creationId xmlns:a16="http://schemas.microsoft.com/office/drawing/2014/main" id="{A48270DB-7D52-4CD3-984A-48133601814F}"/>
               </a:ext>
             </a:extLst>
           </p:cNvPr>
@@ -2819,7 +2819,7 @@
           <p:cNvPr id="13" name="Text-Placeholder-16-14">
             <a:extLst xmlns:a="http://schemas.openxmlformats.org/drawingml/2006/main">
               <a:ext uri="{FF2B5EF4-FFF2-40B4-BE49-F238E27FC236}">
-                <a16:creationId xmlns:a16="http://schemas.microsoft.com/office/drawing/2014/main" id="{E995742B-B4FF-428F-B180-80B3332ECD06}"/>
+                <a16:creationId xmlns:a16="http://schemas.microsoft.com/office/drawing/2014/main" id="{0C1A7ACC-37F3-4231-A919-6418ACB2E326}"/>
               </a:ext>
             </a:extLst>
           </p:cNvPr>
@@ -2872,7 +2872,7 @@
           <p:cNvPr id="14" name="Text-Placeholder-16-15">
             <a:extLst xmlns:a="http://schemas.openxmlformats.org/drawingml/2006/main">
               <a:ext uri="{FF2B5EF4-FFF2-40B4-BE49-F238E27FC236}">
-                <a16:creationId xmlns:a16="http://schemas.microsoft.com/office/drawing/2014/main" id="{AF9A72CB-8E64-417C-B8A6-161279C57460}"/>
+                <a16:creationId xmlns:a16="http://schemas.microsoft.com/office/drawing/2014/main" id="{328005D1-9721-41CB-A96E-6ED9CADC36F3}"/>
               </a:ext>
             </a:extLst>
           </p:cNvPr>
@@ -2925,7 +2925,7 @@
           <p:cNvPr id="15" name="Text-Placeholder-16-16">
             <a:extLst xmlns:a="http://schemas.openxmlformats.org/drawingml/2006/main">
               <a:ext uri="{FF2B5EF4-FFF2-40B4-BE49-F238E27FC236}">
-                <a16:creationId xmlns:a16="http://schemas.microsoft.com/office/drawing/2014/main" id="{757C3186-A40A-46C1-8B9F-5F85DA5D861D}"/>
+                <a16:creationId xmlns:a16="http://schemas.microsoft.com/office/drawing/2014/main" id="{8FF80ADC-6487-4C31-AFB5-6EC76BB50390}"/>
               </a:ext>
             </a:extLst>
           </p:cNvPr>
@@ -2976,7 +2976,7 @@
     </p:spTree>
     <p:extLst>
       <p:ext uri="{BB962C8B-B14F-4D97-AF65-F5344CB8AC3E}">
-        <p14:creationId xmlns:p14="http://schemas.microsoft.com/office/powerpoint/2010/main" val="13006142"/>
+        <p14:creationId xmlns:p14="http://schemas.microsoft.com/office/powerpoint/2010/main" val="963002671"/>
       </p:ext>
     </p:extLst>
   </p:cSld>
@@ -3000,7 +3000,7 @@
           <p:cNvPr id="13" name="Google-Shape-532-p58-2">
             <a:extLst xmlns:a="http://schemas.openxmlformats.org/drawingml/2006/main">
               <a:ext uri="{FF2B5EF4-FFF2-40B4-BE49-F238E27FC236}">
-                <a16:creationId xmlns:a16="http://schemas.microsoft.com/office/drawing/2014/main" id="{273D0A52-FACA-40F5-A62B-96A4D3E43B3E}"/>
+                <a16:creationId xmlns:a16="http://schemas.microsoft.com/office/drawing/2014/main" id="{F9321910-3C34-4C47-8A47-C03EABFEBFC5}"/>
               </a:ext>
             </a:extLst>
           </p:cNvPr>
@@ -3053,7 +3053,7 @@
           <p:cNvPr id="2" name="Google-Shape-533-p58-3">
             <a:extLst xmlns:a="http://schemas.openxmlformats.org/drawingml/2006/main">
               <a:ext uri="{FF2B5EF4-FFF2-40B4-BE49-F238E27FC236}">
-                <a16:creationId xmlns:a16="http://schemas.microsoft.com/office/drawing/2014/main" id="{15367DF3-955D-4BB8-9328-E27765A6A3E8}"/>
+                <a16:creationId xmlns:a16="http://schemas.microsoft.com/office/drawing/2014/main" id="{21D18752-0E16-4CEE-8FDC-C4CD6E1FEBA2}"/>
               </a:ext>
             </a:extLst>
           </p:cNvPr>
@@ -3106,7 +3106,7 @@
           <p:cNvPr id="3" name="Rounded-Rectangle-9-4">
             <a:extLst xmlns:a="http://schemas.openxmlformats.org/drawingml/2006/main">
               <a:ext uri="{FF2B5EF4-FFF2-40B4-BE49-F238E27FC236}">
-                <a16:creationId xmlns:a16="http://schemas.microsoft.com/office/drawing/2014/main" id="{97F884DD-DDB1-4AB7-AFFE-B937CE9C7558}"/>
+                <a16:creationId xmlns:a16="http://schemas.microsoft.com/office/drawing/2014/main" id="{574198CE-B09B-473F-911F-C71CFAF32CDF}"/>
               </a:ext>
             </a:extLst>
           </p:cNvPr>
@@ -3135,7 +3135,7 @@
           <p:cNvPr id="4" name="Rounded-Rectangle-10-5">
             <a:extLst xmlns:a="http://schemas.openxmlformats.org/drawingml/2006/main">
               <a:ext uri="{FF2B5EF4-FFF2-40B4-BE49-F238E27FC236}">
-                <a16:creationId xmlns:a16="http://schemas.microsoft.com/office/drawing/2014/main" id="{BB20877C-1645-423C-B402-633C0A5BD6B4}"/>
+                <a16:creationId xmlns:a16="http://schemas.microsoft.com/office/drawing/2014/main" id="{94936B71-9803-4AA5-859F-358840D598FB}"/>
               </a:ext>
             </a:extLst>
           </p:cNvPr>
@@ -3164,7 +3164,7 @@
           <p:cNvPr id="5" name="Content-Placeholder-9-6">
             <a:extLst xmlns:a="http://schemas.openxmlformats.org/drawingml/2006/main">
               <a:ext uri="{FF2B5EF4-FFF2-40B4-BE49-F238E27FC236}">
-                <a16:creationId xmlns:a16="http://schemas.microsoft.com/office/drawing/2014/main" id="{804B88D8-5EB7-4D2E-A713-5CE638DBD972}"/>
+                <a16:creationId xmlns:a16="http://schemas.microsoft.com/office/drawing/2014/main" id="{705A1ED0-229D-4AC6-A284-C3BA41C18C63}"/>
               </a:ext>
             </a:extLst>
           </p:cNvPr>
@@ -3240,7 +3240,7 @@
           <p:cNvPr id="6" name="Content-Placeholder-10-7">
             <a:extLst xmlns:a="http://schemas.openxmlformats.org/drawingml/2006/main">
               <a:ext uri="{FF2B5EF4-FFF2-40B4-BE49-F238E27FC236}">
-                <a16:creationId xmlns:a16="http://schemas.microsoft.com/office/drawing/2014/main" id="{02E4DD45-9743-4421-85E7-E09C13C4FF65}"/>
+                <a16:creationId xmlns:a16="http://schemas.microsoft.com/office/drawing/2014/main" id="{9235D7AF-942C-486A-9DF5-7B398B48F0E8}"/>
               </a:ext>
             </a:extLst>
           </p:cNvPr>
@@ -3316,7 +3316,7 @@
           <p:cNvPr id="7" name="Google-Shape-340-p61-8">
             <a:extLst xmlns:a="http://schemas.openxmlformats.org/drawingml/2006/main">
               <a:ext uri="{FF2B5EF4-FFF2-40B4-BE49-F238E27FC236}">
-                <a16:creationId xmlns:a16="http://schemas.microsoft.com/office/drawing/2014/main" id="{D81837F7-47AD-4F25-A0A4-B6985A1C5B0C}"/>
+                <a16:creationId xmlns:a16="http://schemas.microsoft.com/office/drawing/2014/main" id="{E445FF01-7B7C-4DA9-9B18-280AFD5B9506}"/>
               </a:ext>
             </a:extLst>
           </p:cNvPr>
@@ -3440,7 +3440,7 @@
           <p:cNvPr id="8" name="Google-Shape-340-p61-9">
             <a:extLst xmlns:a="http://schemas.openxmlformats.org/drawingml/2006/main">
               <a:ext uri="{FF2B5EF4-FFF2-40B4-BE49-F238E27FC236}">
-                <a16:creationId xmlns:a16="http://schemas.microsoft.com/office/drawing/2014/main" id="{2E1C6600-98BD-4486-94F1-43F4D2FAC161}"/>
+                <a16:creationId xmlns:a16="http://schemas.microsoft.com/office/drawing/2014/main" id="{9DFD8C06-B8C2-4485-8AFD-7F72E76C9DEA}"/>
               </a:ext>
             </a:extLst>
           </p:cNvPr>
@@ -3564,7 +3564,7 @@
           <p:cNvPr id="9" name="Rounded-Rectangle-5-10">
             <a:extLst xmlns:a="http://schemas.openxmlformats.org/drawingml/2006/main">
               <a:ext uri="{FF2B5EF4-FFF2-40B4-BE49-F238E27FC236}">
-                <a16:creationId xmlns:a16="http://schemas.microsoft.com/office/drawing/2014/main" id="{ACF66565-F725-4989-9967-560D5B82FAFD}"/>
+                <a16:creationId xmlns:a16="http://schemas.microsoft.com/office/drawing/2014/main" id="{1DFA647D-3479-4779-A53E-5B633E56786C}"/>
               </a:ext>
             </a:extLst>
           </p:cNvPr>
@@ -3593,7 +3593,7 @@
           <p:cNvPr id="10" name="Content-Placeholder-9-11">
             <a:extLst xmlns:a="http://schemas.openxmlformats.org/drawingml/2006/main">
               <a:ext uri="{FF2B5EF4-FFF2-40B4-BE49-F238E27FC236}">
-                <a16:creationId xmlns:a16="http://schemas.microsoft.com/office/drawing/2014/main" id="{9BA6B878-D017-40EF-A059-CEDC6E38C3BF}"/>
+                <a16:creationId xmlns:a16="http://schemas.microsoft.com/office/drawing/2014/main" id="{8BF04358-83C6-4A6F-84A9-FC749BF5EAB3}"/>
               </a:ext>
             </a:extLst>
           </p:cNvPr>
@@ -3669,7 +3669,7 @@
           <p:cNvPr id="11" name="Google-Shape-340-p61-12">
             <a:extLst xmlns:a="http://schemas.openxmlformats.org/drawingml/2006/main">
               <a:ext uri="{FF2B5EF4-FFF2-40B4-BE49-F238E27FC236}">
-                <a16:creationId xmlns:a16="http://schemas.microsoft.com/office/drawing/2014/main" id="{FDDEFE5A-7798-4DE3-AB30-0A4BA514FC6F}"/>
+                <a16:creationId xmlns:a16="http://schemas.microsoft.com/office/drawing/2014/main" id="{AE1A2476-5CF3-4A5C-ACCE-43EEEE819CDE}"/>
               </a:ext>
             </a:extLst>
           </p:cNvPr>
@@ -3793,7 +3793,7 @@
           <p:cNvPr id="12" name="Content-Placeholder-15-13">
             <a:extLst xmlns:a="http://schemas.openxmlformats.org/drawingml/2006/main">
               <a:ext uri="{FF2B5EF4-FFF2-40B4-BE49-F238E27FC236}">
-                <a16:creationId xmlns:a16="http://schemas.microsoft.com/office/drawing/2014/main" id="{068AE7BB-D0E2-48CE-852B-B22F59EE33BC}"/>
+                <a16:creationId xmlns:a16="http://schemas.microsoft.com/office/drawing/2014/main" id="{5645AB92-6C83-4E73-99E6-C5F47397BFE3}"/>
               </a:ext>
             </a:extLst>
           </p:cNvPr>
@@ -3890,7 +3890,7 @@
     </p:spTree>
     <p:extLst>
       <p:ext uri="{BB962C8B-B14F-4D97-AF65-F5344CB8AC3E}">
-        <p14:creationId xmlns:p14="http://schemas.microsoft.com/office/powerpoint/2010/main" val="917723102"/>
+        <p14:creationId xmlns:p14="http://schemas.microsoft.com/office/powerpoint/2010/main" val="1425125473"/>
       </p:ext>
     </p:extLst>
   </p:cSld>
@@ -3914,7 +3914,7 @@
           <p:cNvPr id="4" name="Title-3-1">
             <a:extLst xmlns:a="http://schemas.openxmlformats.org/drawingml/2006/main">
               <a:ext uri="{FF2B5EF4-FFF2-40B4-BE49-F238E27FC236}">
-                <a16:creationId xmlns:a16="http://schemas.microsoft.com/office/drawing/2014/main" id="{5B475A2B-7D84-4038-9B9F-4330E0C07424}"/>
+                <a16:creationId xmlns:a16="http://schemas.microsoft.com/office/drawing/2014/main" id="{06809CAF-0C45-4225-8AF3-64AB301BB3D1}"/>
               </a:ext>
             </a:extLst>
           </p:cNvPr>
@@ -3967,7 +3967,7 @@
           <p:cNvPr id="2" name="Subtitle-4-2">
             <a:extLst xmlns:a="http://schemas.openxmlformats.org/drawingml/2006/main">
               <a:ext uri="{FF2B5EF4-FFF2-40B4-BE49-F238E27FC236}">
-                <a16:creationId xmlns:a16="http://schemas.microsoft.com/office/drawing/2014/main" id="{644C4458-B0D6-4E85-A599-9343393A536B}"/>
+                <a16:creationId xmlns:a16="http://schemas.microsoft.com/office/drawing/2014/main" id="{DC810A55-3570-44A1-B4B3-38B5DFADC403}"/>
               </a:ext>
             </a:extLst>
           </p:cNvPr>
@@ -4010,7 +4010,7 @@
                 <a:ea typeface="Helvetica Neue"/>
                 <a:cs typeface="Helvetica Neue"/>
               </a:rPr>
-              <a:t>github.com/chiffonng/comm-ai-safety</a:t>
+              <a:t>github.com/mychiffonn/comm-ai-safety</a:t>
             </a:r>
           </a:p>
           <a:p xmlns:a="http://schemas.openxmlformats.org/drawingml/2006/main">
@@ -4066,7 +4066,7 @@
           <p:cNvPr id="3" name="Subtitle-4-3">
             <a:extLst xmlns:a="http://schemas.openxmlformats.org/drawingml/2006/main">
               <a:ext uri="{FF2B5EF4-FFF2-40B4-BE49-F238E27FC236}">
-                <a16:creationId xmlns:a16="http://schemas.microsoft.com/office/drawing/2014/main" id="{7D934512-83EA-4A41-9178-D03FA7E7F7FE}"/>
+                <a16:creationId xmlns:a16="http://schemas.microsoft.com/office/drawing/2014/main" id="{BE1A2892-E804-4804-9391-DE8E1C2343D4}"/>
               </a:ext>
             </a:extLst>
           </p:cNvPr>
@@ -4117,7 +4117,7 @@
     </p:spTree>
     <p:extLst>
       <p:ext uri="{BB962C8B-B14F-4D97-AF65-F5344CB8AC3E}">
-        <p14:creationId xmlns:p14="http://schemas.microsoft.com/office/powerpoint/2010/main" val="957569822"/>
+        <p14:creationId xmlns:p14="http://schemas.microsoft.com/office/powerpoint/2010/main" val="949142697"/>
       </p:ext>
     </p:extLst>
   </p:cSld>

</xml_diff>

<commit_message>
Add QR code to pitch deck
</commit_message>
<xml_diff>
--- a/outputs/comm-ai-safety-pitch.pptx
+++ b/outputs/comm-ai-safety-pitch.pptx
@@ -2,17 +2,17 @@
 <file path=ppt/presentation.xml><?xml version="1.0" encoding="utf-8"?>
 <p:presentation xmlns:p="http://schemas.openxmlformats.org/presentationml/2006/main">
   <p:sldMasterIdLst>
-    <p:sldMasterId xmlns:r="http://schemas.openxmlformats.org/officeDocument/2006/relationships" id="2147483648" r:id="Ra463183c85244ee7"/>
+    <p:sldMasterId xmlns:r="http://schemas.openxmlformats.org/officeDocument/2006/relationships" id="2147483648" r:id="Rfa5ec25aebcb4a34"/>
   </p:sldMasterIdLst>
   <p:notesMasterIdLst>
-    <p:notesMasterId xmlns:r="http://schemas.openxmlformats.org/officeDocument/2006/relationships" r:id="R97bc31b1f2b24b74"/>
+    <p:notesMasterId xmlns:r="http://schemas.openxmlformats.org/officeDocument/2006/relationships" r:id="Rb5d0304fec6d4ba5"/>
   </p:notesMasterIdLst>
   <p:sldIdLst>
-    <p:sldId xmlns:r="http://schemas.openxmlformats.org/officeDocument/2006/relationships" id="256" r:id="R3849e11f6d9f40c6"/>
-    <p:sldId xmlns:r="http://schemas.openxmlformats.org/officeDocument/2006/relationships" id="257" r:id="Rf0c8634899c4428c"/>
-    <p:sldId xmlns:r="http://schemas.openxmlformats.org/officeDocument/2006/relationships" id="258" r:id="Rf474cc8f2cc142e1"/>
-    <p:sldId xmlns:r="http://schemas.openxmlformats.org/officeDocument/2006/relationships" id="259" r:id="R1a0025e69b7f4922"/>
-    <p:sldId xmlns:r="http://schemas.openxmlformats.org/officeDocument/2006/relationships" id="260" r:id="Raa67a947fc0748e2"/>
+    <p:sldId xmlns:r="http://schemas.openxmlformats.org/officeDocument/2006/relationships" id="256" r:id="Rb7dd79bc2fa54981"/>
+    <p:sldId xmlns:r="http://schemas.openxmlformats.org/officeDocument/2006/relationships" id="257" r:id="Re1eeb2710795442a"/>
+    <p:sldId xmlns:r="http://schemas.openxmlformats.org/officeDocument/2006/relationships" id="258" r:id="R602fef116dce4913"/>
+    <p:sldId xmlns:r="http://schemas.openxmlformats.org/officeDocument/2006/relationships" id="259" r:id="R2f867bca5bed40f6"/>
+    <p:sldId xmlns:r="http://schemas.openxmlformats.org/officeDocument/2006/relationships" id="260" r:id="R2a4c57f374404327"/>
   </p:sldIdLst>
   <p:sldSz cx="12192000" cy="6858000"/>
   <p:notesSz cx="6858000" cy="9144000"/>
@@ -869,7 +869,7 @@
   </p:cSld>
   <p:clrMap bg1="lt1" tx1="dk1" bg2="lt2" tx2="dk2" accent1="accent1" accent2="accent2" accent3="accent3" accent4="accent4" accent5="accent5" accent6="accent6" hlink="hlink" folHlink="folHlink"/>
   <p:sldLayoutIdLst>
-    <p:sldLayoutId xmlns:r="http://schemas.openxmlformats.org/officeDocument/2006/relationships" id="2147483649" r:id="R3a6362d114124b95"/>
+    <p:sldLayoutId xmlns:r="http://schemas.openxmlformats.org/officeDocument/2006/relationships" id="2147483649" r:id="R5c688dca1528451c"/>
   </p:sldLayoutIdLst>
   <p:txStyles>
     <p:titleStyle>
@@ -1413,7 +1413,7 @@
           <p:cNvPr id="4" name="Title-3-1">
             <a:extLst xmlns:a="http://schemas.openxmlformats.org/drawingml/2006/main">
               <a:ext uri="{FF2B5EF4-FFF2-40B4-BE49-F238E27FC236}">
-                <a16:creationId xmlns:a16="http://schemas.microsoft.com/office/drawing/2014/main" id="{7232E4E7-E515-4832-8427-BDD0B440D750}"/>
+                <a16:creationId xmlns:a16="http://schemas.microsoft.com/office/drawing/2014/main" id="{996E5D39-115C-4B06-A203-35560FA59E7E}"/>
               </a:ext>
             </a:extLst>
           </p:cNvPr>
@@ -1466,7 +1466,7 @@
           <p:cNvPr id="2" name="Subtitle-4-2">
             <a:extLst xmlns:a="http://schemas.openxmlformats.org/drawingml/2006/main">
               <a:ext uri="{FF2B5EF4-FFF2-40B4-BE49-F238E27FC236}">
-                <a16:creationId xmlns:a16="http://schemas.microsoft.com/office/drawing/2014/main" id="{3565CA87-B0F5-43EF-B582-027AA73DC9EC}"/>
+                <a16:creationId xmlns:a16="http://schemas.microsoft.com/office/drawing/2014/main" id="{85FCDEE1-E3B8-4D16-B03B-3FFC5A79147F}"/>
               </a:ext>
             </a:extLst>
           </p:cNvPr>
@@ -1519,7 +1519,7 @@
           <p:cNvPr id="3" name="Subtitle-4-3">
             <a:extLst xmlns:a="http://schemas.openxmlformats.org/drawingml/2006/main">
               <a:ext uri="{FF2B5EF4-FFF2-40B4-BE49-F238E27FC236}">
-                <a16:creationId xmlns:a16="http://schemas.microsoft.com/office/drawing/2014/main" id="{C146D75E-91D2-4350-9A73-8D88C465B33F}"/>
+                <a16:creationId xmlns:a16="http://schemas.microsoft.com/office/drawing/2014/main" id="{48EF8B7C-71BC-4BA8-94F6-438DC6DC003A}"/>
               </a:ext>
             </a:extLst>
           </p:cNvPr>
@@ -1570,7 +1570,7 @@
     </p:spTree>
     <p:extLst>
       <p:ext uri="{BB962C8B-B14F-4D97-AF65-F5344CB8AC3E}">
-        <p14:creationId xmlns:p14="http://schemas.microsoft.com/office/powerpoint/2010/main" val="1915495473"/>
+        <p14:creationId xmlns:p14="http://schemas.microsoft.com/office/powerpoint/2010/main" val="1170619017"/>
       </p:ext>
     </p:extLst>
   </p:cSld>
@@ -1594,7 +1594,7 @@
           <p:cNvPr id="16" name="Slide-Number-Placeholder-3-2">
             <a:extLst xmlns:a="http://schemas.openxmlformats.org/drawingml/2006/main">
               <a:ext uri="{FF2B5EF4-FFF2-40B4-BE49-F238E27FC236}">
-                <a16:creationId xmlns:a16="http://schemas.microsoft.com/office/drawing/2014/main" id="{0995A587-66DE-407C-A4FE-FC9F45E4F611}"/>
+                <a16:creationId xmlns:a16="http://schemas.microsoft.com/office/drawing/2014/main" id="{7834BBE0-4342-4624-A9A4-B05A17D86824}"/>
               </a:ext>
             </a:extLst>
           </p:cNvPr>
@@ -1645,7 +1645,7 @@
           <p:cNvPr id="2" name="Title-10-3">
             <a:extLst xmlns:a="http://schemas.openxmlformats.org/drawingml/2006/main">
               <a:ext uri="{FF2B5EF4-FFF2-40B4-BE49-F238E27FC236}">
-                <a16:creationId xmlns:a16="http://schemas.microsoft.com/office/drawing/2014/main" id="{1D970D1F-910A-4DB5-B21E-44976C2EE12A}"/>
+                <a16:creationId xmlns:a16="http://schemas.microsoft.com/office/drawing/2014/main" id="{FACDA37A-EF3E-4422-9112-67EDFF95FA75}"/>
               </a:ext>
             </a:extLst>
           </p:cNvPr>
@@ -1720,7 +1720,7 @@
           <p:cNvPr id="4" name="Google-Shape-2260-p159-5">
             <a:extLst xmlns:a="http://schemas.openxmlformats.org/drawingml/2006/main">
               <a:ext uri="{FF2B5EF4-FFF2-40B4-BE49-F238E27FC236}">
-                <a16:creationId xmlns:a16="http://schemas.microsoft.com/office/drawing/2014/main" id="{CB629F96-D250-45E8-9799-D843578B8FFC}"/>
+                <a16:creationId xmlns:a16="http://schemas.microsoft.com/office/drawing/2014/main" id="{297849BA-D069-4DDE-ABC8-FD0A09834252}"/>
               </a:ext>
             </a:extLst>
           </p:cNvPr>
@@ -1747,7 +1747,7 @@
           <p:cNvPr id="5" name="Google-Shape-2261-p159-6">
             <a:extLst xmlns:a="http://schemas.openxmlformats.org/drawingml/2006/main">
               <a:ext uri="{FF2B5EF4-FFF2-40B4-BE49-F238E27FC236}">
-                <a16:creationId xmlns:a16="http://schemas.microsoft.com/office/drawing/2014/main" id="{8313F4CE-02F8-4F1D-9FF2-2A24496008FA}"/>
+                <a16:creationId xmlns:a16="http://schemas.microsoft.com/office/drawing/2014/main" id="{A0C2A718-05A0-4D9F-87AC-C01DA7E4FF58}"/>
               </a:ext>
             </a:extLst>
           </p:cNvPr>
@@ -1774,7 +1774,7 @@
           <p:cNvPr id="6" name="Google-Shape-2262-p159-7">
             <a:extLst xmlns:a="http://schemas.openxmlformats.org/drawingml/2006/main">
               <a:ext uri="{FF2B5EF4-FFF2-40B4-BE49-F238E27FC236}">
-                <a16:creationId xmlns:a16="http://schemas.microsoft.com/office/drawing/2014/main" id="{4504EB02-246E-4101-8628-2687FDD3115D}"/>
+                <a16:creationId xmlns:a16="http://schemas.microsoft.com/office/drawing/2014/main" id="{06098E42-02D6-4FC3-9E25-B663D26F9EA6}"/>
               </a:ext>
             </a:extLst>
           </p:cNvPr>
@@ -1801,7 +1801,7 @@
           <p:cNvPr id="7" name="Rounded-Rectangle-19-8">
             <a:extLst xmlns:a="http://schemas.openxmlformats.org/drawingml/2006/main">
               <a:ext uri="{FF2B5EF4-FFF2-40B4-BE49-F238E27FC236}">
-                <a16:creationId xmlns:a16="http://schemas.microsoft.com/office/drawing/2014/main" id="{104693EC-1858-4FDE-85EC-E7C9063F46C5}"/>
+                <a16:creationId xmlns:a16="http://schemas.microsoft.com/office/drawing/2014/main" id="{0C7B4E86-36A4-467A-98AA-BEEE34032F59}"/>
               </a:ext>
             </a:extLst>
           </p:cNvPr>
@@ -1830,7 +1830,7 @@
           <p:cNvPr id="8" name="Content-Placeholder-8-9">
             <a:extLst xmlns:a="http://schemas.openxmlformats.org/drawingml/2006/main">
               <a:ext uri="{FF2B5EF4-FFF2-40B4-BE49-F238E27FC236}">
-                <a16:creationId xmlns:a16="http://schemas.microsoft.com/office/drawing/2014/main" id="{1DDF0D07-5FB1-4ED1-B225-A0C38F5BFD12}"/>
+                <a16:creationId xmlns:a16="http://schemas.microsoft.com/office/drawing/2014/main" id="{B58B1D95-AD43-4B96-B770-FC2E081A749A}"/>
               </a:ext>
             </a:extLst>
           </p:cNvPr>
@@ -1906,7 +1906,7 @@
           <p:cNvPr id="9" name="Rounded-Rectangle-21-10">
             <a:extLst xmlns:a="http://schemas.openxmlformats.org/drawingml/2006/main">
               <a:ext uri="{FF2B5EF4-FFF2-40B4-BE49-F238E27FC236}">
-                <a16:creationId xmlns:a16="http://schemas.microsoft.com/office/drawing/2014/main" id="{1FB5218B-2AD3-4595-BC8E-F88AD5C914D9}"/>
+                <a16:creationId xmlns:a16="http://schemas.microsoft.com/office/drawing/2014/main" id="{2EB580B6-5FDB-447D-ACF8-7626A4AD3E02}"/>
               </a:ext>
             </a:extLst>
           </p:cNvPr>
@@ -1935,7 +1935,7 @@
           <p:cNvPr id="10" name="Content-Placeholder-8-11">
             <a:extLst xmlns:a="http://schemas.openxmlformats.org/drawingml/2006/main">
               <a:ext uri="{FF2B5EF4-FFF2-40B4-BE49-F238E27FC236}">
-                <a16:creationId xmlns:a16="http://schemas.microsoft.com/office/drawing/2014/main" id="{9E793E20-2472-484D-B356-49586470E861}"/>
+                <a16:creationId xmlns:a16="http://schemas.microsoft.com/office/drawing/2014/main" id="{5E6FA5E9-C83B-45E1-8D45-2E73FA2CB3EA}"/>
               </a:ext>
             </a:extLst>
           </p:cNvPr>
@@ -2011,7 +2011,7 @@
           <p:cNvPr id="11" name="Rounded-Rectangle-23-12">
             <a:extLst xmlns:a="http://schemas.openxmlformats.org/drawingml/2006/main">
               <a:ext uri="{FF2B5EF4-FFF2-40B4-BE49-F238E27FC236}">
-                <a16:creationId xmlns:a16="http://schemas.microsoft.com/office/drawing/2014/main" id="{98995313-8447-4C0F-8A44-6BA449B0FCD6}"/>
+                <a16:creationId xmlns:a16="http://schemas.microsoft.com/office/drawing/2014/main" id="{9EA3B962-592C-4AFA-99DD-A4237AF7184B}"/>
               </a:ext>
             </a:extLst>
           </p:cNvPr>
@@ -2040,7 +2040,7 @@
           <p:cNvPr id="12" name="Content-Placeholder-8-13">
             <a:extLst xmlns:a="http://schemas.openxmlformats.org/drawingml/2006/main">
               <a:ext uri="{FF2B5EF4-FFF2-40B4-BE49-F238E27FC236}">
-                <a16:creationId xmlns:a16="http://schemas.microsoft.com/office/drawing/2014/main" id="{841F4ED4-5506-45C9-B597-FC0419E51481}"/>
+                <a16:creationId xmlns:a16="http://schemas.microsoft.com/office/drawing/2014/main" id="{2A3873F7-2EC6-43E8-ADC5-0F6E960F9D19}"/>
               </a:ext>
             </a:extLst>
           </p:cNvPr>
@@ -2116,7 +2116,7 @@
           <p:cNvPr id="13" name="Text-Placeholder-16-14">
             <a:extLst xmlns:a="http://schemas.openxmlformats.org/drawingml/2006/main">
               <a:ext uri="{FF2B5EF4-FFF2-40B4-BE49-F238E27FC236}">
-                <a16:creationId xmlns:a16="http://schemas.microsoft.com/office/drawing/2014/main" id="{8DA9A747-B800-4165-BC21-FA246C7BCCD8}"/>
+                <a16:creationId xmlns:a16="http://schemas.microsoft.com/office/drawing/2014/main" id="{1EE8B753-8B40-4B31-9C35-89674825810F}"/>
               </a:ext>
             </a:extLst>
           </p:cNvPr>
@@ -2169,7 +2169,7 @@
           <p:cNvPr id="14" name="Text-Placeholder-16-15">
             <a:extLst xmlns:a="http://schemas.openxmlformats.org/drawingml/2006/main">
               <a:ext uri="{FF2B5EF4-FFF2-40B4-BE49-F238E27FC236}">
-                <a16:creationId xmlns:a16="http://schemas.microsoft.com/office/drawing/2014/main" id="{FCE864B9-59FC-4569-B52C-0015FDFB06C7}"/>
+                <a16:creationId xmlns:a16="http://schemas.microsoft.com/office/drawing/2014/main" id="{D61E5644-9739-4549-86C4-C7A8A15F1831}"/>
               </a:ext>
             </a:extLst>
           </p:cNvPr>
@@ -2222,7 +2222,7 @@
           <p:cNvPr id="15" name="Text-Placeholder-16-16">
             <a:extLst xmlns:a="http://schemas.openxmlformats.org/drawingml/2006/main">
               <a:ext uri="{FF2B5EF4-FFF2-40B4-BE49-F238E27FC236}">
-                <a16:creationId xmlns:a16="http://schemas.microsoft.com/office/drawing/2014/main" id="{9AD7B9B2-2DB0-47E6-972B-302CCDCC7057}"/>
+                <a16:creationId xmlns:a16="http://schemas.microsoft.com/office/drawing/2014/main" id="{91EEAF8C-14B7-4658-A793-E7C96149F74A}"/>
               </a:ext>
             </a:extLst>
           </p:cNvPr>
@@ -2273,7 +2273,7 @@
     </p:spTree>
     <p:extLst>
       <p:ext uri="{BB962C8B-B14F-4D97-AF65-F5344CB8AC3E}">
-        <p14:creationId xmlns:p14="http://schemas.microsoft.com/office/powerpoint/2010/main" val="1555477717"/>
+        <p14:creationId xmlns:p14="http://schemas.microsoft.com/office/powerpoint/2010/main" val="937284152"/>
       </p:ext>
     </p:extLst>
   </p:cSld>
@@ -2297,7 +2297,7 @@
           <p:cNvPr id="16" name="Slide-Number-Placeholder-3-2">
             <a:extLst xmlns:a="http://schemas.openxmlformats.org/drawingml/2006/main">
               <a:ext uri="{FF2B5EF4-FFF2-40B4-BE49-F238E27FC236}">
-                <a16:creationId xmlns:a16="http://schemas.microsoft.com/office/drawing/2014/main" id="{C74B42EF-4A35-4AEA-AED0-FAC87F9E9551}"/>
+                <a16:creationId xmlns:a16="http://schemas.microsoft.com/office/drawing/2014/main" id="{957F9DEB-4869-4DDD-9659-A34920483883}"/>
               </a:ext>
             </a:extLst>
           </p:cNvPr>
@@ -2348,7 +2348,7 @@
           <p:cNvPr id="2" name="Title-10-3">
             <a:extLst xmlns:a="http://schemas.openxmlformats.org/drawingml/2006/main">
               <a:ext uri="{FF2B5EF4-FFF2-40B4-BE49-F238E27FC236}">
-                <a16:creationId xmlns:a16="http://schemas.microsoft.com/office/drawing/2014/main" id="{12BB2D75-B347-4FC5-A7DC-1E22FF5618EE}"/>
+                <a16:creationId xmlns:a16="http://schemas.microsoft.com/office/drawing/2014/main" id="{9A2007B1-AAF0-4BDA-BC13-F422D27E310F}"/>
               </a:ext>
             </a:extLst>
           </p:cNvPr>
@@ -2423,7 +2423,7 @@
           <p:cNvPr id="4" name="Google-Shape-2260-p159-5">
             <a:extLst xmlns:a="http://schemas.openxmlformats.org/drawingml/2006/main">
               <a:ext uri="{FF2B5EF4-FFF2-40B4-BE49-F238E27FC236}">
-                <a16:creationId xmlns:a16="http://schemas.microsoft.com/office/drawing/2014/main" id="{B7E4087A-2E07-45A0-949C-E1AD9B01002A}"/>
+                <a16:creationId xmlns:a16="http://schemas.microsoft.com/office/drawing/2014/main" id="{48D143A6-865F-4FFF-998E-AB4957625A93}"/>
               </a:ext>
             </a:extLst>
           </p:cNvPr>
@@ -2450,7 +2450,7 @@
           <p:cNvPr id="5" name="Google-Shape-2261-p159-6">
             <a:extLst xmlns:a="http://schemas.openxmlformats.org/drawingml/2006/main">
               <a:ext uri="{FF2B5EF4-FFF2-40B4-BE49-F238E27FC236}">
-                <a16:creationId xmlns:a16="http://schemas.microsoft.com/office/drawing/2014/main" id="{09339FD9-4AA7-40C3-AEF6-5CE5ECD92DA9}"/>
+                <a16:creationId xmlns:a16="http://schemas.microsoft.com/office/drawing/2014/main" id="{03E88ED6-68FB-4B37-A48C-F52BE53183CA}"/>
               </a:ext>
             </a:extLst>
           </p:cNvPr>
@@ -2477,7 +2477,7 @@
           <p:cNvPr id="6" name="Google-Shape-2262-p159-7">
             <a:extLst xmlns:a="http://schemas.openxmlformats.org/drawingml/2006/main">
               <a:ext uri="{FF2B5EF4-FFF2-40B4-BE49-F238E27FC236}">
-                <a16:creationId xmlns:a16="http://schemas.microsoft.com/office/drawing/2014/main" id="{B7191A4F-8452-458E-849E-9B9C2BE00C33}"/>
+                <a16:creationId xmlns:a16="http://schemas.microsoft.com/office/drawing/2014/main" id="{17679430-71BA-464D-9215-C5C60176C27D}"/>
               </a:ext>
             </a:extLst>
           </p:cNvPr>
@@ -2504,7 +2504,7 @@
           <p:cNvPr id="7" name="Rounded-Rectangle-19-8">
             <a:extLst xmlns:a="http://schemas.openxmlformats.org/drawingml/2006/main">
               <a:ext uri="{FF2B5EF4-FFF2-40B4-BE49-F238E27FC236}">
-                <a16:creationId xmlns:a16="http://schemas.microsoft.com/office/drawing/2014/main" id="{0AE2296D-4697-4EDD-9EAD-3D96C6D51F46}"/>
+                <a16:creationId xmlns:a16="http://schemas.microsoft.com/office/drawing/2014/main" id="{360AE73D-6B74-441B-80D3-6E7B7DCC1E0F}"/>
               </a:ext>
             </a:extLst>
           </p:cNvPr>
@@ -2533,7 +2533,7 @@
           <p:cNvPr id="8" name="Content-Placeholder-8-9">
             <a:extLst xmlns:a="http://schemas.openxmlformats.org/drawingml/2006/main">
               <a:ext uri="{FF2B5EF4-FFF2-40B4-BE49-F238E27FC236}">
-                <a16:creationId xmlns:a16="http://schemas.microsoft.com/office/drawing/2014/main" id="{7C621F43-F085-4522-9E78-70D929ABBB8F}"/>
+                <a16:creationId xmlns:a16="http://schemas.microsoft.com/office/drawing/2014/main" id="{0F0FB1CF-C967-4F77-9D53-2F9608395DEC}"/>
               </a:ext>
             </a:extLst>
           </p:cNvPr>
@@ -2609,7 +2609,7 @@
           <p:cNvPr id="9" name="Rounded-Rectangle-21-10">
             <a:extLst xmlns:a="http://schemas.openxmlformats.org/drawingml/2006/main">
               <a:ext uri="{FF2B5EF4-FFF2-40B4-BE49-F238E27FC236}">
-                <a16:creationId xmlns:a16="http://schemas.microsoft.com/office/drawing/2014/main" id="{4F5CA201-8DA8-4D18-B6D2-442309F81091}"/>
+                <a16:creationId xmlns:a16="http://schemas.microsoft.com/office/drawing/2014/main" id="{52D5C2BA-481D-4865-9704-C6C5E1557E66}"/>
               </a:ext>
             </a:extLst>
           </p:cNvPr>
@@ -2638,7 +2638,7 @@
           <p:cNvPr id="10" name="Content-Placeholder-8-11">
             <a:extLst xmlns:a="http://schemas.openxmlformats.org/drawingml/2006/main">
               <a:ext uri="{FF2B5EF4-FFF2-40B4-BE49-F238E27FC236}">
-                <a16:creationId xmlns:a16="http://schemas.microsoft.com/office/drawing/2014/main" id="{8048AAF4-1EE2-4C0D-BBEA-C0F6B83A0307}"/>
+                <a16:creationId xmlns:a16="http://schemas.microsoft.com/office/drawing/2014/main" id="{565B7658-5617-4533-A844-62CA1AE077AA}"/>
               </a:ext>
             </a:extLst>
           </p:cNvPr>
@@ -2714,7 +2714,7 @@
           <p:cNvPr id="11" name="Rounded-Rectangle-23-12">
             <a:extLst xmlns:a="http://schemas.openxmlformats.org/drawingml/2006/main">
               <a:ext uri="{FF2B5EF4-FFF2-40B4-BE49-F238E27FC236}">
-                <a16:creationId xmlns:a16="http://schemas.microsoft.com/office/drawing/2014/main" id="{EE07F9C8-EBAE-4DC8-B034-41BE64AEDB67}"/>
+                <a16:creationId xmlns:a16="http://schemas.microsoft.com/office/drawing/2014/main" id="{88B81F4D-191B-41F9-AB50-027FC5EE5BC6}"/>
               </a:ext>
             </a:extLst>
           </p:cNvPr>
@@ -2743,7 +2743,7 @@
           <p:cNvPr id="12" name="Content-Placeholder-8-13">
             <a:extLst xmlns:a="http://schemas.openxmlformats.org/drawingml/2006/main">
               <a:ext uri="{FF2B5EF4-FFF2-40B4-BE49-F238E27FC236}">
-                <a16:creationId xmlns:a16="http://schemas.microsoft.com/office/drawing/2014/main" id="{A48270DB-7D52-4CD3-984A-48133601814F}"/>
+                <a16:creationId xmlns:a16="http://schemas.microsoft.com/office/drawing/2014/main" id="{88BF9944-1B8C-4CD4-AAD1-7402D4F05A6D}"/>
               </a:ext>
             </a:extLst>
           </p:cNvPr>
@@ -2819,7 +2819,7 @@
           <p:cNvPr id="13" name="Text-Placeholder-16-14">
             <a:extLst xmlns:a="http://schemas.openxmlformats.org/drawingml/2006/main">
               <a:ext uri="{FF2B5EF4-FFF2-40B4-BE49-F238E27FC236}">
-                <a16:creationId xmlns:a16="http://schemas.microsoft.com/office/drawing/2014/main" id="{0C1A7ACC-37F3-4231-A919-6418ACB2E326}"/>
+                <a16:creationId xmlns:a16="http://schemas.microsoft.com/office/drawing/2014/main" id="{16FA7573-F187-4C2E-AAE8-C3EA734AF506}"/>
               </a:ext>
             </a:extLst>
           </p:cNvPr>
@@ -2872,7 +2872,7 @@
           <p:cNvPr id="14" name="Text-Placeholder-16-15">
             <a:extLst xmlns:a="http://schemas.openxmlformats.org/drawingml/2006/main">
               <a:ext uri="{FF2B5EF4-FFF2-40B4-BE49-F238E27FC236}">
-                <a16:creationId xmlns:a16="http://schemas.microsoft.com/office/drawing/2014/main" id="{328005D1-9721-41CB-A96E-6ED9CADC36F3}"/>
+                <a16:creationId xmlns:a16="http://schemas.microsoft.com/office/drawing/2014/main" id="{E7824956-157C-42E0-8820-4AFC07BB7C06}"/>
               </a:ext>
             </a:extLst>
           </p:cNvPr>
@@ -2925,7 +2925,7 @@
           <p:cNvPr id="15" name="Text-Placeholder-16-16">
             <a:extLst xmlns:a="http://schemas.openxmlformats.org/drawingml/2006/main">
               <a:ext uri="{FF2B5EF4-FFF2-40B4-BE49-F238E27FC236}">
-                <a16:creationId xmlns:a16="http://schemas.microsoft.com/office/drawing/2014/main" id="{8FF80ADC-6487-4C31-AFB5-6EC76BB50390}"/>
+                <a16:creationId xmlns:a16="http://schemas.microsoft.com/office/drawing/2014/main" id="{2865F808-287C-49A0-9833-2E6B7D30C1A1}"/>
               </a:ext>
             </a:extLst>
           </p:cNvPr>
@@ -2976,7 +2976,7 @@
     </p:spTree>
     <p:extLst>
       <p:ext uri="{BB962C8B-B14F-4D97-AF65-F5344CB8AC3E}">
-        <p14:creationId xmlns:p14="http://schemas.microsoft.com/office/powerpoint/2010/main" val="963002671"/>
+        <p14:creationId xmlns:p14="http://schemas.microsoft.com/office/powerpoint/2010/main" val="1727701032"/>
       </p:ext>
     </p:extLst>
   </p:cSld>
@@ -3000,7 +3000,7 @@
           <p:cNvPr id="13" name="Google-Shape-532-p58-2">
             <a:extLst xmlns:a="http://schemas.openxmlformats.org/drawingml/2006/main">
               <a:ext uri="{FF2B5EF4-FFF2-40B4-BE49-F238E27FC236}">
-                <a16:creationId xmlns:a16="http://schemas.microsoft.com/office/drawing/2014/main" id="{F9321910-3C34-4C47-8A47-C03EABFEBFC5}"/>
+                <a16:creationId xmlns:a16="http://schemas.microsoft.com/office/drawing/2014/main" id="{84ABE108-BF7A-491C-AB2A-CDF3712C1E0F}"/>
               </a:ext>
             </a:extLst>
           </p:cNvPr>
@@ -3053,7 +3053,7 @@
           <p:cNvPr id="2" name="Google-Shape-533-p58-3">
             <a:extLst xmlns:a="http://schemas.openxmlformats.org/drawingml/2006/main">
               <a:ext uri="{FF2B5EF4-FFF2-40B4-BE49-F238E27FC236}">
-                <a16:creationId xmlns:a16="http://schemas.microsoft.com/office/drawing/2014/main" id="{21D18752-0E16-4CEE-8FDC-C4CD6E1FEBA2}"/>
+                <a16:creationId xmlns:a16="http://schemas.microsoft.com/office/drawing/2014/main" id="{A99E2CF9-8D2C-459A-9D0A-DB21089B6201}"/>
               </a:ext>
             </a:extLst>
           </p:cNvPr>
@@ -3106,7 +3106,7 @@
           <p:cNvPr id="3" name="Rounded-Rectangle-9-4">
             <a:extLst xmlns:a="http://schemas.openxmlformats.org/drawingml/2006/main">
               <a:ext uri="{FF2B5EF4-FFF2-40B4-BE49-F238E27FC236}">
-                <a16:creationId xmlns:a16="http://schemas.microsoft.com/office/drawing/2014/main" id="{574198CE-B09B-473F-911F-C71CFAF32CDF}"/>
+                <a16:creationId xmlns:a16="http://schemas.microsoft.com/office/drawing/2014/main" id="{77AE61A2-45DC-43BB-8675-E62A1552551F}"/>
               </a:ext>
             </a:extLst>
           </p:cNvPr>
@@ -3135,7 +3135,7 @@
           <p:cNvPr id="4" name="Rounded-Rectangle-10-5">
             <a:extLst xmlns:a="http://schemas.openxmlformats.org/drawingml/2006/main">
               <a:ext uri="{FF2B5EF4-FFF2-40B4-BE49-F238E27FC236}">
-                <a16:creationId xmlns:a16="http://schemas.microsoft.com/office/drawing/2014/main" id="{94936B71-9803-4AA5-859F-358840D598FB}"/>
+                <a16:creationId xmlns:a16="http://schemas.microsoft.com/office/drawing/2014/main" id="{B378CC50-C05F-4A83-8A2F-F1F16F63D989}"/>
               </a:ext>
             </a:extLst>
           </p:cNvPr>
@@ -3164,7 +3164,7 @@
           <p:cNvPr id="5" name="Content-Placeholder-9-6">
             <a:extLst xmlns:a="http://schemas.openxmlformats.org/drawingml/2006/main">
               <a:ext uri="{FF2B5EF4-FFF2-40B4-BE49-F238E27FC236}">
-                <a16:creationId xmlns:a16="http://schemas.microsoft.com/office/drawing/2014/main" id="{705A1ED0-229D-4AC6-A284-C3BA41C18C63}"/>
+                <a16:creationId xmlns:a16="http://schemas.microsoft.com/office/drawing/2014/main" id="{CBAF5CA4-63A0-40AE-86A8-7C1185111798}"/>
               </a:ext>
             </a:extLst>
           </p:cNvPr>
@@ -3240,7 +3240,7 @@
           <p:cNvPr id="6" name="Content-Placeholder-10-7">
             <a:extLst xmlns:a="http://schemas.openxmlformats.org/drawingml/2006/main">
               <a:ext uri="{FF2B5EF4-FFF2-40B4-BE49-F238E27FC236}">
-                <a16:creationId xmlns:a16="http://schemas.microsoft.com/office/drawing/2014/main" id="{9235D7AF-942C-486A-9DF5-7B398B48F0E8}"/>
+                <a16:creationId xmlns:a16="http://schemas.microsoft.com/office/drawing/2014/main" id="{FB3B1F57-ADC7-4C9B-A176-F651A39BD88B}"/>
               </a:ext>
             </a:extLst>
           </p:cNvPr>
@@ -3316,7 +3316,7 @@
           <p:cNvPr id="7" name="Google-Shape-340-p61-8">
             <a:extLst xmlns:a="http://schemas.openxmlformats.org/drawingml/2006/main">
               <a:ext uri="{FF2B5EF4-FFF2-40B4-BE49-F238E27FC236}">
-                <a16:creationId xmlns:a16="http://schemas.microsoft.com/office/drawing/2014/main" id="{E445FF01-7B7C-4DA9-9B18-280AFD5B9506}"/>
+                <a16:creationId xmlns:a16="http://schemas.microsoft.com/office/drawing/2014/main" id="{3C7BD552-A471-40C2-9394-9C73AB928185}"/>
               </a:ext>
             </a:extLst>
           </p:cNvPr>
@@ -3440,7 +3440,7 @@
           <p:cNvPr id="8" name="Google-Shape-340-p61-9">
             <a:extLst xmlns:a="http://schemas.openxmlformats.org/drawingml/2006/main">
               <a:ext uri="{FF2B5EF4-FFF2-40B4-BE49-F238E27FC236}">
-                <a16:creationId xmlns:a16="http://schemas.microsoft.com/office/drawing/2014/main" id="{9DFD8C06-B8C2-4485-8AFD-7F72E76C9DEA}"/>
+                <a16:creationId xmlns:a16="http://schemas.microsoft.com/office/drawing/2014/main" id="{EEA6CFB4-4183-4F67-93B1-CED7096376B4}"/>
               </a:ext>
             </a:extLst>
           </p:cNvPr>
@@ -3564,7 +3564,7 @@
           <p:cNvPr id="9" name="Rounded-Rectangle-5-10">
             <a:extLst xmlns:a="http://schemas.openxmlformats.org/drawingml/2006/main">
               <a:ext uri="{FF2B5EF4-FFF2-40B4-BE49-F238E27FC236}">
-                <a16:creationId xmlns:a16="http://schemas.microsoft.com/office/drawing/2014/main" id="{1DFA647D-3479-4779-A53E-5B633E56786C}"/>
+                <a16:creationId xmlns:a16="http://schemas.microsoft.com/office/drawing/2014/main" id="{4EE79339-07AC-4278-B951-0F897B8ECB8C}"/>
               </a:ext>
             </a:extLst>
           </p:cNvPr>
@@ -3593,7 +3593,7 @@
           <p:cNvPr id="10" name="Content-Placeholder-9-11">
             <a:extLst xmlns:a="http://schemas.openxmlformats.org/drawingml/2006/main">
               <a:ext uri="{FF2B5EF4-FFF2-40B4-BE49-F238E27FC236}">
-                <a16:creationId xmlns:a16="http://schemas.microsoft.com/office/drawing/2014/main" id="{8BF04358-83C6-4A6F-84A9-FC749BF5EAB3}"/>
+                <a16:creationId xmlns:a16="http://schemas.microsoft.com/office/drawing/2014/main" id="{C885B357-6091-4014-B2DF-06422E1C2259}"/>
               </a:ext>
             </a:extLst>
           </p:cNvPr>
@@ -3669,7 +3669,7 @@
           <p:cNvPr id="11" name="Google-Shape-340-p61-12">
             <a:extLst xmlns:a="http://schemas.openxmlformats.org/drawingml/2006/main">
               <a:ext uri="{FF2B5EF4-FFF2-40B4-BE49-F238E27FC236}">
-                <a16:creationId xmlns:a16="http://schemas.microsoft.com/office/drawing/2014/main" id="{AE1A2476-5CF3-4A5C-ACCE-43EEEE819CDE}"/>
+                <a16:creationId xmlns:a16="http://schemas.microsoft.com/office/drawing/2014/main" id="{875F1972-37AC-47DC-8D1F-C0FB8C87A7AC}"/>
               </a:ext>
             </a:extLst>
           </p:cNvPr>
@@ -3793,7 +3793,7 @@
           <p:cNvPr id="12" name="Content-Placeholder-15-13">
             <a:extLst xmlns:a="http://schemas.openxmlformats.org/drawingml/2006/main">
               <a:ext uri="{FF2B5EF4-FFF2-40B4-BE49-F238E27FC236}">
-                <a16:creationId xmlns:a16="http://schemas.microsoft.com/office/drawing/2014/main" id="{5645AB92-6C83-4E73-99E6-C5F47397BFE3}"/>
+                <a16:creationId xmlns:a16="http://schemas.microsoft.com/office/drawing/2014/main" id="{464DDC0B-A0A7-44B7-B249-132D2189E40D}"/>
               </a:ext>
             </a:extLst>
           </p:cNvPr>
@@ -3890,7 +3890,7 @@
     </p:spTree>
     <p:extLst>
       <p:ext uri="{BB962C8B-B14F-4D97-AF65-F5344CB8AC3E}">
-        <p14:creationId xmlns:p14="http://schemas.microsoft.com/office/powerpoint/2010/main" val="1425125473"/>
+        <p14:creationId xmlns:p14="http://schemas.microsoft.com/office/powerpoint/2010/main" val="1748398193"/>
       </p:ext>
     </p:extLst>
   </p:cSld>
@@ -3911,10 +3911,10 @@
       </p:grpSpPr>
       <p:sp>
         <p:nvSpPr>
-          <p:cNvPr id="4" name="Title-3-1">
-            <a:extLst xmlns:a="http://schemas.openxmlformats.org/drawingml/2006/main">
-              <a:ext uri="{FF2B5EF4-FFF2-40B4-BE49-F238E27FC236}">
-                <a16:creationId xmlns:a16="http://schemas.microsoft.com/office/drawing/2014/main" id="{06809CAF-0C45-4225-8AF3-64AB301BB3D1}"/>
+          <p:cNvPr id="5" name="Title-3-1">
+            <a:extLst xmlns:a="http://schemas.openxmlformats.org/drawingml/2006/main">
+              <a:ext uri="{FF2B5EF4-FFF2-40B4-BE49-F238E27FC236}">
+                <a16:creationId xmlns:a16="http://schemas.microsoft.com/office/drawing/2014/main" id="{719F3077-BB57-4574-A1C5-D479A04FBA95}"/>
               </a:ext>
             </a:extLst>
           </p:cNvPr>
@@ -3967,7 +3967,7 @@
           <p:cNvPr id="2" name="Subtitle-4-2">
             <a:extLst xmlns:a="http://schemas.openxmlformats.org/drawingml/2006/main">
               <a:ext uri="{FF2B5EF4-FFF2-40B4-BE49-F238E27FC236}">
-                <a16:creationId xmlns:a16="http://schemas.microsoft.com/office/drawing/2014/main" id="{DC810A55-3570-44A1-B4B3-38B5DFADC403}"/>
+                <a16:creationId xmlns:a16="http://schemas.microsoft.com/office/drawing/2014/main" id="{592F3EDF-31E5-420A-9109-7D6EFB643188}"/>
               </a:ext>
             </a:extLst>
           </p:cNvPr>
@@ -4010,7 +4010,7 @@
                 <a:ea typeface="Helvetica Neue"/>
                 <a:cs typeface="Helvetica Neue"/>
               </a:rPr>
-              <a:t>github.com/mychiffonn/comm-ai-safety</a:t>
+              <a:t>Scan for the GitHub repo</a:t>
             </a:r>
           </a:p>
           <a:p xmlns:a="http://schemas.openxmlformats.org/drawingml/2006/main">
@@ -4033,7 +4033,7 @@
                 <a:ea typeface="Helvetica Neue"/>
                 <a:cs typeface="Helvetica Neue"/>
               </a:rPr>
-              <a:t>Worked case: Emergent Misalignment</a:t>
+              <a:t>Worked demo included</a:t>
             </a:r>
           </a:p>
           <a:p xmlns:a="http://schemas.openxmlformats.org/drawingml/2006/main">
@@ -4056,7 +4056,7 @@
                 <a:ea typeface="Helvetica Neue"/>
                 <a:cs typeface="Helvetica Neue"/>
               </a:rPr>
-              <a:t>Open Agent Skills · source-linked · human-in-the-loop</a:t>
+              <a:t>Human-reviewed claims</a:t>
             </a:r>
           </a:p>
         </p:txBody>
@@ -4066,7 +4066,7 @@
           <p:cNvPr id="3" name="Subtitle-4-3">
             <a:extLst xmlns:a="http://schemas.openxmlformats.org/drawingml/2006/main">
               <a:ext uri="{FF2B5EF4-FFF2-40B4-BE49-F238E27FC236}">
-                <a16:creationId xmlns:a16="http://schemas.microsoft.com/office/drawing/2014/main" id="{BE1A2892-E804-4804-9391-DE8E1C2343D4}"/>
+                <a16:creationId xmlns:a16="http://schemas.microsoft.com/office/drawing/2014/main" id="{27F33065-D539-4843-9A5F-30B32BCCF50D}"/>
               </a:ext>
             </a:extLst>
           </p:cNvPr>
@@ -4114,10 +4114,32 @@
           </a:p>
         </p:txBody>
       </p:sp>
+      <p:pic>
+        <p:nvPicPr>
+          <p:cNvPr id="8" name=""/>
+          <p:cNvPicPr>
+            <a:picLocks xmlns:a="http://schemas.openxmlformats.org/drawingml/2006/main" noChangeAspect="1"/>
+          </p:cNvPicPr>
+          <p:nvPr/>
+        </p:nvPicPr>
+        <p:blipFill>
+          <a:blip xmlns:r="http://schemas.openxmlformats.org/officeDocument/2006/relationships" xmlns:a="http://schemas.openxmlformats.org/drawingml/2006/main" r:embed="Rd1e73d3c3fb2441a"/>
+          <a:stretch xmlns:a="http://schemas.openxmlformats.org/drawingml/2006/main"/>
+        </p:blipFill>
+        <p:spPr>
+          <a:xfrm xmlns:a="http://schemas.openxmlformats.org/drawingml/2006/main">
+            <a:off x="9925050" y="4514850"/>
+            <a:ext cx="1466850" cy="1466850"/>
+          </a:xfrm>
+          <a:prstGeom xmlns:a="http://schemas.openxmlformats.org/drawingml/2006/main" prst="rect">
+            <a:avLst/>
+          </a:prstGeom>
+        </p:spPr>
+      </p:pic>
     </p:spTree>
     <p:extLst>
       <p:ext uri="{BB962C8B-B14F-4D97-AF65-F5344CB8AC3E}">
-        <p14:creationId xmlns:p14="http://schemas.microsoft.com/office/powerpoint/2010/main" val="949142697"/>
+        <p14:creationId xmlns:p14="http://schemas.microsoft.com/office/powerpoint/2010/main" val="1377389497"/>
       </p:ext>
     </p:extLst>
   </p:cSld>

</xml_diff>

<commit_message>
Update skills and pitch
</commit_message>
<xml_diff>
--- a/outputs/comm-ai-safety-pitch.pptx
+++ b/outputs/comm-ai-safety-pitch.pptx
@@ -2,17 +2,19 @@
 <file path=ppt/presentation.xml><?xml version="1.0" encoding="utf-8"?>
 <p:presentation xmlns:p="http://schemas.openxmlformats.org/presentationml/2006/main">
   <p:sldMasterIdLst>
-    <p:sldMasterId xmlns:r="http://schemas.openxmlformats.org/officeDocument/2006/relationships" id="2147483648" r:id="Rfa5ec25aebcb4a34"/>
+    <p:sldMasterId xmlns:r="http://schemas.openxmlformats.org/officeDocument/2006/relationships" id="2147483648" r:id="R97fdfe62dfda48e0"/>
   </p:sldMasterIdLst>
   <p:notesMasterIdLst>
-    <p:notesMasterId xmlns:r="http://schemas.openxmlformats.org/officeDocument/2006/relationships" r:id="Rb5d0304fec6d4ba5"/>
+    <p:notesMasterId xmlns:r="http://schemas.openxmlformats.org/officeDocument/2006/relationships" r:id="Re3c7235550bd4fa0"/>
   </p:notesMasterIdLst>
   <p:sldIdLst>
-    <p:sldId xmlns:r="http://schemas.openxmlformats.org/officeDocument/2006/relationships" id="256" r:id="Rb7dd79bc2fa54981"/>
-    <p:sldId xmlns:r="http://schemas.openxmlformats.org/officeDocument/2006/relationships" id="257" r:id="Re1eeb2710795442a"/>
-    <p:sldId xmlns:r="http://schemas.openxmlformats.org/officeDocument/2006/relationships" id="258" r:id="R602fef116dce4913"/>
-    <p:sldId xmlns:r="http://schemas.openxmlformats.org/officeDocument/2006/relationships" id="259" r:id="R2f867bca5bed40f6"/>
-    <p:sldId xmlns:r="http://schemas.openxmlformats.org/officeDocument/2006/relationships" id="260" r:id="R2a4c57f374404327"/>
+    <p:sldId xmlns:r="http://schemas.openxmlformats.org/officeDocument/2006/relationships" id="256" r:id="R0b80fb50f1b74f60"/>
+    <p:sldId xmlns:r="http://schemas.openxmlformats.org/officeDocument/2006/relationships" id="257" r:id="Rc7264047938f49f3"/>
+    <p:sldId xmlns:r="http://schemas.openxmlformats.org/officeDocument/2006/relationships" id="258" r:id="R1ccb9078423c447f"/>
+    <p:sldId xmlns:r="http://schemas.openxmlformats.org/officeDocument/2006/relationships" id="259" r:id="Ra95b1e2dd9374b22"/>
+    <p:sldId xmlns:r="http://schemas.openxmlformats.org/officeDocument/2006/relationships" id="260" r:id="Rb149d41d46cf4dea"/>
+    <p:sldId xmlns:r="http://schemas.openxmlformats.org/officeDocument/2006/relationships" id="261" r:id="R6a05cfbb561e49a3"/>
+    <p:sldId xmlns:r="http://schemas.openxmlformats.org/officeDocument/2006/relationships" id="262" r:id="Rbed9cddcb9ba49f0"/>
   </p:sldIdLst>
   <p:sldSz cx="12192000" cy="6858000"/>
   <p:notesSz cx="6858000" cy="9144000"/>
@@ -831,6 +833,138 @@
 </p:notes>
 </file>
 
+<file path=ppt/notesSlides/notesSlide6.xml><?xml version="1.0" encoding="utf-8"?>
+<p:notes xmlns:p="http://schemas.openxmlformats.org/presentationml/2006/main">
+  <p:cSld>
+    <p:spTree>
+      <p:nvGrpSpPr>
+        <p:cNvPr id="1" name=""/>
+        <p:cNvGrpSpPr/>
+        <p:nvPr/>
+      </p:nvGrpSpPr>
+      <p:grpSpPr>
+        <a:xfrm xmlns:a="http://schemas.openxmlformats.org/drawingml/2006/main"/>
+      </p:grpSpPr>
+      <p:sp>
+        <p:nvSpPr>
+          <p:cNvPr id="2" name="Slide Image Placeholder 1"/>
+          <p:cNvSpPr>
+            <a:spLocks xmlns:a="http://schemas.openxmlformats.org/drawingml/2006/main" noGrp="1"/>
+          </p:cNvSpPr>
+          <p:nvPr>
+            <p:ph type="sldImg" idx="0"/>
+          </p:nvPr>
+        </p:nvSpPr>
+        <p:spPr/>
+      </p:sp>
+      <p:sp>
+        <p:nvSpPr>
+          <p:cNvPr id="3" name="Notes Placeholder 2"/>
+          <p:cNvSpPr>
+            <a:spLocks xmlns:a="http://schemas.openxmlformats.org/drawingml/2006/main" noGrp="1"/>
+          </p:cNvSpPr>
+          <p:nvPr>
+            <p:ph type="body" idx="1"/>
+          </p:nvPr>
+        </p:nvSpPr>
+        <p:spPr/>
+        <p:txBody>
+          <a:bodyPr xmlns:a="http://schemas.openxmlformats.org/drawingml/2006/main"/>
+          <a:lstStyle xmlns:a="http://schemas.openxmlformats.org/drawingml/2006/main"/>
+          <a:p xmlns:a="http://schemas.openxmlformats.org/drawingml/2006/main"/>
+        </p:txBody>
+      </p:sp>
+      <p:sp>
+        <p:nvSpPr>
+          <p:cNvPr id="4" name="Slide Number Placeholder 3"/>
+          <p:cNvSpPr>
+            <a:spLocks xmlns:a="http://schemas.openxmlformats.org/drawingml/2006/main" noGrp="1"/>
+          </p:cNvSpPr>
+          <p:nvPr>
+            <p:ph type="sldNum" idx="5"/>
+          </p:nvPr>
+        </p:nvSpPr>
+        <p:spPr/>
+        <p:txBody>
+          <a:bodyPr xmlns:a="http://schemas.openxmlformats.org/drawingml/2006/main"/>
+          <a:lstStyle xmlns:a="http://schemas.openxmlformats.org/drawingml/2006/main"/>
+          <a:p xmlns:a="http://schemas.openxmlformats.org/drawingml/2006/main"/>
+        </p:txBody>
+      </p:sp>
+    </p:spTree>
+  </p:cSld>
+  <p:clrMapOvr>
+    <a:masterClrMapping xmlns:a="http://schemas.openxmlformats.org/drawingml/2006/main"/>
+  </p:clrMapOvr>
+</p:notes>
+</file>
+
+<file path=ppt/notesSlides/notesSlide7.xml><?xml version="1.0" encoding="utf-8"?>
+<p:notes xmlns:p="http://schemas.openxmlformats.org/presentationml/2006/main">
+  <p:cSld>
+    <p:spTree>
+      <p:nvGrpSpPr>
+        <p:cNvPr id="1" name=""/>
+        <p:cNvGrpSpPr/>
+        <p:nvPr/>
+      </p:nvGrpSpPr>
+      <p:grpSpPr>
+        <a:xfrm xmlns:a="http://schemas.openxmlformats.org/drawingml/2006/main"/>
+      </p:grpSpPr>
+      <p:sp>
+        <p:nvSpPr>
+          <p:cNvPr id="2" name="Slide Image Placeholder 1"/>
+          <p:cNvSpPr>
+            <a:spLocks xmlns:a="http://schemas.openxmlformats.org/drawingml/2006/main" noGrp="1"/>
+          </p:cNvSpPr>
+          <p:nvPr>
+            <p:ph type="sldImg" idx="0"/>
+          </p:nvPr>
+        </p:nvSpPr>
+        <p:spPr/>
+      </p:sp>
+      <p:sp>
+        <p:nvSpPr>
+          <p:cNvPr id="3" name="Notes Placeholder 2"/>
+          <p:cNvSpPr>
+            <a:spLocks xmlns:a="http://schemas.openxmlformats.org/drawingml/2006/main" noGrp="1"/>
+          </p:cNvSpPr>
+          <p:nvPr>
+            <p:ph type="body" idx="1"/>
+          </p:nvPr>
+        </p:nvSpPr>
+        <p:spPr/>
+        <p:txBody>
+          <a:bodyPr xmlns:a="http://schemas.openxmlformats.org/drawingml/2006/main"/>
+          <a:lstStyle xmlns:a="http://schemas.openxmlformats.org/drawingml/2006/main"/>
+          <a:p xmlns:a="http://schemas.openxmlformats.org/drawingml/2006/main"/>
+        </p:txBody>
+      </p:sp>
+      <p:sp>
+        <p:nvSpPr>
+          <p:cNvPr id="4" name="Slide Number Placeholder 3"/>
+          <p:cNvSpPr>
+            <a:spLocks xmlns:a="http://schemas.openxmlformats.org/drawingml/2006/main" noGrp="1"/>
+          </p:cNvSpPr>
+          <p:nvPr>
+            <p:ph type="sldNum" idx="5"/>
+          </p:nvPr>
+        </p:nvSpPr>
+        <p:spPr/>
+        <p:txBody>
+          <a:bodyPr xmlns:a="http://schemas.openxmlformats.org/drawingml/2006/main"/>
+          <a:lstStyle xmlns:a="http://schemas.openxmlformats.org/drawingml/2006/main"/>
+          <a:p xmlns:a="http://schemas.openxmlformats.org/drawingml/2006/main"/>
+        </p:txBody>
+      </p:sp>
+    </p:spTree>
+  </p:cSld>
+  <p:clrMapOvr>
+    <a:masterClrMapping xmlns:a="http://schemas.openxmlformats.org/drawingml/2006/main"/>
+  </p:clrMapOvr>
+</p:notes>
+</file>
+
 <file path=ppt/slideLayouts/slideLayout1.xml><?xml version="1.0" encoding="utf-8"?>
 <p:sldLayout xmlns:p="http://schemas.openxmlformats.org/presentationml/2006/main" type="title">
   <p:cSld name="Title Slide">
@@ -869,7 +1003,7 @@
   </p:cSld>
   <p:clrMap bg1="lt1" tx1="dk1" bg2="lt2" tx2="dk2" accent1="accent1" accent2="accent2" accent3="accent3" accent4="accent4" accent5="accent5" accent6="accent6" hlink="hlink" folHlink="folHlink"/>
   <p:sldLayoutIdLst>
-    <p:sldLayoutId xmlns:r="http://schemas.openxmlformats.org/officeDocument/2006/relationships" id="2147483649" r:id="R5c688dca1528451c"/>
+    <p:sldLayoutId xmlns:r="http://schemas.openxmlformats.org/officeDocument/2006/relationships" id="2147483649" r:id="R5648174e553a4cc1"/>
   </p:sldLayoutIdLst>
   <p:txStyles>
     <p:titleStyle>
@@ -1438,6 +1572,7 @@
           <a:lstStyle xmlns:a="http://schemas.openxmlformats.org/drawingml/2006/main"/>
           <a:p xmlns:a="http://schemas.openxmlformats.org/drawingml/2006/main">
             <a:pPr algn="l">
+              <a:buNone/>
               <a:defRPr sz="6000">
                 <a:solidFill>
                   <a:srgbClr val="000000"/>
@@ -1491,6 +1626,7 @@
           <a:lstStyle xmlns:a="http://schemas.openxmlformats.org/drawingml/2006/main"/>
           <a:p xmlns:a="http://schemas.openxmlformats.org/drawingml/2006/main">
             <a:pPr algn="l">
+              <a:buNone/>
               <a:defRPr sz="2400">
                 <a:solidFill>
                   <a:srgbClr val="000000"/>
@@ -1509,7 +1645,7 @@
                 <a:ea typeface="Helvetica Neue"/>
                 <a:cs typeface="Helvetica Neue"/>
               </a:rPr>
-              <a:t>comm-ai-safety turns technical sources into reviewable public communication—without losing the conditions that make a claim true.</a:t>
+              <a:t>comm-ai-safety turns technical sources into fast, reviewable public communication—then keeps human approval and source fidelity as publication gates.</a:t>
             </a:r>
           </a:p>
         </p:txBody>
@@ -1544,6 +1680,7 @@
           <a:lstStyle xmlns:a="http://schemas.openxmlformats.org/drawingml/2006/main"/>
           <a:p xmlns:a="http://schemas.openxmlformats.org/drawingml/2006/main">
             <a:pPr algn="l">
+              <a:buNone/>
               <a:defRPr sz="2400">
                 <a:solidFill>
                   <a:srgbClr val="000000"/>
@@ -1562,7 +1699,7 @@
                 <a:ea typeface="Helvetica Neue"/>
                 <a:cs typeface="Helvetica Neue"/>
               </a:rPr>
-              <a:t>AI-safety hackathon</a:t>
+              <a:t>AI-safety communication skills</a:t>
             </a:r>
           </a:p>
         </p:txBody>
@@ -1591,10 +1728,10 @@
       </p:grpSpPr>
       <p:sp>
         <p:nvSpPr>
-          <p:cNvPr id="16" name="Slide-Number-Placeholder-3-2">
-            <a:extLst xmlns:a="http://schemas.openxmlformats.org/drawingml/2006/main">
-              <a:ext uri="{FF2B5EF4-FFF2-40B4-BE49-F238E27FC236}">
-                <a16:creationId xmlns:a16="http://schemas.microsoft.com/office/drawing/2014/main" id="{7834BBE0-4342-4624-A9A4-B05A17D86824}"/>
+          <p:cNvPr id="13" name="Google-Shape-532-p58-2">
+            <a:extLst xmlns:a="http://schemas.openxmlformats.org/drawingml/2006/main">
+              <a:ext uri="{FF2B5EF4-FFF2-40B4-BE49-F238E27FC236}">
+                <a16:creationId xmlns:a16="http://schemas.microsoft.com/office/drawing/2014/main" id="{84ABE108-BF7A-491C-AB2A-CDF3712C1E0F}"/>
               </a:ext>
             </a:extLst>
           </p:cNvPr>
@@ -1613,10 +1750,13 @@
           </a:prstGeom>
         </p:spPr>
         <p:txBody>
-          <a:bodyPr xmlns:a="http://schemas.openxmlformats.org/drawingml/2006/main" lIns="0" tIns="0" rIns="0" bIns="0" anchor="b"/>
+          <a:bodyPr xmlns:a="http://schemas.openxmlformats.org/drawingml/2006/main" wrap="square" lIns="0" tIns="0" rIns="0" bIns="0" anchor="b">
+            <a:noAutofit/>
+          </a:bodyPr>
           <a:lstStyle xmlns:a="http://schemas.openxmlformats.org/drawingml/2006/main"/>
           <a:p xmlns:a="http://schemas.openxmlformats.org/drawingml/2006/main">
             <a:pPr algn="r">
+              <a:buNone/>
               <a:defRPr sz="1000">
                 <a:solidFill>
                   <a:srgbClr val="000000"/>
@@ -1642,34 +1782,35 @@
       </p:sp>
       <p:sp>
         <p:nvSpPr>
-          <p:cNvPr id="2" name="Title-10-3">
-            <a:extLst xmlns:a="http://schemas.openxmlformats.org/drawingml/2006/main">
-              <a:ext uri="{FF2B5EF4-FFF2-40B4-BE49-F238E27FC236}">
-                <a16:creationId xmlns:a16="http://schemas.microsoft.com/office/drawing/2014/main" id="{FACDA37A-EF3E-4422-9112-67EDFF95FA75}"/>
-              </a:ext>
-            </a:extLst>
-          </p:cNvPr>
-          <p:cNvSpPr>
-            <a:spLocks xmlns:a="http://schemas.openxmlformats.org/drawingml/2006/main" noGrp="1"/>
-          </p:cNvSpPr>
-          <p:nvPr/>
-        </p:nvSpPr>
-        <p:spPr>
-          <a:xfrm xmlns:a="http://schemas.openxmlformats.org/drawingml/2006/main">
-            <a:off x="393668" y="344043"/>
-            <a:ext cx="11404568" cy="1047464"/>
+          <p:cNvPr id="2" name="Google-Shape-533-p58-3">
+            <a:extLst xmlns:a="http://schemas.openxmlformats.org/drawingml/2006/main">
+              <a:ext uri="{FF2B5EF4-FFF2-40B4-BE49-F238E27FC236}">
+                <a16:creationId xmlns:a16="http://schemas.microsoft.com/office/drawing/2014/main" id="{A99E2CF9-8D2C-459A-9D0A-DB21089B6201}"/>
+              </a:ext>
+            </a:extLst>
+          </p:cNvPr>
+          <p:cNvSpPr>
+            <a:spLocks xmlns:a="http://schemas.openxmlformats.org/drawingml/2006/main" noGrp="1"/>
+          </p:cNvSpPr>
+          <p:nvPr/>
+        </p:nvSpPr>
+        <p:spPr>
+          <a:xfrm xmlns:a="http://schemas.openxmlformats.org/drawingml/2006/main">
+            <a:off x="393668" y="344519"/>
+            <a:ext cx="11404568" cy="1283018"/>
           </a:xfrm>
           <a:prstGeom xmlns:a="http://schemas.openxmlformats.org/drawingml/2006/main" prst="rect">
             <a:avLst/>
           </a:prstGeom>
         </p:spPr>
         <p:txBody>
-          <a:bodyPr xmlns:a="http://schemas.openxmlformats.org/drawingml/2006/main" lIns="0" tIns="0" rIns="0" bIns="0" anchor="t">
-            <a:normAutofit fontScale="100000"/>
+          <a:bodyPr xmlns:a="http://schemas.openxmlformats.org/drawingml/2006/main" wrap="square" lIns="0" tIns="0" rIns="0" bIns="0" anchor="t">
+            <a:noAutofit/>
           </a:bodyPr>
           <a:lstStyle xmlns:a="http://schemas.openxmlformats.org/drawingml/2006/main"/>
           <a:p xmlns:a="http://schemas.openxmlformats.org/drawingml/2006/main">
             <a:pPr algn="l">
+              <a:buNone/>
               <a:defRPr sz="2900">
                 <a:solidFill>
                   <a:srgbClr val="000000"/>
@@ -1688,136 +1829,33 @@
                 <a:ea typeface="Helvetica Neue"/>
                 <a:cs typeface="Helvetica Neue"/>
               </a:rPr>
-              <a:t>The failure happens when evidence crosses audiences.</a:t>
+              <a:t>Portable skills make careful communication easier to repeat.</a:t>
             </a:r>
           </a:p>
         </p:txBody>
       </p:sp>
-      <p:cxnSp>
-        <p:nvCxnSpPr>
-          <p:cNvPr id="18" name="Google-Shape-2259-p159-4"/>
-          <p:cNvCxnSpPr/>
-          <p:nvPr/>
-        </p:nvCxnSpPr>
-        <p:spPr>
-          <a:xfrm xmlns:a="http://schemas.openxmlformats.org/drawingml/2006/main">
-            <a:off x="337757" y="5341620"/>
-            <a:ext cx="12245435" cy="286"/>
-          </a:xfrm>
-          <a:prstGeom xmlns:a="http://schemas.openxmlformats.org/drawingml/2006/main" prst="straightConnector1">
-            <a:avLst/>
-          </a:prstGeom>
-          <a:ln xmlns:a="http://schemas.openxmlformats.org/drawingml/2006/main" w="9525">
-            <a:solidFill>
-              <a:srgbClr val="000000"/>
-            </a:solidFill>
-            <a:prstDash val="solid"/>
-          </a:ln>
-        </p:spPr>
-      </p:cxnSp>
-      <p:sp>
-        <p:nvSpPr>
-          <p:cNvPr id="4" name="Google-Shape-2260-p159-5">
-            <a:extLst xmlns:a="http://schemas.openxmlformats.org/drawingml/2006/main">
-              <a:ext uri="{FF2B5EF4-FFF2-40B4-BE49-F238E27FC236}">
-                <a16:creationId xmlns:a16="http://schemas.microsoft.com/office/drawing/2014/main" id="{297849BA-D069-4DDE-ABC8-FD0A09834252}"/>
-              </a:ext>
-            </a:extLst>
-          </p:cNvPr>
-          <p:cNvSpPr>
-            <a:spLocks xmlns:a="http://schemas.openxmlformats.org/drawingml/2006/main" noGrp="1"/>
-          </p:cNvSpPr>
-          <p:nvPr/>
-        </p:nvSpPr>
-        <p:spPr>
-          <a:xfrm xmlns:a="http://schemas.openxmlformats.org/drawingml/2006/main">
-            <a:off x="337757" y="5288089"/>
-            <a:ext cx="107061" cy="107061"/>
-          </a:xfrm>
-          <a:prstGeom xmlns:a="http://schemas.openxmlformats.org/drawingml/2006/main" prst="ellipse">
-            <a:avLst/>
-          </a:prstGeom>
-          <a:solidFill xmlns:a="http://schemas.openxmlformats.org/drawingml/2006/main">
-            <a:srgbClr val="000000"/>
-          </a:solidFill>
-        </p:spPr>
-      </p:sp>
-      <p:sp>
-        <p:nvSpPr>
-          <p:cNvPr id="5" name="Google-Shape-2261-p159-6">
-            <a:extLst xmlns:a="http://schemas.openxmlformats.org/drawingml/2006/main">
-              <a:ext uri="{FF2B5EF4-FFF2-40B4-BE49-F238E27FC236}">
-                <a16:creationId xmlns:a16="http://schemas.microsoft.com/office/drawing/2014/main" id="{A0C2A718-05A0-4D9F-87AC-C01DA7E4FF58}"/>
-              </a:ext>
-            </a:extLst>
-          </p:cNvPr>
-          <p:cNvSpPr>
-            <a:spLocks xmlns:a="http://schemas.openxmlformats.org/drawingml/2006/main" noGrp="1"/>
-          </p:cNvSpPr>
-          <p:nvPr/>
-        </p:nvSpPr>
-        <p:spPr>
-          <a:xfrm xmlns:a="http://schemas.openxmlformats.org/drawingml/2006/main">
-            <a:off x="4251770" y="5288089"/>
-            <a:ext cx="107061" cy="107061"/>
-          </a:xfrm>
-          <a:prstGeom xmlns:a="http://schemas.openxmlformats.org/drawingml/2006/main" prst="ellipse">
-            <a:avLst/>
-          </a:prstGeom>
-          <a:solidFill xmlns:a="http://schemas.openxmlformats.org/drawingml/2006/main">
-            <a:srgbClr val="000000"/>
-          </a:solidFill>
-        </p:spPr>
-      </p:sp>
-      <p:sp>
-        <p:nvSpPr>
-          <p:cNvPr id="6" name="Google-Shape-2262-p159-7">
-            <a:extLst xmlns:a="http://schemas.openxmlformats.org/drawingml/2006/main">
-              <a:ext uri="{FF2B5EF4-FFF2-40B4-BE49-F238E27FC236}">
-                <a16:creationId xmlns:a16="http://schemas.microsoft.com/office/drawing/2014/main" id="{06098E42-02D6-4FC3-9E25-B663D26F9EA6}"/>
-              </a:ext>
-            </a:extLst>
-          </p:cNvPr>
-          <p:cNvSpPr>
-            <a:spLocks xmlns:a="http://schemas.openxmlformats.org/drawingml/2006/main" noGrp="1"/>
-          </p:cNvSpPr>
-          <p:nvPr/>
-        </p:nvSpPr>
-        <p:spPr>
-          <a:xfrm xmlns:a="http://schemas.openxmlformats.org/drawingml/2006/main">
-            <a:off x="8176070" y="5288089"/>
-            <a:ext cx="107061" cy="107061"/>
-          </a:xfrm>
-          <a:prstGeom xmlns:a="http://schemas.openxmlformats.org/drawingml/2006/main" prst="ellipse">
-            <a:avLst/>
-          </a:prstGeom>
-          <a:solidFill xmlns:a="http://schemas.openxmlformats.org/drawingml/2006/main">
-            <a:srgbClr val="000000"/>
-          </a:solidFill>
-        </p:spPr>
-      </p:sp>
-      <p:sp>
-        <p:nvSpPr>
-          <p:cNvPr id="7" name="Rounded-Rectangle-19-8">
-            <a:extLst xmlns:a="http://schemas.openxmlformats.org/drawingml/2006/main">
-              <a:ext uri="{FF2B5EF4-FFF2-40B4-BE49-F238E27FC236}">
-                <a16:creationId xmlns:a16="http://schemas.microsoft.com/office/drawing/2014/main" id="{0C7B4E86-36A4-467A-98AA-BEEE34032F59}"/>
-              </a:ext>
-            </a:extLst>
-          </p:cNvPr>
-          <p:cNvSpPr>
-            <a:spLocks xmlns:a="http://schemas.openxmlformats.org/drawingml/2006/main" noGrp="1"/>
-          </p:cNvSpPr>
-          <p:nvPr/>
-        </p:nvSpPr>
-        <p:spPr>
-          <a:xfrm xmlns:a="http://schemas.openxmlformats.org/drawingml/2006/main">
-            <a:off x="393668" y="1401794"/>
-            <a:ext cx="3568732" cy="3619500"/>
+      <p:sp>
+        <p:nvSpPr>
+          <p:cNvPr id="3" name="Rounded-Rectangle-9-4">
+            <a:extLst xmlns:a="http://schemas.openxmlformats.org/drawingml/2006/main">
+              <a:ext uri="{FF2B5EF4-FFF2-40B4-BE49-F238E27FC236}">
+                <a16:creationId xmlns:a16="http://schemas.microsoft.com/office/drawing/2014/main" id="{77AE61A2-45DC-43BB-8675-E62A1552551F}"/>
+              </a:ext>
+            </a:extLst>
+          </p:cNvPr>
+          <p:cNvSpPr>
+            <a:spLocks xmlns:a="http://schemas.openxmlformats.org/drawingml/2006/main" noGrp="1"/>
+          </p:cNvSpPr>
+          <p:nvPr/>
+        </p:nvSpPr>
+        <p:spPr>
+          <a:xfrm xmlns:a="http://schemas.openxmlformats.org/drawingml/2006/main">
+            <a:off x="4308920" y="3365468"/>
+            <a:ext cx="3568732" cy="2628900"/>
           </a:xfrm>
           <a:prstGeom xmlns:a="http://schemas.openxmlformats.org/drawingml/2006/main" prst="roundRect">
             <a:avLst>
-              <a:gd name="adj" fmla="val 2135"/>
+              <a:gd name="adj" fmla="val 2899"/>
             </a:avLst>
           </a:prstGeom>
           <a:solidFill xmlns:a="http://schemas.openxmlformats.org/drawingml/2006/main">
@@ -1827,22 +1865,51 @@
       </p:sp>
       <p:sp>
         <p:nvSpPr>
-          <p:cNvPr id="8" name="Content-Placeholder-8-9">
-            <a:extLst xmlns:a="http://schemas.openxmlformats.org/drawingml/2006/main">
-              <a:ext uri="{FF2B5EF4-FFF2-40B4-BE49-F238E27FC236}">
-                <a16:creationId xmlns:a16="http://schemas.microsoft.com/office/drawing/2014/main" id="{B58B1D95-AD43-4B96-B770-FC2E081A749A}"/>
-              </a:ext>
-            </a:extLst>
-          </p:cNvPr>
-          <p:cNvSpPr>
-            <a:spLocks xmlns:a="http://schemas.openxmlformats.org/drawingml/2006/main" noGrp="1"/>
-          </p:cNvSpPr>
-          <p:nvPr/>
-        </p:nvSpPr>
-        <p:spPr>
-          <a:xfrm xmlns:a="http://schemas.openxmlformats.org/drawingml/2006/main">
-            <a:off x="703421" y="1806797"/>
-            <a:ext cx="2949321" cy="2566797"/>
+          <p:cNvPr id="4" name="Rounded-Rectangle-10-5">
+            <a:extLst xmlns:a="http://schemas.openxmlformats.org/drawingml/2006/main">
+              <a:ext uri="{FF2B5EF4-FFF2-40B4-BE49-F238E27FC236}">
+                <a16:creationId xmlns:a16="http://schemas.microsoft.com/office/drawing/2014/main" id="{B378CC50-C05F-4A83-8A2F-F1F16F63D989}"/>
+              </a:ext>
+            </a:extLst>
+          </p:cNvPr>
+          <p:cNvSpPr>
+            <a:spLocks xmlns:a="http://schemas.openxmlformats.org/drawingml/2006/main" noGrp="1"/>
+          </p:cNvSpPr>
+          <p:nvPr/>
+        </p:nvSpPr>
+        <p:spPr>
+          <a:xfrm xmlns:a="http://schemas.openxmlformats.org/drawingml/2006/main">
+            <a:off x="8229600" y="3365468"/>
+            <a:ext cx="3568732" cy="2628900"/>
+          </a:xfrm>
+          <a:prstGeom xmlns:a="http://schemas.openxmlformats.org/drawingml/2006/main" prst="roundRect">
+            <a:avLst>
+              <a:gd name="adj" fmla="val 2899"/>
+            </a:avLst>
+          </a:prstGeom>
+          <a:solidFill xmlns:a="http://schemas.openxmlformats.org/drawingml/2006/main">
+            <a:srgbClr val="F2F2F2"/>
+          </a:solidFill>
+        </p:spPr>
+      </p:sp>
+      <p:sp>
+        <p:nvSpPr>
+          <p:cNvPr id="5" name="Content-Placeholder-9-6">
+            <a:extLst xmlns:a="http://schemas.openxmlformats.org/drawingml/2006/main">
+              <a:ext uri="{FF2B5EF4-FFF2-40B4-BE49-F238E27FC236}">
+                <a16:creationId xmlns:a16="http://schemas.microsoft.com/office/drawing/2014/main" id="{CBAF5CA4-63A0-40AE-86A8-7C1185111798}"/>
+              </a:ext>
+            </a:extLst>
+          </p:cNvPr>
+          <p:cNvSpPr>
+            <a:spLocks xmlns:a="http://schemas.openxmlformats.org/drawingml/2006/main" noGrp="1"/>
+          </p:cNvSpPr>
+          <p:nvPr/>
+        </p:nvSpPr>
+        <p:spPr>
+          <a:xfrm xmlns:a="http://schemas.openxmlformats.org/drawingml/2006/main">
+            <a:off x="4621816" y="4146137"/>
+            <a:ext cx="2949321" cy="1432846"/>
           </a:xfrm>
           <a:prstGeom xmlns:a="http://schemas.openxmlformats.org/drawingml/2006/main" prst="rect">
             <a:avLst/>
@@ -1855,7 +1922,8 @@
           <a:lstStyle xmlns:a="http://schemas.openxmlformats.org/drawingml/2006/main"/>
           <a:p xmlns:a="http://schemas.openxmlformats.org/drawingml/2006/main">
             <a:pPr algn="l">
-              <a:defRPr sz="1600">
+              <a:buNone/>
+              <a:defRPr sz="2400">
                 <a:solidFill>
                   <a:srgbClr val="000000"/>
                 </a:solidFill>
@@ -1873,12 +1941,13 @@
                 <a:ea typeface="Helvetica Neue"/>
                 <a:cs typeface="Helvetica Neue"/>
               </a:rPr>
-              <a:t>Technical result</a:t>
+              <a:t>Move faster with gates</a:t>
             </a:r>
           </a:p>
           <a:p xmlns:a="http://schemas.openxmlformats.org/drawingml/2006/main">
             <a:pPr algn="l">
-              <a:defRPr sz="1600">
+              <a:buNone/>
+              <a:defRPr sz="2400">
                 <a:solidFill>
                   <a:srgbClr val="000000"/>
                 </a:solidFill>
@@ -1896,58 +1965,29 @@
                 <a:ea typeface="Helvetica Neue"/>
                 <a:cs typeface="Helvetica Neue"/>
               </a:rPr>
-              <a:t>A result is bounded by model, task, prompting, baseline, uncertainty, and caveats.</a:t>
+              <a:t>Draft early; verify evidence and get human approval before publication.</a:t>
             </a:r>
           </a:p>
         </p:txBody>
       </p:sp>
       <p:sp>
         <p:nvSpPr>
-          <p:cNvPr id="9" name="Rounded-Rectangle-21-10">
-            <a:extLst xmlns:a="http://schemas.openxmlformats.org/drawingml/2006/main">
-              <a:ext uri="{FF2B5EF4-FFF2-40B4-BE49-F238E27FC236}">
-                <a16:creationId xmlns:a16="http://schemas.microsoft.com/office/drawing/2014/main" id="{2EB580B6-5FDB-447D-ACF8-7626A4AD3E02}"/>
-              </a:ext>
-            </a:extLst>
-          </p:cNvPr>
-          <p:cNvSpPr>
-            <a:spLocks xmlns:a="http://schemas.openxmlformats.org/drawingml/2006/main" noGrp="1"/>
-          </p:cNvSpPr>
-          <p:nvPr/>
-        </p:nvSpPr>
-        <p:spPr>
-          <a:xfrm xmlns:a="http://schemas.openxmlformats.org/drawingml/2006/main">
-            <a:off x="4308443" y="1401794"/>
-            <a:ext cx="3568732" cy="3619500"/>
-          </a:xfrm>
-          <a:prstGeom xmlns:a="http://schemas.openxmlformats.org/drawingml/2006/main" prst="roundRect">
-            <a:avLst>
-              <a:gd name="adj" fmla="val 2135"/>
-            </a:avLst>
-          </a:prstGeom>
-          <a:solidFill xmlns:a="http://schemas.openxmlformats.org/drawingml/2006/main">
-            <a:srgbClr val="F2F2F2"/>
-          </a:solidFill>
-        </p:spPr>
-      </p:sp>
-      <p:sp>
-        <p:nvSpPr>
-          <p:cNvPr id="10" name="Content-Placeholder-8-11">
-            <a:extLst xmlns:a="http://schemas.openxmlformats.org/drawingml/2006/main">
-              <a:ext uri="{FF2B5EF4-FFF2-40B4-BE49-F238E27FC236}">
-                <a16:creationId xmlns:a16="http://schemas.microsoft.com/office/drawing/2014/main" id="{5E6FA5E9-C83B-45E1-8D45-2E73FA2CB3EA}"/>
-              </a:ext>
-            </a:extLst>
-          </p:cNvPr>
-          <p:cNvSpPr>
-            <a:spLocks xmlns:a="http://schemas.openxmlformats.org/drawingml/2006/main" noGrp="1"/>
-          </p:cNvSpPr>
-          <p:nvPr/>
-        </p:nvSpPr>
-        <p:spPr>
-          <a:xfrm xmlns:a="http://schemas.openxmlformats.org/drawingml/2006/main">
-            <a:off x="4618196" y="1806797"/>
-            <a:ext cx="2949321" cy="2566797"/>
+          <p:cNvPr id="6" name="Content-Placeholder-10-7">
+            <a:extLst xmlns:a="http://schemas.openxmlformats.org/drawingml/2006/main">
+              <a:ext uri="{FF2B5EF4-FFF2-40B4-BE49-F238E27FC236}">
+                <a16:creationId xmlns:a16="http://schemas.microsoft.com/office/drawing/2014/main" id="{FB3B1F57-ADC7-4C9B-A176-F651A39BD88B}"/>
+              </a:ext>
+            </a:extLst>
+          </p:cNvPr>
+          <p:cNvSpPr>
+            <a:spLocks xmlns:a="http://schemas.openxmlformats.org/drawingml/2006/main" noGrp="1"/>
+          </p:cNvSpPr>
+          <p:nvPr/>
+        </p:nvSpPr>
+        <p:spPr>
+          <a:xfrm xmlns:a="http://schemas.openxmlformats.org/drawingml/2006/main">
+            <a:off x="8536115" y="4146137"/>
+            <a:ext cx="2949321" cy="1432846"/>
           </a:xfrm>
           <a:prstGeom xmlns:a="http://schemas.openxmlformats.org/drawingml/2006/main" prst="rect">
             <a:avLst/>
@@ -1960,7 +2000,8 @@
           <a:lstStyle xmlns:a="http://schemas.openxmlformats.org/drawingml/2006/main"/>
           <a:p xmlns:a="http://schemas.openxmlformats.org/drawingml/2006/main">
             <a:pPr algn="l">
-              <a:defRPr sz="1600">
+              <a:buNone/>
+              <a:defRPr sz="2400">
                 <a:solidFill>
                   <a:srgbClr val="000000"/>
                 </a:solidFill>
@@ -1978,12 +2019,13 @@
                 <a:ea typeface="Helvetica Neue"/>
                 <a:cs typeface="Helvetica Neue"/>
               </a:rPr>
-              <a:t>Public artifact</a:t>
+              <a:t>Keep one evidence spine</a:t>
             </a:r>
           </a:p>
           <a:p xmlns:a="http://schemas.openxmlformats.org/drawingml/2006/main">
             <a:pPr algn="l">
-              <a:defRPr sz="1600">
+              <a:buNone/>
+              <a:defRPr sz="2400">
                 <a:solidFill>
                   <a:srgbClr val="000000"/>
                 </a:solidFill>
@@ -2001,33 +2043,281 @@
                 <a:ea typeface="Helvetica Neue"/>
                 <a:cs typeface="Helvetica Neue"/>
               </a:rPr>
-              <a:t>A release, post, visual, or demo must stay clear, useful, and faithful under compression.</a:t>
+              <a:t>Public, press, and audit outputs share the same claim boundaries.</a:t>
             </a:r>
           </a:p>
         </p:txBody>
       </p:sp>
       <p:sp>
         <p:nvSpPr>
-          <p:cNvPr id="11" name="Rounded-Rectangle-23-12">
-            <a:extLst xmlns:a="http://schemas.openxmlformats.org/drawingml/2006/main">
-              <a:ext uri="{FF2B5EF4-FFF2-40B4-BE49-F238E27FC236}">
-                <a16:creationId xmlns:a16="http://schemas.microsoft.com/office/drawing/2014/main" id="{9EA3B962-592C-4AFA-99DD-A4237AF7184B}"/>
-              </a:ext>
-            </a:extLst>
-          </p:cNvPr>
-          <p:cNvSpPr>
-            <a:spLocks xmlns:a="http://schemas.openxmlformats.org/drawingml/2006/main" noGrp="1"/>
-          </p:cNvSpPr>
-          <p:nvPr/>
-        </p:nvSpPr>
-        <p:spPr>
-          <a:xfrm xmlns:a="http://schemas.openxmlformats.org/drawingml/2006/main">
-            <a:off x="8237506" y="1401794"/>
-            <a:ext cx="3568732" cy="3619500"/>
+          <p:cNvPr id="7" name="Google-Shape-340-p61-8">
+            <a:extLst xmlns:a="http://schemas.openxmlformats.org/drawingml/2006/main">
+              <a:ext uri="{FF2B5EF4-FFF2-40B4-BE49-F238E27FC236}">
+                <a16:creationId xmlns:a16="http://schemas.microsoft.com/office/drawing/2014/main" id="{3C7BD552-A471-40C2-9394-9C73AB928185}"/>
+              </a:ext>
+            </a:extLst>
+          </p:cNvPr>
+          <p:cNvSpPr>
+            <a:spLocks xmlns:a="http://schemas.openxmlformats.org/drawingml/2006/main" noGrp="1"/>
+          </p:cNvSpPr>
+          <p:nvPr/>
+        </p:nvSpPr>
+        <p:spPr>
+          <a:xfrm xmlns:a="http://schemas.openxmlformats.org/drawingml/2006/main">
+            <a:off x="4627626" y="3694081"/>
+            <a:ext cx="233839" cy="233744"/>
+          </a:xfrm>
+          <a:custGeom xmlns:a="http://schemas.openxmlformats.org/drawingml/2006/main">
+            <a:pathLst>
+              <a:path w="205740000" h="205740000">
+                <a:moveTo>
+                  <a:pt x="102870000" y="20574000"/>
+                </a:moveTo>
+                <a:cubicBezTo>
+                  <a:pt x="57426225" y="20574000"/>
+                  <a:pt x="20574000" y="57426225"/>
+                  <a:pt x="20574000" y="102870000"/>
+                </a:cubicBezTo>
+                <a:cubicBezTo>
+                  <a:pt x="20574000" y="148313775"/>
+                  <a:pt x="57426225" y="185166000"/>
+                  <a:pt x="102870000" y="185166000"/>
+                </a:cubicBezTo>
+                <a:cubicBezTo>
+                  <a:pt x="148313775" y="185166000"/>
+                  <a:pt x="185166000" y="148313775"/>
+                  <a:pt x="185166000" y="102870000"/>
+                </a:cubicBezTo>
+                <a:cubicBezTo>
+                  <a:pt x="185166000" y="57426225"/>
+                  <a:pt x="148313775" y="20574000"/>
+                  <a:pt x="102870000" y="20574000"/>
+                </a:cubicBezTo>
+                <a:close/>
+                <a:moveTo>
+                  <a:pt x="0" y="102870000"/>
+                </a:moveTo>
+                <a:cubicBezTo>
+                  <a:pt x="0" y="46053375"/>
+                  <a:pt x="46053375" y="0"/>
+                  <a:pt x="102870000" y="0"/>
+                </a:cubicBezTo>
+                <a:cubicBezTo>
+                  <a:pt x="159686625" y="0"/>
+                  <a:pt x="205740000" y="46053375"/>
+                  <a:pt x="205740000" y="102870000"/>
+                </a:cubicBezTo>
+                <a:cubicBezTo>
+                  <a:pt x="205740000" y="159686625"/>
+                  <a:pt x="159686625" y="205740000"/>
+                  <a:pt x="102870000" y="205740000"/>
+                </a:cubicBezTo>
+                <a:cubicBezTo>
+                  <a:pt x="46053375" y="205740000"/>
+                  <a:pt x="0" y="159686625"/>
+                  <a:pt x="0" y="102870000"/>
+                </a:cubicBezTo>
+                <a:close/>
+                <a:moveTo>
+                  <a:pt x="144789525" y="61026675"/>
+                </a:moveTo>
+                <a:cubicBezTo>
+                  <a:pt x="149437725" y="64293750"/>
+                  <a:pt x="150561675" y="70713600"/>
+                  <a:pt x="147285075" y="75352275"/>
+                </a:cubicBezTo>
+                <a:lnTo>
+                  <a:pt x="98421825" y="144789525"/>
+                </a:lnTo>
+                <a:cubicBezTo>
+                  <a:pt x="96621600" y="147351750"/>
+                  <a:pt x="93764100" y="148942425"/>
+                  <a:pt x="90649425" y="149142450"/>
+                </a:cubicBezTo>
+                <a:cubicBezTo>
+                  <a:pt x="87534750" y="149332950"/>
+                  <a:pt x="84496275" y="148104225"/>
+                  <a:pt x="82400775" y="145799175"/>
+                </a:cubicBezTo>
+                <a:lnTo>
+                  <a:pt x="56683275" y="117509925"/>
+                </a:lnTo>
+                <a:cubicBezTo>
+                  <a:pt x="52863750" y="113299875"/>
+                  <a:pt x="53178075" y="106803825"/>
+                  <a:pt x="57369075" y="102974775"/>
+                </a:cubicBezTo>
+                <a:cubicBezTo>
+                  <a:pt x="61579125" y="99155250"/>
+                  <a:pt x="68075175" y="99469575"/>
+                  <a:pt x="71904225" y="103660575"/>
+                </a:cubicBezTo>
+                <a:lnTo>
+                  <a:pt x="88982550" y="122453400"/>
+                </a:lnTo>
+                <a:lnTo>
+                  <a:pt x="130463925" y="63522225"/>
+                </a:lnTo>
+                <a:cubicBezTo>
+                  <a:pt x="133731000" y="58874025"/>
+                  <a:pt x="140150850" y="57750075"/>
+                  <a:pt x="144789525" y="61026675"/>
+                </a:cubicBezTo>
+                <a:close/>
+              </a:path>
+            </a:pathLst>
+          </a:custGeom>
+          <a:solidFill xmlns:a="http://schemas.openxmlformats.org/drawingml/2006/main">
+            <a:srgbClr val="000000"/>
+          </a:solidFill>
+        </p:spPr>
+      </p:sp>
+      <p:sp>
+        <p:nvSpPr>
+          <p:cNvPr id="8" name="Google-Shape-340-p61-9">
+            <a:extLst xmlns:a="http://schemas.openxmlformats.org/drawingml/2006/main">
+              <a:ext uri="{FF2B5EF4-FFF2-40B4-BE49-F238E27FC236}">
+                <a16:creationId xmlns:a16="http://schemas.microsoft.com/office/drawing/2014/main" id="{EEA6CFB4-4183-4F67-93B1-CED7096376B4}"/>
+              </a:ext>
+            </a:extLst>
+          </p:cNvPr>
+          <p:cNvSpPr>
+            <a:spLocks xmlns:a="http://schemas.openxmlformats.org/drawingml/2006/main" noGrp="1"/>
+          </p:cNvSpPr>
+          <p:nvPr/>
+        </p:nvSpPr>
+        <p:spPr>
+          <a:xfrm xmlns:a="http://schemas.openxmlformats.org/drawingml/2006/main">
+            <a:off x="8533257" y="3694081"/>
+            <a:ext cx="233839" cy="233744"/>
+          </a:xfrm>
+          <a:custGeom xmlns:a="http://schemas.openxmlformats.org/drawingml/2006/main">
+            <a:pathLst>
+              <a:path w="205740000" h="205740000">
+                <a:moveTo>
+                  <a:pt x="102870000" y="20574000"/>
+                </a:moveTo>
+                <a:cubicBezTo>
+                  <a:pt x="57426225" y="20574000"/>
+                  <a:pt x="20574000" y="57426225"/>
+                  <a:pt x="20574000" y="102870000"/>
+                </a:cubicBezTo>
+                <a:cubicBezTo>
+                  <a:pt x="20574000" y="148313775"/>
+                  <a:pt x="57426225" y="185166000"/>
+                  <a:pt x="102870000" y="185166000"/>
+                </a:cubicBezTo>
+                <a:cubicBezTo>
+                  <a:pt x="148313775" y="185166000"/>
+                  <a:pt x="185166000" y="148313775"/>
+                  <a:pt x="185166000" y="102870000"/>
+                </a:cubicBezTo>
+                <a:cubicBezTo>
+                  <a:pt x="185166000" y="57426225"/>
+                  <a:pt x="148313775" y="20574000"/>
+                  <a:pt x="102870000" y="20574000"/>
+                </a:cubicBezTo>
+                <a:close/>
+                <a:moveTo>
+                  <a:pt x="0" y="102870000"/>
+                </a:moveTo>
+                <a:cubicBezTo>
+                  <a:pt x="0" y="46053375"/>
+                  <a:pt x="46053375" y="0"/>
+                  <a:pt x="102870000" y="0"/>
+                </a:cubicBezTo>
+                <a:cubicBezTo>
+                  <a:pt x="159686625" y="0"/>
+                  <a:pt x="205740000" y="46053375"/>
+                  <a:pt x="205740000" y="102870000"/>
+                </a:cubicBezTo>
+                <a:cubicBezTo>
+                  <a:pt x="205740000" y="159686625"/>
+                  <a:pt x="159686625" y="205740000"/>
+                  <a:pt x="102870000" y="205740000"/>
+                </a:cubicBezTo>
+                <a:cubicBezTo>
+                  <a:pt x="46053375" y="205740000"/>
+                  <a:pt x="0" y="159686625"/>
+                  <a:pt x="0" y="102870000"/>
+                </a:cubicBezTo>
+                <a:close/>
+                <a:moveTo>
+                  <a:pt x="144789525" y="61026675"/>
+                </a:moveTo>
+                <a:cubicBezTo>
+                  <a:pt x="149437725" y="64293750"/>
+                  <a:pt x="150561675" y="70713600"/>
+                  <a:pt x="147285075" y="75352275"/>
+                </a:cubicBezTo>
+                <a:lnTo>
+                  <a:pt x="98421825" y="144789525"/>
+                </a:lnTo>
+                <a:cubicBezTo>
+                  <a:pt x="96621600" y="147351750"/>
+                  <a:pt x="93764100" y="148942425"/>
+                  <a:pt x="90649425" y="149142450"/>
+                </a:cubicBezTo>
+                <a:cubicBezTo>
+                  <a:pt x="87534750" y="149332950"/>
+                  <a:pt x="84496275" y="148104225"/>
+                  <a:pt x="82400775" y="145799175"/>
+                </a:cubicBezTo>
+                <a:lnTo>
+                  <a:pt x="56683275" y="117509925"/>
+                </a:lnTo>
+                <a:cubicBezTo>
+                  <a:pt x="52863750" y="113299875"/>
+                  <a:pt x="53178075" y="106803825"/>
+                  <a:pt x="57369075" y="102974775"/>
+                </a:cubicBezTo>
+                <a:cubicBezTo>
+                  <a:pt x="61579125" y="99155250"/>
+                  <a:pt x="68075175" y="99469575"/>
+                  <a:pt x="71904225" y="103660575"/>
+                </a:cubicBezTo>
+                <a:lnTo>
+                  <a:pt x="88982550" y="122453400"/>
+                </a:lnTo>
+                <a:lnTo>
+                  <a:pt x="130463925" y="63522225"/>
+                </a:lnTo>
+                <a:cubicBezTo>
+                  <a:pt x="133731000" y="58874025"/>
+                  <a:pt x="140150850" y="57750075"/>
+                  <a:pt x="144789525" y="61026675"/>
+                </a:cubicBezTo>
+                <a:close/>
+              </a:path>
+            </a:pathLst>
+          </a:custGeom>
+          <a:solidFill xmlns:a="http://schemas.openxmlformats.org/drawingml/2006/main">
+            <a:srgbClr val="000000"/>
+          </a:solidFill>
+        </p:spPr>
+      </p:sp>
+      <p:sp>
+        <p:nvSpPr>
+          <p:cNvPr id="9" name="Rounded-Rectangle-5-10">
+            <a:extLst xmlns:a="http://schemas.openxmlformats.org/drawingml/2006/main">
+              <a:ext uri="{FF2B5EF4-FFF2-40B4-BE49-F238E27FC236}">
+                <a16:creationId xmlns:a16="http://schemas.microsoft.com/office/drawing/2014/main" id="{4EE79339-07AC-4278-B951-0F897B8ECB8C}"/>
+              </a:ext>
+            </a:extLst>
+          </p:cNvPr>
+          <p:cNvSpPr>
+            <a:spLocks xmlns:a="http://schemas.openxmlformats.org/drawingml/2006/main" noGrp="1"/>
+          </p:cNvSpPr>
+          <p:nvPr/>
+        </p:nvSpPr>
+        <p:spPr>
+          <a:xfrm xmlns:a="http://schemas.openxmlformats.org/drawingml/2006/main">
+            <a:off x="388334" y="3365468"/>
+            <a:ext cx="3568732" cy="2628900"/>
           </a:xfrm>
           <a:prstGeom xmlns:a="http://schemas.openxmlformats.org/drawingml/2006/main" prst="roundRect">
             <a:avLst>
-              <a:gd name="adj" fmla="val 2135"/>
+              <a:gd name="adj" fmla="val 2899"/>
             </a:avLst>
           </a:prstGeom>
           <a:solidFill xmlns:a="http://schemas.openxmlformats.org/drawingml/2006/main">
@@ -2037,22 +2327,22 @@
       </p:sp>
       <p:sp>
         <p:nvSpPr>
-          <p:cNvPr id="12" name="Content-Placeholder-8-13">
-            <a:extLst xmlns:a="http://schemas.openxmlformats.org/drawingml/2006/main">
-              <a:ext uri="{FF2B5EF4-FFF2-40B4-BE49-F238E27FC236}">
-                <a16:creationId xmlns:a16="http://schemas.microsoft.com/office/drawing/2014/main" id="{2A3873F7-2EC6-43E8-ADC5-0F6E960F9D19}"/>
-              </a:ext>
-            </a:extLst>
-          </p:cNvPr>
-          <p:cNvSpPr>
-            <a:spLocks xmlns:a="http://schemas.openxmlformats.org/drawingml/2006/main" noGrp="1"/>
-          </p:cNvSpPr>
-          <p:nvPr/>
-        </p:nvSpPr>
-        <p:spPr>
-          <a:xfrm xmlns:a="http://schemas.openxmlformats.org/drawingml/2006/main">
-            <a:off x="8547259" y="1806797"/>
-            <a:ext cx="2949321" cy="2566797"/>
+          <p:cNvPr id="10" name="Content-Placeholder-9-11">
+            <a:extLst xmlns:a="http://schemas.openxmlformats.org/drawingml/2006/main">
+              <a:ext uri="{FF2B5EF4-FFF2-40B4-BE49-F238E27FC236}">
+                <a16:creationId xmlns:a16="http://schemas.microsoft.com/office/drawing/2014/main" id="{C885B357-6091-4014-B2DF-06422E1C2259}"/>
+              </a:ext>
+            </a:extLst>
+          </p:cNvPr>
+          <p:cNvSpPr>
+            <a:spLocks xmlns:a="http://schemas.openxmlformats.org/drawingml/2006/main" noGrp="1"/>
+          </p:cNvSpPr>
+          <p:nvPr/>
+        </p:nvSpPr>
+        <p:spPr>
+          <a:xfrm xmlns:a="http://schemas.openxmlformats.org/drawingml/2006/main">
+            <a:off x="701135" y="4146137"/>
+            <a:ext cx="2949321" cy="1432846"/>
           </a:xfrm>
           <a:prstGeom xmlns:a="http://schemas.openxmlformats.org/drawingml/2006/main" prst="rect">
             <a:avLst/>
@@ -2065,7 +2355,8 @@
           <a:lstStyle xmlns:a="http://schemas.openxmlformats.org/drawingml/2006/main"/>
           <a:p xmlns:a="http://schemas.openxmlformats.org/drawingml/2006/main">
             <a:pPr algn="l">
-              <a:defRPr sz="1600">
+              <a:buNone/>
+              <a:defRPr sz="2400">
                 <a:solidFill>
                   <a:srgbClr val="000000"/>
                 </a:solidFill>
@@ -2083,12 +2374,13 @@
                 <a:ea typeface="Helvetica Neue"/>
                 <a:cs typeface="Helvetica Neue"/>
               </a:rPr>
-              <a:t>Avoidable distortion</a:t>
+              <a:t>Package the judgment</a:t>
             </a:r>
           </a:p>
           <a:p xmlns:a="http://schemas.openxmlformats.org/drawingml/2006/main">
             <a:pPr algn="l">
-              <a:defRPr sz="1600">
+              <a:buNone/>
+              <a:defRPr sz="2400">
                 <a:solidFill>
                   <a:srgbClr val="000000"/>
                 </a:solidFill>
@@ -2106,42 +2398,167 @@
                 <a:ea typeface="Helvetica Neue"/>
                 <a:cs typeface="Helvetica Neue"/>
               </a:rPr>
-              <a:t>Capability can become propensity; a benchmark can become real-world harm; a demo can become a misleading proxy.</a:t>
+              <a:t>Workflows, principles, references, and templates travel together.</a:t>
             </a:r>
           </a:p>
         </p:txBody>
       </p:sp>
       <p:sp>
         <p:nvSpPr>
-          <p:cNvPr id="13" name="Text-Placeholder-16-14">
-            <a:extLst xmlns:a="http://schemas.openxmlformats.org/drawingml/2006/main">
-              <a:ext uri="{FF2B5EF4-FFF2-40B4-BE49-F238E27FC236}">
-                <a16:creationId xmlns:a16="http://schemas.microsoft.com/office/drawing/2014/main" id="{1EE8B753-8B40-4B31-9C35-89674825810F}"/>
-              </a:ext>
-            </a:extLst>
-          </p:cNvPr>
-          <p:cNvSpPr>
-            <a:spLocks xmlns:a="http://schemas.openxmlformats.org/drawingml/2006/main" noGrp="1"/>
-          </p:cNvSpPr>
-          <p:nvPr/>
-        </p:nvSpPr>
-        <p:spPr>
-          <a:xfrm xmlns:a="http://schemas.openxmlformats.org/drawingml/2006/main">
-            <a:off x="4251770" y="5602414"/>
-            <a:ext cx="2595944" cy="391954"/>
+          <p:cNvPr id="11" name="Google-Shape-340-p61-12">
+            <a:extLst xmlns:a="http://schemas.openxmlformats.org/drawingml/2006/main">
+              <a:ext uri="{FF2B5EF4-FFF2-40B4-BE49-F238E27FC236}">
+                <a16:creationId xmlns:a16="http://schemas.microsoft.com/office/drawing/2014/main" id="{875F1972-37AC-47DC-8D1F-C0FB8C87A7AC}"/>
+              </a:ext>
+            </a:extLst>
+          </p:cNvPr>
+          <p:cNvSpPr>
+            <a:spLocks xmlns:a="http://schemas.openxmlformats.org/drawingml/2006/main" noGrp="1"/>
+          </p:cNvSpPr>
+          <p:nvPr/>
+        </p:nvSpPr>
+        <p:spPr>
+          <a:xfrm xmlns:a="http://schemas.openxmlformats.org/drawingml/2006/main">
+            <a:off x="707041" y="3694081"/>
+            <a:ext cx="233839" cy="233744"/>
+          </a:xfrm>
+          <a:custGeom xmlns:a="http://schemas.openxmlformats.org/drawingml/2006/main">
+            <a:pathLst>
+              <a:path w="205740000" h="205740000">
+                <a:moveTo>
+                  <a:pt x="102870000" y="20574000"/>
+                </a:moveTo>
+                <a:cubicBezTo>
+                  <a:pt x="57426225" y="20574000"/>
+                  <a:pt x="20574000" y="57426225"/>
+                  <a:pt x="20574000" y="102870000"/>
+                </a:cubicBezTo>
+                <a:cubicBezTo>
+                  <a:pt x="20574000" y="148313775"/>
+                  <a:pt x="57426225" y="185166000"/>
+                  <a:pt x="102870000" y="185166000"/>
+                </a:cubicBezTo>
+                <a:cubicBezTo>
+                  <a:pt x="148313775" y="185166000"/>
+                  <a:pt x="185166000" y="148313775"/>
+                  <a:pt x="185166000" y="102870000"/>
+                </a:cubicBezTo>
+                <a:cubicBezTo>
+                  <a:pt x="185166000" y="57426225"/>
+                  <a:pt x="148313775" y="20574000"/>
+                  <a:pt x="102870000" y="20574000"/>
+                </a:cubicBezTo>
+                <a:close/>
+                <a:moveTo>
+                  <a:pt x="0" y="102870000"/>
+                </a:moveTo>
+                <a:cubicBezTo>
+                  <a:pt x="0" y="46053375"/>
+                  <a:pt x="46053375" y="0"/>
+                  <a:pt x="102870000" y="0"/>
+                </a:cubicBezTo>
+                <a:cubicBezTo>
+                  <a:pt x="159686625" y="0"/>
+                  <a:pt x="205740000" y="46053375"/>
+                  <a:pt x="205740000" y="102870000"/>
+                </a:cubicBezTo>
+                <a:cubicBezTo>
+                  <a:pt x="205740000" y="159686625"/>
+                  <a:pt x="159686625" y="205740000"/>
+                  <a:pt x="102870000" y="205740000"/>
+                </a:cubicBezTo>
+                <a:cubicBezTo>
+                  <a:pt x="46053375" y="205740000"/>
+                  <a:pt x="0" y="159686625"/>
+                  <a:pt x="0" y="102870000"/>
+                </a:cubicBezTo>
+                <a:close/>
+                <a:moveTo>
+                  <a:pt x="144789525" y="61026675"/>
+                </a:moveTo>
+                <a:cubicBezTo>
+                  <a:pt x="149437725" y="64293750"/>
+                  <a:pt x="150561675" y="70713600"/>
+                  <a:pt x="147285075" y="75352275"/>
+                </a:cubicBezTo>
+                <a:lnTo>
+                  <a:pt x="98421825" y="144789525"/>
+                </a:lnTo>
+                <a:cubicBezTo>
+                  <a:pt x="96621600" y="147351750"/>
+                  <a:pt x="93764100" y="148942425"/>
+                  <a:pt x="90649425" y="149142450"/>
+                </a:cubicBezTo>
+                <a:cubicBezTo>
+                  <a:pt x="87534750" y="149332950"/>
+                  <a:pt x="84496275" y="148104225"/>
+                  <a:pt x="82400775" y="145799175"/>
+                </a:cubicBezTo>
+                <a:lnTo>
+                  <a:pt x="56683275" y="117509925"/>
+                </a:lnTo>
+                <a:cubicBezTo>
+                  <a:pt x="52863750" y="113299875"/>
+                  <a:pt x="53178075" y="106803825"/>
+                  <a:pt x="57369075" y="102974775"/>
+                </a:cubicBezTo>
+                <a:cubicBezTo>
+                  <a:pt x="61579125" y="99155250"/>
+                  <a:pt x="68075175" y="99469575"/>
+                  <a:pt x="71904225" y="103660575"/>
+                </a:cubicBezTo>
+                <a:lnTo>
+                  <a:pt x="88982550" y="122453400"/>
+                </a:lnTo>
+                <a:lnTo>
+                  <a:pt x="130463925" y="63522225"/>
+                </a:lnTo>
+                <a:cubicBezTo>
+                  <a:pt x="133731000" y="58874025"/>
+                  <a:pt x="140150850" y="57750075"/>
+                  <a:pt x="144789525" y="61026675"/>
+                </a:cubicBezTo>
+                <a:close/>
+              </a:path>
+            </a:pathLst>
+          </a:custGeom>
+          <a:solidFill xmlns:a="http://schemas.openxmlformats.org/drawingml/2006/main">
+            <a:srgbClr val="000000"/>
+          </a:solidFill>
+        </p:spPr>
+      </p:sp>
+      <p:sp>
+        <p:nvSpPr>
+          <p:cNvPr id="12" name="Content-Placeholder-15-13">
+            <a:extLst xmlns:a="http://schemas.openxmlformats.org/drawingml/2006/main">
+              <a:ext uri="{FF2B5EF4-FFF2-40B4-BE49-F238E27FC236}">
+                <a16:creationId xmlns:a16="http://schemas.microsoft.com/office/drawing/2014/main" id="{464DDC0B-A0A7-44B7-B249-132D2189E40D}"/>
+              </a:ext>
+            </a:extLst>
+          </p:cNvPr>
+          <p:cNvSpPr>
+            <a:spLocks xmlns:a="http://schemas.openxmlformats.org/drawingml/2006/main" noGrp="1"/>
+          </p:cNvSpPr>
+          <p:nvPr/>
+        </p:nvSpPr>
+        <p:spPr>
+          <a:xfrm xmlns:a="http://schemas.openxmlformats.org/drawingml/2006/main">
+            <a:off x="393668" y="1450562"/>
+            <a:ext cx="11404568" cy="1629251"/>
           </a:xfrm>
           <a:prstGeom xmlns:a="http://schemas.openxmlformats.org/drawingml/2006/main" prst="rect">
             <a:avLst/>
           </a:prstGeom>
         </p:spPr>
         <p:txBody>
-          <a:bodyPr xmlns:a="http://schemas.openxmlformats.org/drawingml/2006/main" lIns="91440" tIns="45720" rIns="91440" bIns="45720">
+          <a:bodyPr xmlns:a="http://schemas.openxmlformats.org/drawingml/2006/main" lIns="0" tIns="0" rIns="0" bIns="0">
             <a:noAutofit/>
           </a:bodyPr>
           <a:lstStyle xmlns:a="http://schemas.openxmlformats.org/drawingml/2006/main"/>
           <a:p xmlns:a="http://schemas.openxmlformats.org/drawingml/2006/main">
             <a:pPr algn="l">
-              <a:defRPr sz="2400">
+              <a:buNone/>
+              <a:defRPr sz="1600">
                 <a:solidFill>
                   <a:srgbClr val="000000"/>
                 </a:solidFill>
@@ -2159,42 +2576,13 @@
                 <a:ea typeface="Helvetica Neue"/>
                 <a:cs typeface="Helvetica Neue"/>
               </a:rPr>
-              <a:t>translation</a:t>
+              <a:t>Bring your own harness</a:t>
             </a:r>
           </a:p>
-        </p:txBody>
-      </p:sp>
-      <p:sp>
-        <p:nvSpPr>
-          <p:cNvPr id="14" name="Text-Placeholder-16-15">
-            <a:extLst xmlns:a="http://schemas.openxmlformats.org/drawingml/2006/main">
-              <a:ext uri="{FF2B5EF4-FFF2-40B4-BE49-F238E27FC236}">
-                <a16:creationId xmlns:a16="http://schemas.microsoft.com/office/drawing/2014/main" id="{D61E5644-9739-4549-86C4-C7A8A15F1831}"/>
-              </a:ext>
-            </a:extLst>
-          </p:cNvPr>
-          <p:cNvSpPr>
-            <a:spLocks xmlns:a="http://schemas.openxmlformats.org/drawingml/2006/main" noGrp="1"/>
-          </p:cNvSpPr>
-          <p:nvPr/>
-        </p:nvSpPr>
-        <p:spPr>
-          <a:xfrm xmlns:a="http://schemas.openxmlformats.org/drawingml/2006/main">
-            <a:off x="390906" y="5602414"/>
-            <a:ext cx="2595944" cy="391954"/>
-          </a:xfrm>
-          <a:prstGeom xmlns:a="http://schemas.openxmlformats.org/drawingml/2006/main" prst="rect">
-            <a:avLst/>
-          </a:prstGeom>
-        </p:spPr>
-        <p:txBody>
-          <a:bodyPr xmlns:a="http://schemas.openxmlformats.org/drawingml/2006/main" lIns="91440" tIns="45720" rIns="91440" bIns="45720">
-            <a:noAutofit/>
-          </a:bodyPr>
-          <a:lstStyle xmlns:a="http://schemas.openxmlformats.org/drawingml/2006/main"/>
           <a:p xmlns:a="http://schemas.openxmlformats.org/drawingml/2006/main">
             <a:pPr algn="l">
-              <a:defRPr sz="2400">
+              <a:buNone/>
+              <a:defRPr sz="1600">
                 <a:solidFill>
                   <a:srgbClr val="000000"/>
                 </a:solidFill>
@@ -2212,42 +2600,13 @@
                 <a:ea typeface="Helvetica Neue"/>
                 <a:cs typeface="Helvetica Neue"/>
               </a:rPr>
-              <a:t>source</a:t>
+              <a:t>Use the AI or agent harness you already trust.</a:t>
             </a:r>
           </a:p>
-        </p:txBody>
-      </p:sp>
-      <p:sp>
-        <p:nvSpPr>
-          <p:cNvPr id="15" name="Text-Placeholder-16-16">
-            <a:extLst xmlns:a="http://schemas.openxmlformats.org/drawingml/2006/main">
-              <a:ext uri="{FF2B5EF4-FFF2-40B4-BE49-F238E27FC236}">
-                <a16:creationId xmlns:a16="http://schemas.microsoft.com/office/drawing/2014/main" id="{91EEAF8C-14B7-4658-A793-E7C96149F74A}"/>
-              </a:ext>
-            </a:extLst>
-          </p:cNvPr>
-          <p:cNvSpPr>
-            <a:spLocks xmlns:a="http://schemas.openxmlformats.org/drawingml/2006/main" noGrp="1"/>
-          </p:cNvSpPr>
-          <p:nvPr/>
-        </p:nvSpPr>
-        <p:spPr>
-          <a:xfrm xmlns:a="http://schemas.openxmlformats.org/drawingml/2006/main">
-            <a:off x="8225409" y="5602414"/>
-            <a:ext cx="2595944" cy="391954"/>
-          </a:xfrm>
-          <a:prstGeom xmlns:a="http://schemas.openxmlformats.org/drawingml/2006/main" prst="rect">
-            <a:avLst/>
-          </a:prstGeom>
-        </p:spPr>
-        <p:txBody>
-          <a:bodyPr xmlns:a="http://schemas.openxmlformats.org/drawingml/2006/main" lIns="91440" tIns="45720" rIns="91440" bIns="45720">
-            <a:noAutofit/>
-          </a:bodyPr>
-          <a:lstStyle xmlns:a="http://schemas.openxmlformats.org/drawingml/2006/main"/>
           <a:p xmlns:a="http://schemas.openxmlformats.org/drawingml/2006/main">
             <a:pPr algn="l">
-              <a:defRPr sz="2400">
+              <a:buNone/>
+              <a:defRPr sz="1600">
                 <a:solidFill>
                   <a:srgbClr val="000000"/>
                 </a:solidFill>
@@ -2265,7 +2624,7 @@
                 <a:ea typeface="Helvetica Neue"/>
                 <a:cs typeface="Helvetica Neue"/>
               </a:rPr>
-              <a:t>reader belief</a:t>
+              <a:t>The package brings a repeatable communication workflow with it.</a:t>
             </a:r>
           </a:p>
         </p:txBody>
@@ -2273,7 +2632,7 @@
     </p:spTree>
     <p:extLst>
       <p:ext uri="{BB962C8B-B14F-4D97-AF65-F5344CB8AC3E}">
-        <p14:creationId xmlns:p14="http://schemas.microsoft.com/office/powerpoint/2010/main" val="937284152"/>
+        <p14:creationId xmlns:p14="http://schemas.microsoft.com/office/powerpoint/2010/main" val="1748398193"/>
       </p:ext>
     </p:extLst>
   </p:cSld>
@@ -2297,7 +2656,7 @@
           <p:cNvPr id="16" name="Slide-Number-Placeholder-3-2">
             <a:extLst xmlns:a="http://schemas.openxmlformats.org/drawingml/2006/main">
               <a:ext uri="{FF2B5EF4-FFF2-40B4-BE49-F238E27FC236}">
-                <a16:creationId xmlns:a16="http://schemas.microsoft.com/office/drawing/2014/main" id="{957F9DEB-4869-4DDD-9659-A34920483883}"/>
+                <a16:creationId xmlns:a16="http://schemas.microsoft.com/office/drawing/2014/main" id="{7834BBE0-4342-4624-A9A4-B05A17D86824}"/>
               </a:ext>
             </a:extLst>
           </p:cNvPr>
@@ -2320,6 +2679,7 @@
           <a:lstStyle xmlns:a="http://schemas.openxmlformats.org/drawingml/2006/main"/>
           <a:p xmlns:a="http://schemas.openxmlformats.org/drawingml/2006/main">
             <a:pPr algn="r">
+              <a:buNone/>
               <a:defRPr sz="1000">
                 <a:solidFill>
                   <a:srgbClr val="000000"/>
@@ -2348,7 +2708,7 @@
           <p:cNvPr id="2" name="Title-10-3">
             <a:extLst xmlns:a="http://schemas.openxmlformats.org/drawingml/2006/main">
               <a:ext uri="{FF2B5EF4-FFF2-40B4-BE49-F238E27FC236}">
-                <a16:creationId xmlns:a16="http://schemas.microsoft.com/office/drawing/2014/main" id="{9A2007B1-AAF0-4BDA-BC13-F422D27E310F}"/>
+                <a16:creationId xmlns:a16="http://schemas.microsoft.com/office/drawing/2014/main" id="{FACDA37A-EF3E-4422-9112-67EDFF95FA75}"/>
               </a:ext>
             </a:extLst>
           </p:cNvPr>
@@ -2373,6 +2733,7 @@
           <a:lstStyle xmlns:a="http://schemas.openxmlformats.org/drawingml/2006/main"/>
           <a:p xmlns:a="http://schemas.openxmlformats.org/drawingml/2006/main">
             <a:pPr algn="l">
+              <a:buNone/>
               <a:defRPr sz="2900">
                 <a:solidFill>
                   <a:srgbClr val="000000"/>
@@ -2391,14 +2752,14 @@
                 <a:ea typeface="Helvetica Neue"/>
                 <a:cs typeface="Helvetica Neue"/>
               </a:rPr>
-              <a:t>A small workflow creates a practical quality-control layer.</a:t>
+              <a:t>The failure happens when evidence crosses audiences.</a:t>
             </a:r>
           </a:p>
         </p:txBody>
       </p:sp>
       <p:cxnSp>
         <p:nvCxnSpPr>
-          <p:cNvPr id="18" name="Google-Shape-2259-p159-4"/>
+          <p:cNvPr id="30" name="Google-Shape-2259-p159-4"/>
           <p:cNvCxnSpPr/>
           <p:nvPr/>
         </p:nvCxnSpPr>
@@ -2423,7 +2784,7 @@
           <p:cNvPr id="4" name="Google-Shape-2260-p159-5">
             <a:extLst xmlns:a="http://schemas.openxmlformats.org/drawingml/2006/main">
               <a:ext uri="{FF2B5EF4-FFF2-40B4-BE49-F238E27FC236}">
-                <a16:creationId xmlns:a16="http://schemas.microsoft.com/office/drawing/2014/main" id="{48D143A6-865F-4FFF-998E-AB4957625A93}"/>
+                <a16:creationId xmlns:a16="http://schemas.microsoft.com/office/drawing/2014/main" id="{297849BA-D069-4DDE-ABC8-FD0A09834252}"/>
               </a:ext>
             </a:extLst>
           </p:cNvPr>
@@ -2450,7 +2811,7 @@
           <p:cNvPr id="5" name="Google-Shape-2261-p159-6">
             <a:extLst xmlns:a="http://schemas.openxmlformats.org/drawingml/2006/main">
               <a:ext uri="{FF2B5EF4-FFF2-40B4-BE49-F238E27FC236}">
-                <a16:creationId xmlns:a16="http://schemas.microsoft.com/office/drawing/2014/main" id="{03E88ED6-68FB-4B37-A48C-F52BE53183CA}"/>
+                <a16:creationId xmlns:a16="http://schemas.microsoft.com/office/drawing/2014/main" id="{A0C2A718-05A0-4D9F-87AC-C01DA7E4FF58}"/>
               </a:ext>
             </a:extLst>
           </p:cNvPr>
@@ -2477,7 +2838,7 @@
           <p:cNvPr id="6" name="Google-Shape-2262-p159-7">
             <a:extLst xmlns:a="http://schemas.openxmlformats.org/drawingml/2006/main">
               <a:ext uri="{FF2B5EF4-FFF2-40B4-BE49-F238E27FC236}">
-                <a16:creationId xmlns:a16="http://schemas.microsoft.com/office/drawing/2014/main" id="{17679430-71BA-464D-9215-C5C60176C27D}"/>
+                <a16:creationId xmlns:a16="http://schemas.microsoft.com/office/drawing/2014/main" id="{06098E42-02D6-4FC3-9E25-B663D26F9EA6}"/>
               </a:ext>
             </a:extLst>
           </p:cNvPr>
@@ -2504,7 +2865,7 @@
           <p:cNvPr id="7" name="Rounded-Rectangle-19-8">
             <a:extLst xmlns:a="http://schemas.openxmlformats.org/drawingml/2006/main">
               <a:ext uri="{FF2B5EF4-FFF2-40B4-BE49-F238E27FC236}">
-                <a16:creationId xmlns:a16="http://schemas.microsoft.com/office/drawing/2014/main" id="{360AE73D-6B74-441B-80D3-6E7B7DCC1E0F}"/>
+                <a16:creationId xmlns:a16="http://schemas.microsoft.com/office/drawing/2014/main" id="{0C7B4E86-36A4-467A-98AA-BEEE34032F59}"/>
               </a:ext>
             </a:extLst>
           </p:cNvPr>
@@ -2533,7 +2894,7 @@
           <p:cNvPr id="8" name="Content-Placeholder-8-9">
             <a:extLst xmlns:a="http://schemas.openxmlformats.org/drawingml/2006/main">
               <a:ext uri="{FF2B5EF4-FFF2-40B4-BE49-F238E27FC236}">
-                <a16:creationId xmlns:a16="http://schemas.microsoft.com/office/drawing/2014/main" id="{0F0FB1CF-C967-4F77-9D53-2F9608395DEC}"/>
+                <a16:creationId xmlns:a16="http://schemas.microsoft.com/office/drawing/2014/main" id="{B58B1D95-AD43-4B96-B770-FC2E081A749A}"/>
               </a:ext>
             </a:extLst>
           </p:cNvPr>
@@ -2558,6 +2919,7 @@
           <a:lstStyle xmlns:a="http://schemas.openxmlformats.org/drawingml/2006/main"/>
           <a:p xmlns:a="http://schemas.openxmlformats.org/drawingml/2006/main">
             <a:pPr algn="l">
+              <a:buNone/>
               <a:defRPr sz="1600">
                 <a:solidFill>
                   <a:srgbClr val="000000"/>
@@ -2576,11 +2938,12 @@
                 <a:ea typeface="Helvetica Neue"/>
                 <a:cs typeface="Helvetica Neue"/>
               </a:rPr>
-              <a:t>1. Anchor claims</a:t>
+              <a:t>Technical result</a:t>
             </a:r>
           </a:p>
           <a:p xmlns:a="http://schemas.openxmlformats.org/drawingml/2006/main">
             <a:pPr algn="l">
+              <a:buNone/>
               <a:defRPr sz="1600">
                 <a:solidFill>
                   <a:srgbClr val="000000"/>
@@ -2599,7 +2962,7 @@
                 <a:ea typeface="Helvetica Neue"/>
                 <a:cs typeface="Helvetica Neue"/>
               </a:rPr>
-              <a:t>Build a compact ledger tied to primary sources, conditions, numbers, scope, and caveats.</a:t>
+              <a:t>A result is bounded by model, task, prompting, baseline, uncertainty, and caveats.</a:t>
             </a:r>
           </a:p>
         </p:txBody>
@@ -2609,7 +2972,7 @@
           <p:cNvPr id="9" name="Rounded-Rectangle-21-10">
             <a:extLst xmlns:a="http://schemas.openxmlformats.org/drawingml/2006/main">
               <a:ext uri="{FF2B5EF4-FFF2-40B4-BE49-F238E27FC236}">
-                <a16:creationId xmlns:a16="http://schemas.microsoft.com/office/drawing/2014/main" id="{52D5C2BA-481D-4865-9704-C6C5E1557E66}"/>
+                <a16:creationId xmlns:a16="http://schemas.microsoft.com/office/drawing/2014/main" id="{2EB580B6-5FDB-447D-ACF8-7626A4AD3E02}"/>
               </a:ext>
             </a:extLst>
           </p:cNvPr>
@@ -2638,7 +3001,7 @@
           <p:cNvPr id="10" name="Content-Placeholder-8-11">
             <a:extLst xmlns:a="http://schemas.openxmlformats.org/drawingml/2006/main">
               <a:ext uri="{FF2B5EF4-FFF2-40B4-BE49-F238E27FC236}">
-                <a16:creationId xmlns:a16="http://schemas.microsoft.com/office/drawing/2014/main" id="{565B7658-5617-4533-A844-62CA1AE077AA}"/>
+                <a16:creationId xmlns:a16="http://schemas.microsoft.com/office/drawing/2014/main" id="{5E6FA5E9-C83B-45E1-8D45-2E73FA2CB3EA}"/>
               </a:ext>
             </a:extLst>
           </p:cNvPr>
@@ -2663,6 +3026,7 @@
           <a:lstStyle xmlns:a="http://schemas.openxmlformats.org/drawingml/2006/main"/>
           <a:p xmlns:a="http://schemas.openxmlformats.org/drawingml/2006/main">
             <a:pPr algn="l">
+              <a:buNone/>
               <a:defRPr sz="1600">
                 <a:solidFill>
                   <a:srgbClr val="000000"/>
@@ -2681,11 +3045,12 @@
                 <a:ea typeface="Helvetica Neue"/>
                 <a:cs typeface="Helvetica Neue"/>
               </a:rPr>
-              <a:t>2. Adapt responsibly</a:t>
+              <a:t>Public artifact</a:t>
             </a:r>
           </a:p>
           <a:p xmlns:a="http://schemas.openxmlformats.org/drawingml/2006/main">
             <a:pPr algn="l">
+              <a:buNone/>
               <a:defRPr sz="1600">
                 <a:solidFill>
                   <a:srgbClr val="000000"/>
@@ -2704,7 +3069,7 @@
                 <a:ea typeface="Helvetica Neue"/>
                 <a:cs typeface="Helvetica Neue"/>
               </a:rPr>
-              <a:t>A researcher validates the main claims; the authoring skill fits them to one defined audience.</a:t>
+              <a:t>A release, post, visual, or demo must stay clear, useful, and faithful under compression.</a:t>
             </a:r>
           </a:p>
         </p:txBody>
@@ -2714,7 +3079,7 @@
           <p:cNvPr id="11" name="Rounded-Rectangle-23-12">
             <a:extLst xmlns:a="http://schemas.openxmlformats.org/drawingml/2006/main">
               <a:ext uri="{FF2B5EF4-FFF2-40B4-BE49-F238E27FC236}">
-                <a16:creationId xmlns:a16="http://schemas.microsoft.com/office/drawing/2014/main" id="{88B81F4D-191B-41F9-AB50-027FC5EE5BC6}"/>
+                <a16:creationId xmlns:a16="http://schemas.microsoft.com/office/drawing/2014/main" id="{9EA3B962-592C-4AFA-99DD-A4237AF7184B}"/>
               </a:ext>
             </a:extLst>
           </p:cNvPr>
@@ -2743,7 +3108,7 @@
           <p:cNvPr id="12" name="Content-Placeholder-8-13">
             <a:extLst xmlns:a="http://schemas.openxmlformats.org/drawingml/2006/main">
               <a:ext uri="{FF2B5EF4-FFF2-40B4-BE49-F238E27FC236}">
-                <a16:creationId xmlns:a16="http://schemas.microsoft.com/office/drawing/2014/main" id="{88BF9944-1B8C-4CD4-AAD1-7402D4F05A6D}"/>
+                <a16:creationId xmlns:a16="http://schemas.microsoft.com/office/drawing/2014/main" id="{2A3873F7-2EC6-43E8-ADC5-0F6E960F9D19}"/>
               </a:ext>
             </a:extLst>
           </p:cNvPr>
@@ -2768,6 +3133,7 @@
           <a:lstStyle xmlns:a="http://schemas.openxmlformats.org/drawingml/2006/main"/>
           <a:p xmlns:a="http://schemas.openxmlformats.org/drawingml/2006/main">
             <a:pPr algn="l">
+              <a:buNone/>
               <a:defRPr sz="1600">
                 <a:solidFill>
                   <a:srgbClr val="000000"/>
@@ -2786,11 +3152,12 @@
                 <a:ea typeface="Helvetica Neue"/>
                 <a:cs typeface="Helvetica Neue"/>
               </a:rPr>
-              <a:t>3. Audit before release</a:t>
+              <a:t>Avoidable distortion</a:t>
             </a:r>
           </a:p>
           <a:p xmlns:a="http://schemas.openxmlformats.org/drawingml/2006/main">
             <a:pPr algn="l">
+              <a:buNone/>
               <a:defRPr sz="1600">
                 <a:solidFill>
                   <a:srgbClr val="000000"/>
@@ -2809,7 +3176,7 @@
                 <a:ea typeface="Helvetica Neue"/>
                 <a:cs typeface="Helvetica Neue"/>
               </a:rPr>
-              <a:t>Check the finished artifact for fidelity, missing context, unsafe demos, rights, and accessibility.</a:t>
+              <a:t>Capability becomes propensity; a model-only score becomes misuse uplift or deployment evidence; a demo becomes a misleading proxy.</a:t>
             </a:r>
           </a:p>
         </p:txBody>
@@ -2819,7 +3186,7 @@
           <p:cNvPr id="13" name="Text-Placeholder-16-14">
             <a:extLst xmlns:a="http://schemas.openxmlformats.org/drawingml/2006/main">
               <a:ext uri="{FF2B5EF4-FFF2-40B4-BE49-F238E27FC236}">
-                <a16:creationId xmlns:a16="http://schemas.microsoft.com/office/drawing/2014/main" id="{16FA7573-F187-4C2E-AAE8-C3EA734AF506}"/>
+                <a16:creationId xmlns:a16="http://schemas.microsoft.com/office/drawing/2014/main" id="{1EE8B753-8B40-4B31-9C35-89674825810F}"/>
               </a:ext>
             </a:extLst>
           </p:cNvPr>
@@ -2844,6 +3211,7 @@
           <a:lstStyle xmlns:a="http://schemas.openxmlformats.org/drawingml/2006/main"/>
           <a:p xmlns:a="http://schemas.openxmlformats.org/drawingml/2006/main">
             <a:pPr algn="l">
+              <a:buNone/>
               <a:defRPr sz="2400">
                 <a:solidFill>
                   <a:srgbClr val="000000"/>
@@ -2862,7 +3230,7 @@
                 <a:ea typeface="Helvetica Neue"/>
                 <a:cs typeface="Helvetica Neue"/>
               </a:rPr>
-              <a:t>communication</a:t>
+              <a:t>translation</a:t>
             </a:r>
           </a:p>
         </p:txBody>
@@ -2872,7 +3240,7 @@
           <p:cNvPr id="14" name="Text-Placeholder-16-15">
             <a:extLst xmlns:a="http://schemas.openxmlformats.org/drawingml/2006/main">
               <a:ext uri="{FF2B5EF4-FFF2-40B4-BE49-F238E27FC236}">
-                <a16:creationId xmlns:a16="http://schemas.microsoft.com/office/drawing/2014/main" id="{E7824956-157C-42E0-8820-4AFC07BB7C06}"/>
+                <a16:creationId xmlns:a16="http://schemas.microsoft.com/office/drawing/2014/main" id="{D61E5644-9739-4549-86C4-C7A8A15F1831}"/>
               </a:ext>
             </a:extLst>
           </p:cNvPr>
@@ -2897,6 +3265,7 @@
           <a:lstStyle xmlns:a="http://schemas.openxmlformats.org/drawingml/2006/main"/>
           <a:p xmlns:a="http://schemas.openxmlformats.org/drawingml/2006/main">
             <a:pPr algn="l">
+              <a:buNone/>
               <a:defRPr sz="2400">
                 <a:solidFill>
                   <a:srgbClr val="000000"/>
@@ -2915,7 +3284,7 @@
                 <a:ea typeface="Helvetica Neue"/>
                 <a:cs typeface="Helvetica Neue"/>
               </a:rPr>
-              <a:t>evidence</a:t>
+              <a:t>source</a:t>
             </a:r>
           </a:p>
         </p:txBody>
@@ -2925,7 +3294,7 @@
           <p:cNvPr id="15" name="Text-Placeholder-16-16">
             <a:extLst xmlns:a="http://schemas.openxmlformats.org/drawingml/2006/main">
               <a:ext uri="{FF2B5EF4-FFF2-40B4-BE49-F238E27FC236}">
-                <a16:creationId xmlns:a16="http://schemas.microsoft.com/office/drawing/2014/main" id="{2865F808-287C-49A0-9833-2E6B7D30C1A1}"/>
+                <a16:creationId xmlns:a16="http://schemas.microsoft.com/office/drawing/2014/main" id="{91EEAF8C-14B7-4658-A793-E7C96149F74A}"/>
               </a:ext>
             </a:extLst>
           </p:cNvPr>
@@ -2950,6 +3319,7 @@
           <a:lstStyle xmlns:a="http://schemas.openxmlformats.org/drawingml/2006/main"/>
           <a:p xmlns:a="http://schemas.openxmlformats.org/drawingml/2006/main">
             <a:pPr algn="l">
+              <a:buNone/>
               <a:defRPr sz="2400">
                 <a:solidFill>
                   <a:srgbClr val="000000"/>
@@ -2968,7 +3338,7 @@
                 <a:ea typeface="Helvetica Neue"/>
                 <a:cs typeface="Helvetica Neue"/>
               </a:rPr>
-              <a:t>review</a:t>
+              <a:t>reader belief</a:t>
             </a:r>
           </a:p>
         </p:txBody>
@@ -2976,7 +3346,7 @@
     </p:spTree>
     <p:extLst>
       <p:ext uri="{BB962C8B-B14F-4D97-AF65-F5344CB8AC3E}">
-        <p14:creationId xmlns:p14="http://schemas.microsoft.com/office/powerpoint/2010/main" val="1727701032"/>
+        <p14:creationId xmlns:p14="http://schemas.microsoft.com/office/powerpoint/2010/main" val="937284152"/>
       </p:ext>
     </p:extLst>
   </p:cSld>
@@ -2997,10 +3367,10 @@
       </p:grpSpPr>
       <p:sp>
         <p:nvSpPr>
-          <p:cNvPr id="13" name="Google-Shape-532-p58-2">
-            <a:extLst xmlns:a="http://schemas.openxmlformats.org/drawingml/2006/main">
-              <a:ext uri="{FF2B5EF4-FFF2-40B4-BE49-F238E27FC236}">
-                <a16:creationId xmlns:a16="http://schemas.microsoft.com/office/drawing/2014/main" id="{84ABE108-BF7A-491C-AB2A-CDF3712C1E0F}"/>
+          <p:cNvPr id="16" name="Slide-Number-Placeholder-3-2">
+            <a:extLst xmlns:a="http://schemas.openxmlformats.org/drawingml/2006/main">
+              <a:ext uri="{FF2B5EF4-FFF2-40B4-BE49-F238E27FC236}">
+                <a16:creationId xmlns:a16="http://schemas.microsoft.com/office/drawing/2014/main" id="{957F9DEB-4869-4DDD-9659-A34920483883}"/>
               </a:ext>
             </a:extLst>
           </p:cNvPr>
@@ -3019,12 +3389,11 @@
           </a:prstGeom>
         </p:spPr>
         <p:txBody>
-          <a:bodyPr xmlns:a="http://schemas.openxmlformats.org/drawingml/2006/main" wrap="square" lIns="0" tIns="0" rIns="0" bIns="0" anchor="b">
-            <a:noAutofit/>
-          </a:bodyPr>
+          <a:bodyPr xmlns:a="http://schemas.openxmlformats.org/drawingml/2006/main" lIns="0" tIns="0" rIns="0" bIns="0" anchor="b"/>
           <a:lstStyle xmlns:a="http://schemas.openxmlformats.org/drawingml/2006/main"/>
           <a:p xmlns:a="http://schemas.openxmlformats.org/drawingml/2006/main">
             <a:pPr algn="r">
+              <a:buNone/>
               <a:defRPr sz="1000">
                 <a:solidFill>
                   <a:srgbClr val="000000"/>
@@ -3050,34 +3419,35 @@
       </p:sp>
       <p:sp>
         <p:nvSpPr>
-          <p:cNvPr id="2" name="Google-Shape-533-p58-3">
-            <a:extLst xmlns:a="http://schemas.openxmlformats.org/drawingml/2006/main">
-              <a:ext uri="{FF2B5EF4-FFF2-40B4-BE49-F238E27FC236}">
-                <a16:creationId xmlns:a16="http://schemas.microsoft.com/office/drawing/2014/main" id="{A99E2CF9-8D2C-459A-9D0A-DB21089B6201}"/>
-              </a:ext>
-            </a:extLst>
-          </p:cNvPr>
-          <p:cNvSpPr>
-            <a:spLocks xmlns:a="http://schemas.openxmlformats.org/drawingml/2006/main" noGrp="1"/>
-          </p:cNvSpPr>
-          <p:nvPr/>
-        </p:nvSpPr>
-        <p:spPr>
-          <a:xfrm xmlns:a="http://schemas.openxmlformats.org/drawingml/2006/main">
-            <a:off x="393668" y="344519"/>
-            <a:ext cx="11404568" cy="1283018"/>
+          <p:cNvPr id="2" name="Title-10-3">
+            <a:extLst xmlns:a="http://schemas.openxmlformats.org/drawingml/2006/main">
+              <a:ext uri="{FF2B5EF4-FFF2-40B4-BE49-F238E27FC236}">
+                <a16:creationId xmlns:a16="http://schemas.microsoft.com/office/drawing/2014/main" id="{9A2007B1-AAF0-4BDA-BC13-F422D27E310F}"/>
+              </a:ext>
+            </a:extLst>
+          </p:cNvPr>
+          <p:cNvSpPr>
+            <a:spLocks xmlns:a="http://schemas.openxmlformats.org/drawingml/2006/main" noGrp="1"/>
+          </p:cNvSpPr>
+          <p:nvPr/>
+        </p:nvSpPr>
+        <p:spPr>
+          <a:xfrm xmlns:a="http://schemas.openxmlformats.org/drawingml/2006/main">
+            <a:off x="393668" y="344043"/>
+            <a:ext cx="11404568" cy="1047464"/>
           </a:xfrm>
           <a:prstGeom xmlns:a="http://schemas.openxmlformats.org/drawingml/2006/main" prst="rect">
             <a:avLst/>
           </a:prstGeom>
         </p:spPr>
         <p:txBody>
-          <a:bodyPr xmlns:a="http://schemas.openxmlformats.org/drawingml/2006/main" wrap="square" lIns="0" tIns="0" rIns="0" bIns="0" anchor="t">
-            <a:noAutofit/>
+          <a:bodyPr xmlns:a="http://schemas.openxmlformats.org/drawingml/2006/main" lIns="0" tIns="0" rIns="0" bIns="0" anchor="t">
+            <a:normAutofit fontScale="100000"/>
           </a:bodyPr>
           <a:lstStyle xmlns:a="http://schemas.openxmlformats.org/drawingml/2006/main"/>
           <a:p xmlns:a="http://schemas.openxmlformats.org/drawingml/2006/main">
             <a:pPr algn="l">
+              <a:buNone/>
               <a:defRPr sz="2900">
                 <a:solidFill>
                   <a:srgbClr val="000000"/>
@@ -3096,33 +3466,136 @@
                 <a:ea typeface="Helvetica Neue"/>
                 <a:cs typeface="Helvetica Neue"/>
               </a:rPr>
-              <a:t>Three skills cover the channels where nuance most often disappears.</a:t>
+              <a:t>A useful draft comes early; publication checks stay strict.</a:t>
             </a:r>
           </a:p>
         </p:txBody>
       </p:sp>
-      <p:sp>
-        <p:nvSpPr>
-          <p:cNvPr id="3" name="Rounded-Rectangle-9-4">
-            <a:extLst xmlns:a="http://schemas.openxmlformats.org/drawingml/2006/main">
-              <a:ext uri="{FF2B5EF4-FFF2-40B4-BE49-F238E27FC236}">
-                <a16:creationId xmlns:a16="http://schemas.microsoft.com/office/drawing/2014/main" id="{77AE61A2-45DC-43BB-8675-E62A1552551F}"/>
-              </a:ext>
-            </a:extLst>
-          </p:cNvPr>
-          <p:cNvSpPr>
-            <a:spLocks xmlns:a="http://schemas.openxmlformats.org/drawingml/2006/main" noGrp="1"/>
-          </p:cNvSpPr>
-          <p:nvPr/>
-        </p:nvSpPr>
-        <p:spPr>
-          <a:xfrm xmlns:a="http://schemas.openxmlformats.org/drawingml/2006/main">
-            <a:off x="4308920" y="3365468"/>
-            <a:ext cx="3568732" cy="2628900"/>
+      <p:cxnSp>
+        <p:nvCxnSpPr>
+          <p:cNvPr id="30" name="Google-Shape-2259-p159-4"/>
+          <p:cNvCxnSpPr/>
+          <p:nvPr/>
+        </p:nvCxnSpPr>
+        <p:spPr>
+          <a:xfrm xmlns:a="http://schemas.openxmlformats.org/drawingml/2006/main">
+            <a:off x="337757" y="5341620"/>
+            <a:ext cx="12245435" cy="286"/>
+          </a:xfrm>
+          <a:prstGeom xmlns:a="http://schemas.openxmlformats.org/drawingml/2006/main" prst="straightConnector1">
+            <a:avLst/>
+          </a:prstGeom>
+          <a:ln xmlns:a="http://schemas.openxmlformats.org/drawingml/2006/main" w="9525">
+            <a:solidFill>
+              <a:srgbClr val="000000"/>
+            </a:solidFill>
+            <a:prstDash val="solid"/>
+          </a:ln>
+        </p:spPr>
+      </p:cxnSp>
+      <p:sp>
+        <p:nvSpPr>
+          <p:cNvPr id="4" name="Google-Shape-2260-p159-5">
+            <a:extLst xmlns:a="http://schemas.openxmlformats.org/drawingml/2006/main">
+              <a:ext uri="{FF2B5EF4-FFF2-40B4-BE49-F238E27FC236}">
+                <a16:creationId xmlns:a16="http://schemas.microsoft.com/office/drawing/2014/main" id="{48D143A6-865F-4FFF-998E-AB4957625A93}"/>
+              </a:ext>
+            </a:extLst>
+          </p:cNvPr>
+          <p:cNvSpPr>
+            <a:spLocks xmlns:a="http://schemas.openxmlformats.org/drawingml/2006/main" noGrp="1"/>
+          </p:cNvSpPr>
+          <p:nvPr/>
+        </p:nvSpPr>
+        <p:spPr>
+          <a:xfrm xmlns:a="http://schemas.openxmlformats.org/drawingml/2006/main">
+            <a:off x="337757" y="5288089"/>
+            <a:ext cx="107061" cy="107061"/>
+          </a:xfrm>
+          <a:prstGeom xmlns:a="http://schemas.openxmlformats.org/drawingml/2006/main" prst="ellipse">
+            <a:avLst/>
+          </a:prstGeom>
+          <a:solidFill xmlns:a="http://schemas.openxmlformats.org/drawingml/2006/main">
+            <a:srgbClr val="000000"/>
+          </a:solidFill>
+        </p:spPr>
+      </p:sp>
+      <p:sp>
+        <p:nvSpPr>
+          <p:cNvPr id="5" name="Google-Shape-2261-p159-6">
+            <a:extLst xmlns:a="http://schemas.openxmlformats.org/drawingml/2006/main">
+              <a:ext uri="{FF2B5EF4-FFF2-40B4-BE49-F238E27FC236}">
+                <a16:creationId xmlns:a16="http://schemas.microsoft.com/office/drawing/2014/main" id="{03E88ED6-68FB-4B37-A48C-F52BE53183CA}"/>
+              </a:ext>
+            </a:extLst>
+          </p:cNvPr>
+          <p:cNvSpPr>
+            <a:spLocks xmlns:a="http://schemas.openxmlformats.org/drawingml/2006/main" noGrp="1"/>
+          </p:cNvSpPr>
+          <p:nvPr/>
+        </p:nvSpPr>
+        <p:spPr>
+          <a:xfrm xmlns:a="http://schemas.openxmlformats.org/drawingml/2006/main">
+            <a:off x="4251770" y="5288089"/>
+            <a:ext cx="107061" cy="107061"/>
+          </a:xfrm>
+          <a:prstGeom xmlns:a="http://schemas.openxmlformats.org/drawingml/2006/main" prst="ellipse">
+            <a:avLst/>
+          </a:prstGeom>
+          <a:solidFill xmlns:a="http://schemas.openxmlformats.org/drawingml/2006/main">
+            <a:srgbClr val="000000"/>
+          </a:solidFill>
+        </p:spPr>
+      </p:sp>
+      <p:sp>
+        <p:nvSpPr>
+          <p:cNvPr id="6" name="Google-Shape-2262-p159-7">
+            <a:extLst xmlns:a="http://schemas.openxmlformats.org/drawingml/2006/main">
+              <a:ext uri="{FF2B5EF4-FFF2-40B4-BE49-F238E27FC236}">
+                <a16:creationId xmlns:a16="http://schemas.microsoft.com/office/drawing/2014/main" id="{17679430-71BA-464D-9215-C5C60176C27D}"/>
+              </a:ext>
+            </a:extLst>
+          </p:cNvPr>
+          <p:cNvSpPr>
+            <a:spLocks xmlns:a="http://schemas.openxmlformats.org/drawingml/2006/main" noGrp="1"/>
+          </p:cNvSpPr>
+          <p:nvPr/>
+        </p:nvSpPr>
+        <p:spPr>
+          <a:xfrm xmlns:a="http://schemas.openxmlformats.org/drawingml/2006/main">
+            <a:off x="8176070" y="5288089"/>
+            <a:ext cx="107061" cy="107061"/>
+          </a:xfrm>
+          <a:prstGeom xmlns:a="http://schemas.openxmlformats.org/drawingml/2006/main" prst="ellipse">
+            <a:avLst/>
+          </a:prstGeom>
+          <a:solidFill xmlns:a="http://schemas.openxmlformats.org/drawingml/2006/main">
+            <a:srgbClr val="000000"/>
+          </a:solidFill>
+        </p:spPr>
+      </p:sp>
+      <p:sp>
+        <p:nvSpPr>
+          <p:cNvPr id="7" name="Rounded-Rectangle-19-8">
+            <a:extLst xmlns:a="http://schemas.openxmlformats.org/drawingml/2006/main">
+              <a:ext uri="{FF2B5EF4-FFF2-40B4-BE49-F238E27FC236}">
+                <a16:creationId xmlns:a16="http://schemas.microsoft.com/office/drawing/2014/main" id="{360AE73D-6B74-441B-80D3-6E7B7DCC1E0F}"/>
+              </a:ext>
+            </a:extLst>
+          </p:cNvPr>
+          <p:cNvSpPr>
+            <a:spLocks xmlns:a="http://schemas.openxmlformats.org/drawingml/2006/main" noGrp="1"/>
+          </p:cNvSpPr>
+          <p:nvPr/>
+        </p:nvSpPr>
+        <p:spPr>
+          <a:xfrm xmlns:a="http://schemas.openxmlformats.org/drawingml/2006/main">
+            <a:off x="393668" y="1401794"/>
+            <a:ext cx="3568732" cy="3619500"/>
           </a:xfrm>
           <a:prstGeom xmlns:a="http://schemas.openxmlformats.org/drawingml/2006/main" prst="roundRect">
             <a:avLst>
-              <a:gd name="adj" fmla="val 2899"/>
+              <a:gd name="adj" fmla="val 2135"/>
             </a:avLst>
           </a:prstGeom>
           <a:solidFill xmlns:a="http://schemas.openxmlformats.org/drawingml/2006/main">
@@ -3132,51 +3605,22 @@
       </p:sp>
       <p:sp>
         <p:nvSpPr>
-          <p:cNvPr id="4" name="Rounded-Rectangle-10-5">
-            <a:extLst xmlns:a="http://schemas.openxmlformats.org/drawingml/2006/main">
-              <a:ext uri="{FF2B5EF4-FFF2-40B4-BE49-F238E27FC236}">
-                <a16:creationId xmlns:a16="http://schemas.microsoft.com/office/drawing/2014/main" id="{B378CC50-C05F-4A83-8A2F-F1F16F63D989}"/>
-              </a:ext>
-            </a:extLst>
-          </p:cNvPr>
-          <p:cNvSpPr>
-            <a:spLocks xmlns:a="http://schemas.openxmlformats.org/drawingml/2006/main" noGrp="1"/>
-          </p:cNvSpPr>
-          <p:nvPr/>
-        </p:nvSpPr>
-        <p:spPr>
-          <a:xfrm xmlns:a="http://schemas.openxmlformats.org/drawingml/2006/main">
-            <a:off x="8229600" y="3365468"/>
-            <a:ext cx="3568732" cy="2628900"/>
-          </a:xfrm>
-          <a:prstGeom xmlns:a="http://schemas.openxmlformats.org/drawingml/2006/main" prst="roundRect">
-            <a:avLst>
-              <a:gd name="adj" fmla="val 2899"/>
-            </a:avLst>
-          </a:prstGeom>
-          <a:solidFill xmlns:a="http://schemas.openxmlformats.org/drawingml/2006/main">
-            <a:srgbClr val="F2F2F2"/>
-          </a:solidFill>
-        </p:spPr>
-      </p:sp>
-      <p:sp>
-        <p:nvSpPr>
-          <p:cNvPr id="5" name="Content-Placeholder-9-6">
-            <a:extLst xmlns:a="http://schemas.openxmlformats.org/drawingml/2006/main">
-              <a:ext uri="{FF2B5EF4-FFF2-40B4-BE49-F238E27FC236}">
-                <a16:creationId xmlns:a16="http://schemas.microsoft.com/office/drawing/2014/main" id="{CBAF5CA4-63A0-40AE-86A8-7C1185111798}"/>
-              </a:ext>
-            </a:extLst>
-          </p:cNvPr>
-          <p:cNvSpPr>
-            <a:spLocks xmlns:a="http://schemas.openxmlformats.org/drawingml/2006/main" noGrp="1"/>
-          </p:cNvSpPr>
-          <p:nvPr/>
-        </p:nvSpPr>
-        <p:spPr>
-          <a:xfrm xmlns:a="http://schemas.openxmlformats.org/drawingml/2006/main">
-            <a:off x="4621816" y="4146137"/>
-            <a:ext cx="2949321" cy="1432846"/>
+          <p:cNvPr id="8" name="Content-Placeholder-8-9">
+            <a:extLst xmlns:a="http://schemas.openxmlformats.org/drawingml/2006/main">
+              <a:ext uri="{FF2B5EF4-FFF2-40B4-BE49-F238E27FC236}">
+                <a16:creationId xmlns:a16="http://schemas.microsoft.com/office/drawing/2014/main" id="{0F0FB1CF-C967-4F77-9D53-2F9608395DEC}"/>
+              </a:ext>
+            </a:extLst>
+          </p:cNvPr>
+          <p:cNvSpPr>
+            <a:spLocks xmlns:a="http://schemas.openxmlformats.org/drawingml/2006/main" noGrp="1"/>
+          </p:cNvSpPr>
+          <p:nvPr/>
+        </p:nvSpPr>
+        <p:spPr>
+          <a:xfrm xmlns:a="http://schemas.openxmlformats.org/drawingml/2006/main">
+            <a:off x="703421" y="1806797"/>
+            <a:ext cx="2949321" cy="2566797"/>
           </a:xfrm>
           <a:prstGeom xmlns:a="http://schemas.openxmlformats.org/drawingml/2006/main" prst="rect">
             <a:avLst/>
@@ -3189,7 +3633,8 @@
           <a:lstStyle xmlns:a="http://schemas.openxmlformats.org/drawingml/2006/main"/>
           <a:p xmlns:a="http://schemas.openxmlformats.org/drawingml/2006/main">
             <a:pPr algn="l">
-              <a:defRPr sz="2400">
+              <a:buNone/>
+              <a:defRPr sz="1600">
                 <a:solidFill>
                   <a:srgbClr val="000000"/>
                 </a:solidFill>
@@ -3207,12 +3652,13 @@
                 <a:ea typeface="Helvetica Neue"/>
                 <a:cs typeface="Helvetica Neue"/>
               </a:rPr>
-              <a:t>comm-audit</a:t>
+              <a:t>1. Frame and draft</a:t>
             </a:r>
           </a:p>
           <a:p xmlns:a="http://schemas.openxmlformats.org/drawingml/2006/main">
             <a:pPr algn="l">
-              <a:defRPr sz="2400">
+              <a:buNone/>
+              <a:defRPr sz="1600">
                 <a:solidFill>
                   <a:srgbClr val="000000"/>
                 </a:solidFill>
@@ -3230,29 +3676,58 @@
                 <a:ea typeface="Helvetica Neue"/>
                 <a:cs typeface="Helvetica Neue"/>
               </a:rPr>
-              <a:t>A claim-by-claim check of conditions, caveats, quantitative context, safety, rights, and access.</a:t>
+              <a:t>Name one audience and goal. Lead with one takeaway, up to two supporting claims, and a visible working-draft label.</a:t>
             </a:r>
           </a:p>
         </p:txBody>
       </p:sp>
       <p:sp>
         <p:nvSpPr>
-          <p:cNvPr id="6" name="Content-Placeholder-10-7">
-            <a:extLst xmlns:a="http://schemas.openxmlformats.org/drawingml/2006/main">
-              <a:ext uri="{FF2B5EF4-FFF2-40B4-BE49-F238E27FC236}">
-                <a16:creationId xmlns:a16="http://schemas.microsoft.com/office/drawing/2014/main" id="{FB3B1F57-ADC7-4C9B-A176-F651A39BD88B}"/>
-              </a:ext>
-            </a:extLst>
-          </p:cNvPr>
-          <p:cNvSpPr>
-            <a:spLocks xmlns:a="http://schemas.openxmlformats.org/drawingml/2006/main" noGrp="1"/>
-          </p:cNvSpPr>
-          <p:nvPr/>
-        </p:nvSpPr>
-        <p:spPr>
-          <a:xfrm xmlns:a="http://schemas.openxmlformats.org/drawingml/2006/main">
-            <a:off x="8536115" y="4146137"/>
-            <a:ext cx="2949321" cy="1432846"/>
+          <p:cNvPr id="9" name="Rounded-Rectangle-21-10">
+            <a:extLst xmlns:a="http://schemas.openxmlformats.org/drawingml/2006/main">
+              <a:ext uri="{FF2B5EF4-FFF2-40B4-BE49-F238E27FC236}">
+                <a16:creationId xmlns:a16="http://schemas.microsoft.com/office/drawing/2014/main" id="{52D5C2BA-481D-4865-9704-C6C5E1557E66}"/>
+              </a:ext>
+            </a:extLst>
+          </p:cNvPr>
+          <p:cNvSpPr>
+            <a:spLocks xmlns:a="http://schemas.openxmlformats.org/drawingml/2006/main" noGrp="1"/>
+          </p:cNvSpPr>
+          <p:nvPr/>
+        </p:nvSpPr>
+        <p:spPr>
+          <a:xfrm xmlns:a="http://schemas.openxmlformats.org/drawingml/2006/main">
+            <a:off x="4308443" y="1401794"/>
+            <a:ext cx="3568732" cy="3619500"/>
+          </a:xfrm>
+          <a:prstGeom xmlns:a="http://schemas.openxmlformats.org/drawingml/2006/main" prst="roundRect">
+            <a:avLst>
+              <a:gd name="adj" fmla="val 2135"/>
+            </a:avLst>
+          </a:prstGeom>
+          <a:solidFill xmlns:a="http://schemas.openxmlformats.org/drawingml/2006/main">
+            <a:srgbClr val="F2F2F2"/>
+          </a:solidFill>
+        </p:spPr>
+      </p:sp>
+      <p:sp>
+        <p:nvSpPr>
+          <p:cNvPr id="10" name="Content-Placeholder-8-11">
+            <a:extLst xmlns:a="http://schemas.openxmlformats.org/drawingml/2006/main">
+              <a:ext uri="{FF2B5EF4-FFF2-40B4-BE49-F238E27FC236}">
+                <a16:creationId xmlns:a16="http://schemas.microsoft.com/office/drawing/2014/main" id="{565B7658-5617-4533-A844-62CA1AE077AA}"/>
+              </a:ext>
+            </a:extLst>
+          </p:cNvPr>
+          <p:cNvSpPr>
+            <a:spLocks xmlns:a="http://schemas.openxmlformats.org/drawingml/2006/main" noGrp="1"/>
+          </p:cNvSpPr>
+          <p:nvPr/>
+        </p:nvSpPr>
+        <p:spPr>
+          <a:xfrm xmlns:a="http://schemas.openxmlformats.org/drawingml/2006/main">
+            <a:off x="4618196" y="1806797"/>
+            <a:ext cx="2949321" cy="2566797"/>
           </a:xfrm>
           <a:prstGeom xmlns:a="http://schemas.openxmlformats.org/drawingml/2006/main" prst="rect">
             <a:avLst/>
@@ -3265,7 +3740,8 @@
           <a:lstStyle xmlns:a="http://schemas.openxmlformats.org/drawingml/2006/main"/>
           <a:p xmlns:a="http://schemas.openxmlformats.org/drawingml/2006/main">
             <a:pPr algn="l">
-              <a:defRPr sz="2400">
+              <a:buNone/>
+              <a:defRPr sz="1600">
                 <a:solidFill>
                   <a:srgbClr val="000000"/>
                 </a:solidFill>
@@ -3283,12 +3759,13 @@
                 <a:ea typeface="Helvetica Neue"/>
                 <a:cs typeface="Helvetica Neue"/>
               </a:rPr>
-              <a:t>One enforceable rule</a:t>
+              <a:t>2. Verify and approve</a:t>
             </a:r>
           </a:p>
           <a:p xmlns:a="http://schemas.openxmlformats.org/drawingml/2006/main">
             <a:pPr algn="l">
-              <a:defRPr sz="2400">
+              <a:buNone/>
+              <a:defRPr sz="1600">
                 <a:solidFill>
                   <a:srgbClr val="000000"/>
                 </a:solidFill>
@@ -3306,281 +3783,33 @@
                 <a:ea typeface="Helvetica Neue"/>
                 <a:cs typeface="Helvetica Neue"/>
               </a:rPr>
-              <a:t>No artifact is called audited or publishable until the required human checkpoints and material audit items are resolved.</a:t>
+              <a:t>Check every load-bearing claim against primary sources. Then a responsible human approves the core evidence map.</a:t>
             </a:r>
           </a:p>
         </p:txBody>
       </p:sp>
       <p:sp>
         <p:nvSpPr>
-          <p:cNvPr id="7" name="Google-Shape-340-p61-8">
-            <a:extLst xmlns:a="http://schemas.openxmlformats.org/drawingml/2006/main">
-              <a:ext uri="{FF2B5EF4-FFF2-40B4-BE49-F238E27FC236}">
-                <a16:creationId xmlns:a16="http://schemas.microsoft.com/office/drawing/2014/main" id="{3C7BD552-A471-40C2-9394-9C73AB928185}"/>
-              </a:ext>
-            </a:extLst>
-          </p:cNvPr>
-          <p:cNvSpPr>
-            <a:spLocks xmlns:a="http://schemas.openxmlformats.org/drawingml/2006/main" noGrp="1"/>
-          </p:cNvSpPr>
-          <p:nvPr/>
-        </p:nvSpPr>
-        <p:spPr>
-          <a:xfrm xmlns:a="http://schemas.openxmlformats.org/drawingml/2006/main">
-            <a:off x="4627626" y="3694081"/>
-            <a:ext cx="233839" cy="233744"/>
-          </a:xfrm>
-          <a:custGeom xmlns:a="http://schemas.openxmlformats.org/drawingml/2006/main">
-            <a:pathLst>
-              <a:path w="205740000" h="205740000">
-                <a:moveTo>
-                  <a:pt x="102870000" y="20574000"/>
-                </a:moveTo>
-                <a:cubicBezTo>
-                  <a:pt x="57426225" y="20574000"/>
-                  <a:pt x="20574000" y="57426225"/>
-                  <a:pt x="20574000" y="102870000"/>
-                </a:cubicBezTo>
-                <a:cubicBezTo>
-                  <a:pt x="20574000" y="148313775"/>
-                  <a:pt x="57426225" y="185166000"/>
-                  <a:pt x="102870000" y="185166000"/>
-                </a:cubicBezTo>
-                <a:cubicBezTo>
-                  <a:pt x="148313775" y="185166000"/>
-                  <a:pt x="185166000" y="148313775"/>
-                  <a:pt x="185166000" y="102870000"/>
-                </a:cubicBezTo>
-                <a:cubicBezTo>
-                  <a:pt x="185166000" y="57426225"/>
-                  <a:pt x="148313775" y="20574000"/>
-                  <a:pt x="102870000" y="20574000"/>
-                </a:cubicBezTo>
-                <a:close/>
-                <a:moveTo>
-                  <a:pt x="0" y="102870000"/>
-                </a:moveTo>
-                <a:cubicBezTo>
-                  <a:pt x="0" y="46053375"/>
-                  <a:pt x="46053375" y="0"/>
-                  <a:pt x="102870000" y="0"/>
-                </a:cubicBezTo>
-                <a:cubicBezTo>
-                  <a:pt x="159686625" y="0"/>
-                  <a:pt x="205740000" y="46053375"/>
-                  <a:pt x="205740000" y="102870000"/>
-                </a:cubicBezTo>
-                <a:cubicBezTo>
-                  <a:pt x="205740000" y="159686625"/>
-                  <a:pt x="159686625" y="205740000"/>
-                  <a:pt x="102870000" y="205740000"/>
-                </a:cubicBezTo>
-                <a:cubicBezTo>
-                  <a:pt x="46053375" y="205740000"/>
-                  <a:pt x="0" y="159686625"/>
-                  <a:pt x="0" y="102870000"/>
-                </a:cubicBezTo>
-                <a:close/>
-                <a:moveTo>
-                  <a:pt x="144789525" y="61026675"/>
-                </a:moveTo>
-                <a:cubicBezTo>
-                  <a:pt x="149437725" y="64293750"/>
-                  <a:pt x="150561675" y="70713600"/>
-                  <a:pt x="147285075" y="75352275"/>
-                </a:cubicBezTo>
-                <a:lnTo>
-                  <a:pt x="98421825" y="144789525"/>
-                </a:lnTo>
-                <a:cubicBezTo>
-                  <a:pt x="96621600" y="147351750"/>
-                  <a:pt x="93764100" y="148942425"/>
-                  <a:pt x="90649425" y="149142450"/>
-                </a:cubicBezTo>
-                <a:cubicBezTo>
-                  <a:pt x="87534750" y="149332950"/>
-                  <a:pt x="84496275" y="148104225"/>
-                  <a:pt x="82400775" y="145799175"/>
-                </a:cubicBezTo>
-                <a:lnTo>
-                  <a:pt x="56683275" y="117509925"/>
-                </a:lnTo>
-                <a:cubicBezTo>
-                  <a:pt x="52863750" y="113299875"/>
-                  <a:pt x="53178075" y="106803825"/>
-                  <a:pt x="57369075" y="102974775"/>
-                </a:cubicBezTo>
-                <a:cubicBezTo>
-                  <a:pt x="61579125" y="99155250"/>
-                  <a:pt x="68075175" y="99469575"/>
-                  <a:pt x="71904225" y="103660575"/>
-                </a:cubicBezTo>
-                <a:lnTo>
-                  <a:pt x="88982550" y="122453400"/>
-                </a:lnTo>
-                <a:lnTo>
-                  <a:pt x="130463925" y="63522225"/>
-                </a:lnTo>
-                <a:cubicBezTo>
-                  <a:pt x="133731000" y="58874025"/>
-                  <a:pt x="140150850" y="57750075"/>
-                  <a:pt x="144789525" y="61026675"/>
-                </a:cubicBezTo>
-                <a:close/>
-              </a:path>
-            </a:pathLst>
-          </a:custGeom>
-          <a:solidFill xmlns:a="http://schemas.openxmlformats.org/drawingml/2006/main">
-            <a:srgbClr val="000000"/>
-          </a:solidFill>
-        </p:spPr>
-      </p:sp>
-      <p:sp>
-        <p:nvSpPr>
-          <p:cNvPr id="8" name="Google-Shape-340-p61-9">
-            <a:extLst xmlns:a="http://schemas.openxmlformats.org/drawingml/2006/main">
-              <a:ext uri="{FF2B5EF4-FFF2-40B4-BE49-F238E27FC236}">
-                <a16:creationId xmlns:a16="http://schemas.microsoft.com/office/drawing/2014/main" id="{EEA6CFB4-4183-4F67-93B1-CED7096376B4}"/>
-              </a:ext>
-            </a:extLst>
-          </p:cNvPr>
-          <p:cNvSpPr>
-            <a:spLocks xmlns:a="http://schemas.openxmlformats.org/drawingml/2006/main" noGrp="1"/>
-          </p:cNvSpPr>
-          <p:nvPr/>
-        </p:nvSpPr>
-        <p:spPr>
-          <a:xfrm xmlns:a="http://schemas.openxmlformats.org/drawingml/2006/main">
-            <a:off x="8533257" y="3694081"/>
-            <a:ext cx="233839" cy="233744"/>
-          </a:xfrm>
-          <a:custGeom xmlns:a="http://schemas.openxmlformats.org/drawingml/2006/main">
-            <a:pathLst>
-              <a:path w="205740000" h="205740000">
-                <a:moveTo>
-                  <a:pt x="102870000" y="20574000"/>
-                </a:moveTo>
-                <a:cubicBezTo>
-                  <a:pt x="57426225" y="20574000"/>
-                  <a:pt x="20574000" y="57426225"/>
-                  <a:pt x="20574000" y="102870000"/>
-                </a:cubicBezTo>
-                <a:cubicBezTo>
-                  <a:pt x="20574000" y="148313775"/>
-                  <a:pt x="57426225" y="185166000"/>
-                  <a:pt x="102870000" y="185166000"/>
-                </a:cubicBezTo>
-                <a:cubicBezTo>
-                  <a:pt x="148313775" y="185166000"/>
-                  <a:pt x="185166000" y="148313775"/>
-                  <a:pt x="185166000" y="102870000"/>
-                </a:cubicBezTo>
-                <a:cubicBezTo>
-                  <a:pt x="185166000" y="57426225"/>
-                  <a:pt x="148313775" y="20574000"/>
-                  <a:pt x="102870000" y="20574000"/>
-                </a:cubicBezTo>
-                <a:close/>
-                <a:moveTo>
-                  <a:pt x="0" y="102870000"/>
-                </a:moveTo>
-                <a:cubicBezTo>
-                  <a:pt x="0" y="46053375"/>
-                  <a:pt x="46053375" y="0"/>
-                  <a:pt x="102870000" y="0"/>
-                </a:cubicBezTo>
-                <a:cubicBezTo>
-                  <a:pt x="159686625" y="0"/>
-                  <a:pt x="205740000" y="46053375"/>
-                  <a:pt x="205740000" y="102870000"/>
-                </a:cubicBezTo>
-                <a:cubicBezTo>
-                  <a:pt x="205740000" y="159686625"/>
-                  <a:pt x="159686625" y="205740000"/>
-                  <a:pt x="102870000" y="205740000"/>
-                </a:cubicBezTo>
-                <a:cubicBezTo>
-                  <a:pt x="46053375" y="205740000"/>
-                  <a:pt x="0" y="159686625"/>
-                  <a:pt x="0" y="102870000"/>
-                </a:cubicBezTo>
-                <a:close/>
-                <a:moveTo>
-                  <a:pt x="144789525" y="61026675"/>
-                </a:moveTo>
-                <a:cubicBezTo>
-                  <a:pt x="149437725" y="64293750"/>
-                  <a:pt x="150561675" y="70713600"/>
-                  <a:pt x="147285075" y="75352275"/>
-                </a:cubicBezTo>
-                <a:lnTo>
-                  <a:pt x="98421825" y="144789525"/>
-                </a:lnTo>
-                <a:cubicBezTo>
-                  <a:pt x="96621600" y="147351750"/>
-                  <a:pt x="93764100" y="148942425"/>
-                  <a:pt x="90649425" y="149142450"/>
-                </a:cubicBezTo>
-                <a:cubicBezTo>
-                  <a:pt x="87534750" y="149332950"/>
-                  <a:pt x="84496275" y="148104225"/>
-                  <a:pt x="82400775" y="145799175"/>
-                </a:cubicBezTo>
-                <a:lnTo>
-                  <a:pt x="56683275" y="117509925"/>
-                </a:lnTo>
-                <a:cubicBezTo>
-                  <a:pt x="52863750" y="113299875"/>
-                  <a:pt x="53178075" y="106803825"/>
-                  <a:pt x="57369075" y="102974775"/>
-                </a:cubicBezTo>
-                <a:cubicBezTo>
-                  <a:pt x="61579125" y="99155250"/>
-                  <a:pt x="68075175" y="99469575"/>
-                  <a:pt x="71904225" y="103660575"/>
-                </a:cubicBezTo>
-                <a:lnTo>
-                  <a:pt x="88982550" y="122453400"/>
-                </a:lnTo>
-                <a:lnTo>
-                  <a:pt x="130463925" y="63522225"/>
-                </a:lnTo>
-                <a:cubicBezTo>
-                  <a:pt x="133731000" y="58874025"/>
-                  <a:pt x="140150850" y="57750075"/>
-                  <a:pt x="144789525" y="61026675"/>
-                </a:cubicBezTo>
-                <a:close/>
-              </a:path>
-            </a:pathLst>
-          </a:custGeom>
-          <a:solidFill xmlns:a="http://schemas.openxmlformats.org/drawingml/2006/main">
-            <a:srgbClr val="000000"/>
-          </a:solidFill>
-        </p:spPr>
-      </p:sp>
-      <p:sp>
-        <p:nvSpPr>
-          <p:cNvPr id="9" name="Rounded-Rectangle-5-10">
-            <a:extLst xmlns:a="http://schemas.openxmlformats.org/drawingml/2006/main">
-              <a:ext uri="{FF2B5EF4-FFF2-40B4-BE49-F238E27FC236}">
-                <a16:creationId xmlns:a16="http://schemas.microsoft.com/office/drawing/2014/main" id="{4EE79339-07AC-4278-B951-0F897B8ECB8C}"/>
-              </a:ext>
-            </a:extLst>
-          </p:cNvPr>
-          <p:cNvSpPr>
-            <a:spLocks xmlns:a="http://schemas.openxmlformats.org/drawingml/2006/main" noGrp="1"/>
-          </p:cNvSpPr>
-          <p:nvPr/>
-        </p:nvSpPr>
-        <p:spPr>
-          <a:xfrm xmlns:a="http://schemas.openxmlformats.org/drawingml/2006/main">
-            <a:off x="388334" y="3365468"/>
-            <a:ext cx="3568732" cy="2628900"/>
+          <p:cNvPr id="11" name="Rounded-Rectangle-23-12">
+            <a:extLst xmlns:a="http://schemas.openxmlformats.org/drawingml/2006/main">
+              <a:ext uri="{FF2B5EF4-FFF2-40B4-BE49-F238E27FC236}">
+                <a16:creationId xmlns:a16="http://schemas.microsoft.com/office/drawing/2014/main" id="{88B81F4D-191B-41F9-AB50-027FC5EE5BC6}"/>
+              </a:ext>
+            </a:extLst>
+          </p:cNvPr>
+          <p:cNvSpPr>
+            <a:spLocks xmlns:a="http://schemas.openxmlformats.org/drawingml/2006/main" noGrp="1"/>
+          </p:cNvSpPr>
+          <p:nvPr/>
+        </p:nvSpPr>
+        <p:spPr>
+          <a:xfrm xmlns:a="http://schemas.openxmlformats.org/drawingml/2006/main">
+            <a:off x="8237506" y="1401794"/>
+            <a:ext cx="3568732" cy="3619500"/>
           </a:xfrm>
           <a:prstGeom xmlns:a="http://schemas.openxmlformats.org/drawingml/2006/main" prst="roundRect">
             <a:avLst>
-              <a:gd name="adj" fmla="val 2899"/>
+              <a:gd name="adj" fmla="val 2135"/>
             </a:avLst>
           </a:prstGeom>
           <a:solidFill xmlns:a="http://schemas.openxmlformats.org/drawingml/2006/main">
@@ -3590,22 +3819,22 @@
       </p:sp>
       <p:sp>
         <p:nvSpPr>
-          <p:cNvPr id="10" name="Content-Placeholder-9-11">
-            <a:extLst xmlns:a="http://schemas.openxmlformats.org/drawingml/2006/main">
-              <a:ext uri="{FF2B5EF4-FFF2-40B4-BE49-F238E27FC236}">
-                <a16:creationId xmlns:a16="http://schemas.microsoft.com/office/drawing/2014/main" id="{C885B357-6091-4014-B2DF-06422E1C2259}"/>
-              </a:ext>
-            </a:extLst>
-          </p:cNvPr>
-          <p:cNvSpPr>
-            <a:spLocks xmlns:a="http://schemas.openxmlformats.org/drawingml/2006/main" noGrp="1"/>
-          </p:cNvSpPr>
-          <p:nvPr/>
-        </p:nvSpPr>
-        <p:spPr>
-          <a:xfrm xmlns:a="http://schemas.openxmlformats.org/drawingml/2006/main">
-            <a:off x="701135" y="4146137"/>
-            <a:ext cx="2949321" cy="1432846"/>
+          <p:cNvPr id="12" name="Content-Placeholder-8-13">
+            <a:extLst xmlns:a="http://schemas.openxmlformats.org/drawingml/2006/main">
+              <a:ext uri="{FF2B5EF4-FFF2-40B4-BE49-F238E27FC236}">
+                <a16:creationId xmlns:a16="http://schemas.microsoft.com/office/drawing/2014/main" id="{88BF9944-1B8C-4CD4-AAD1-7402D4F05A6D}"/>
+              </a:ext>
+            </a:extLst>
+          </p:cNvPr>
+          <p:cNvSpPr>
+            <a:spLocks xmlns:a="http://schemas.openxmlformats.org/drawingml/2006/main" noGrp="1"/>
+          </p:cNvSpPr>
+          <p:nvPr/>
+        </p:nvSpPr>
+        <p:spPr>
+          <a:xfrm xmlns:a="http://schemas.openxmlformats.org/drawingml/2006/main">
+            <a:off x="8547259" y="1806797"/>
+            <a:ext cx="2949321" cy="2566797"/>
           </a:xfrm>
           <a:prstGeom xmlns:a="http://schemas.openxmlformats.org/drawingml/2006/main" prst="rect">
             <a:avLst/>
@@ -3618,7 +3847,8 @@
           <a:lstStyle xmlns:a="http://schemas.openxmlformats.org/drawingml/2006/main"/>
           <a:p xmlns:a="http://schemas.openxmlformats.org/drawingml/2006/main">
             <a:pPr algn="l">
-              <a:defRPr sz="2400">
+              <a:buNone/>
+              <a:defRPr sz="1600">
                 <a:solidFill>
                   <a:srgbClr val="000000"/>
                 </a:solidFill>
@@ -3636,12 +3866,13 @@
                 <a:ea typeface="Helvetica Neue"/>
                 <a:cs typeface="Helvetica Neue"/>
               </a:rPr>
-              <a:t>comm-press</a:t>
+              <a:t>3. Test and audit</a:t>
             </a:r>
           </a:p>
           <a:p xmlns:a="http://schemas.openxmlformats.org/drawingml/2006/main">
             <a:pPr algn="l">
-              <a:defRPr sz="2400">
+              <a:buNone/>
+              <a:defRPr sz="1600">
                 <a:solidFill>
                   <a:srgbClr val="000000"/>
                 </a:solidFill>
@@ -3659,166 +3890,43 @@
                 <a:ea typeface="Helvetica Neue"/>
                 <a:cs typeface="Helvetica Neue"/>
               </a:rPr>
-              <a:t>Source-verifiable releases, media briefs, pitches, and journalist FAQs without manufactured hype.</a:t>
+              <a:t>Use reader teach-back, rapid checks during drafting, and a full, proportionate audit before publication.</a:t>
             </a:r>
           </a:p>
         </p:txBody>
       </p:sp>
       <p:sp>
         <p:nvSpPr>
-          <p:cNvPr id="11" name="Google-Shape-340-p61-12">
-            <a:extLst xmlns:a="http://schemas.openxmlformats.org/drawingml/2006/main">
-              <a:ext uri="{FF2B5EF4-FFF2-40B4-BE49-F238E27FC236}">
-                <a16:creationId xmlns:a16="http://schemas.microsoft.com/office/drawing/2014/main" id="{875F1972-37AC-47DC-8D1F-C0FB8C87A7AC}"/>
-              </a:ext>
-            </a:extLst>
-          </p:cNvPr>
-          <p:cNvSpPr>
-            <a:spLocks xmlns:a="http://schemas.openxmlformats.org/drawingml/2006/main" noGrp="1"/>
-          </p:cNvSpPr>
-          <p:nvPr/>
-        </p:nvSpPr>
-        <p:spPr>
-          <a:xfrm xmlns:a="http://schemas.openxmlformats.org/drawingml/2006/main">
-            <a:off x="707041" y="3694081"/>
-            <a:ext cx="233839" cy="233744"/>
-          </a:xfrm>
-          <a:custGeom xmlns:a="http://schemas.openxmlformats.org/drawingml/2006/main">
-            <a:pathLst>
-              <a:path w="205740000" h="205740000">
-                <a:moveTo>
-                  <a:pt x="102870000" y="20574000"/>
-                </a:moveTo>
-                <a:cubicBezTo>
-                  <a:pt x="57426225" y="20574000"/>
-                  <a:pt x="20574000" y="57426225"/>
-                  <a:pt x="20574000" y="102870000"/>
-                </a:cubicBezTo>
-                <a:cubicBezTo>
-                  <a:pt x="20574000" y="148313775"/>
-                  <a:pt x="57426225" y="185166000"/>
-                  <a:pt x="102870000" y="185166000"/>
-                </a:cubicBezTo>
-                <a:cubicBezTo>
-                  <a:pt x="148313775" y="185166000"/>
-                  <a:pt x="185166000" y="148313775"/>
-                  <a:pt x="185166000" y="102870000"/>
-                </a:cubicBezTo>
-                <a:cubicBezTo>
-                  <a:pt x="185166000" y="57426225"/>
-                  <a:pt x="148313775" y="20574000"/>
-                  <a:pt x="102870000" y="20574000"/>
-                </a:cubicBezTo>
-                <a:close/>
-                <a:moveTo>
-                  <a:pt x="0" y="102870000"/>
-                </a:moveTo>
-                <a:cubicBezTo>
-                  <a:pt x="0" y="46053375"/>
-                  <a:pt x="46053375" y="0"/>
-                  <a:pt x="102870000" y="0"/>
-                </a:cubicBezTo>
-                <a:cubicBezTo>
-                  <a:pt x="159686625" y="0"/>
-                  <a:pt x="205740000" y="46053375"/>
-                  <a:pt x="205740000" y="102870000"/>
-                </a:cubicBezTo>
-                <a:cubicBezTo>
-                  <a:pt x="205740000" y="159686625"/>
-                  <a:pt x="159686625" y="205740000"/>
-                  <a:pt x="102870000" y="205740000"/>
-                </a:cubicBezTo>
-                <a:cubicBezTo>
-                  <a:pt x="46053375" y="205740000"/>
-                  <a:pt x="0" y="159686625"/>
-                  <a:pt x="0" y="102870000"/>
-                </a:cubicBezTo>
-                <a:close/>
-                <a:moveTo>
-                  <a:pt x="144789525" y="61026675"/>
-                </a:moveTo>
-                <a:cubicBezTo>
-                  <a:pt x="149437725" y="64293750"/>
-                  <a:pt x="150561675" y="70713600"/>
-                  <a:pt x="147285075" y="75352275"/>
-                </a:cubicBezTo>
-                <a:lnTo>
-                  <a:pt x="98421825" y="144789525"/>
-                </a:lnTo>
-                <a:cubicBezTo>
-                  <a:pt x="96621600" y="147351750"/>
-                  <a:pt x="93764100" y="148942425"/>
-                  <a:pt x="90649425" y="149142450"/>
-                </a:cubicBezTo>
-                <a:cubicBezTo>
-                  <a:pt x="87534750" y="149332950"/>
-                  <a:pt x="84496275" y="148104225"/>
-                  <a:pt x="82400775" y="145799175"/>
-                </a:cubicBezTo>
-                <a:lnTo>
-                  <a:pt x="56683275" y="117509925"/>
-                </a:lnTo>
-                <a:cubicBezTo>
-                  <a:pt x="52863750" y="113299875"/>
-                  <a:pt x="53178075" y="106803825"/>
-                  <a:pt x="57369075" y="102974775"/>
-                </a:cubicBezTo>
-                <a:cubicBezTo>
-                  <a:pt x="61579125" y="99155250"/>
-                  <a:pt x="68075175" y="99469575"/>
-                  <a:pt x="71904225" y="103660575"/>
-                </a:cubicBezTo>
-                <a:lnTo>
-                  <a:pt x="88982550" y="122453400"/>
-                </a:lnTo>
-                <a:lnTo>
-                  <a:pt x="130463925" y="63522225"/>
-                </a:lnTo>
-                <a:cubicBezTo>
-                  <a:pt x="133731000" y="58874025"/>
-                  <a:pt x="140150850" y="57750075"/>
-                  <a:pt x="144789525" y="61026675"/>
-                </a:cubicBezTo>
-                <a:close/>
-              </a:path>
-            </a:pathLst>
-          </a:custGeom>
-          <a:solidFill xmlns:a="http://schemas.openxmlformats.org/drawingml/2006/main">
-            <a:srgbClr val="000000"/>
-          </a:solidFill>
-        </p:spPr>
-      </p:sp>
-      <p:sp>
-        <p:nvSpPr>
-          <p:cNvPr id="12" name="Content-Placeholder-15-13">
-            <a:extLst xmlns:a="http://schemas.openxmlformats.org/drawingml/2006/main">
-              <a:ext uri="{FF2B5EF4-FFF2-40B4-BE49-F238E27FC236}">
-                <a16:creationId xmlns:a16="http://schemas.microsoft.com/office/drawing/2014/main" id="{464DDC0B-A0A7-44B7-B249-132D2189E40D}"/>
-              </a:ext>
-            </a:extLst>
-          </p:cNvPr>
-          <p:cNvSpPr>
-            <a:spLocks xmlns:a="http://schemas.openxmlformats.org/drawingml/2006/main" noGrp="1"/>
-          </p:cNvSpPr>
-          <p:nvPr/>
-        </p:nvSpPr>
-        <p:spPr>
-          <a:xfrm xmlns:a="http://schemas.openxmlformats.org/drawingml/2006/main">
-            <a:off x="393668" y="1450562"/>
-            <a:ext cx="11404568" cy="1629251"/>
+          <p:cNvPr id="13" name="Text-Placeholder-16-14">
+            <a:extLst xmlns:a="http://schemas.openxmlformats.org/drawingml/2006/main">
+              <a:ext uri="{FF2B5EF4-FFF2-40B4-BE49-F238E27FC236}">
+                <a16:creationId xmlns:a16="http://schemas.microsoft.com/office/drawing/2014/main" id="{16FA7573-F187-4C2E-AAE8-C3EA734AF506}"/>
+              </a:ext>
+            </a:extLst>
+          </p:cNvPr>
+          <p:cNvSpPr>
+            <a:spLocks xmlns:a="http://schemas.openxmlformats.org/drawingml/2006/main" noGrp="1"/>
+          </p:cNvSpPr>
+          <p:nvPr/>
+        </p:nvSpPr>
+        <p:spPr>
+          <a:xfrm xmlns:a="http://schemas.openxmlformats.org/drawingml/2006/main">
+            <a:off x="4251770" y="5602414"/>
+            <a:ext cx="2595944" cy="391954"/>
           </a:xfrm>
           <a:prstGeom xmlns:a="http://schemas.openxmlformats.org/drawingml/2006/main" prst="rect">
             <a:avLst/>
           </a:prstGeom>
         </p:spPr>
         <p:txBody>
-          <a:bodyPr xmlns:a="http://schemas.openxmlformats.org/drawingml/2006/main" lIns="0" tIns="0" rIns="0" bIns="0">
+          <a:bodyPr xmlns:a="http://schemas.openxmlformats.org/drawingml/2006/main" lIns="91440" tIns="45720" rIns="91440" bIns="45720">
             <a:noAutofit/>
           </a:bodyPr>
           <a:lstStyle xmlns:a="http://schemas.openxmlformats.org/drawingml/2006/main"/>
           <a:p xmlns:a="http://schemas.openxmlformats.org/drawingml/2006/main">
             <a:pPr algn="l">
-              <a:defRPr sz="1600">
+              <a:buNone/>
+              <a:defRPr sz="2400">
                 <a:solidFill>
                   <a:srgbClr val="000000"/>
                 </a:solidFill>
@@ -3836,12 +3944,43 @@
                 <a:ea typeface="Helvetica Neue"/>
                 <a:cs typeface="Helvetica Neue"/>
               </a:rPr>
-              <a:t>comm-public</a:t>
+              <a:t>verified evidence</a:t>
             </a:r>
           </a:p>
+        </p:txBody>
+      </p:sp>
+      <p:sp>
+        <p:nvSpPr>
+          <p:cNvPr id="14" name="Text-Placeholder-16-15">
+            <a:extLst xmlns:a="http://schemas.openxmlformats.org/drawingml/2006/main">
+              <a:ext uri="{FF2B5EF4-FFF2-40B4-BE49-F238E27FC236}">
+                <a16:creationId xmlns:a16="http://schemas.microsoft.com/office/drawing/2014/main" id="{E7824956-157C-42E0-8820-4AFC07BB7C06}"/>
+              </a:ext>
+            </a:extLst>
+          </p:cNvPr>
+          <p:cNvSpPr>
+            <a:spLocks xmlns:a="http://schemas.openxmlformats.org/drawingml/2006/main" noGrp="1"/>
+          </p:cNvSpPr>
+          <p:nvPr/>
+        </p:nvSpPr>
+        <p:spPr>
+          <a:xfrm xmlns:a="http://schemas.openxmlformats.org/drawingml/2006/main">
+            <a:off x="390906" y="5602414"/>
+            <a:ext cx="2595944" cy="391954"/>
+          </a:xfrm>
+          <a:prstGeom xmlns:a="http://schemas.openxmlformats.org/drawingml/2006/main" prst="rect">
+            <a:avLst/>
+          </a:prstGeom>
+        </p:spPr>
+        <p:txBody>
+          <a:bodyPr xmlns:a="http://schemas.openxmlformats.org/drawingml/2006/main" lIns="91440" tIns="45720" rIns="91440" bIns="45720">
+            <a:noAutofit/>
+          </a:bodyPr>
+          <a:lstStyle xmlns:a="http://schemas.openxmlformats.org/drawingml/2006/main"/>
           <a:p xmlns:a="http://schemas.openxmlformats.org/drawingml/2006/main">
             <a:pPr algn="l">
-              <a:defRPr sz="1600">
+              <a:buNone/>
+              <a:defRPr sz="2400">
                 <a:solidFill>
                   <a:srgbClr val="000000"/>
                 </a:solidFill>
@@ -3859,12 +3998,43 @@
                 <a:ea typeface="Helvetica Neue"/>
                 <a:cs typeface="Helvetica Neue"/>
               </a:rPr>
-              <a:t>Explainers, FAQs, social copy, visual briefs, and safer demo briefs for a named audience.</a:t>
+              <a:t>working draft</a:t>
             </a:r>
           </a:p>
+        </p:txBody>
+      </p:sp>
+      <p:sp>
+        <p:nvSpPr>
+          <p:cNvPr id="15" name="Text-Placeholder-16-16">
+            <a:extLst xmlns:a="http://schemas.openxmlformats.org/drawingml/2006/main">
+              <a:ext uri="{FF2B5EF4-FFF2-40B4-BE49-F238E27FC236}">
+                <a16:creationId xmlns:a16="http://schemas.microsoft.com/office/drawing/2014/main" id="{2865F808-287C-49A0-9833-2E6B7D30C1A1}"/>
+              </a:ext>
+            </a:extLst>
+          </p:cNvPr>
+          <p:cNvSpPr>
+            <a:spLocks xmlns:a="http://schemas.openxmlformats.org/drawingml/2006/main" noGrp="1"/>
+          </p:cNvSpPr>
+          <p:nvPr/>
+        </p:nvSpPr>
+        <p:spPr>
+          <a:xfrm xmlns:a="http://schemas.openxmlformats.org/drawingml/2006/main">
+            <a:off x="8225409" y="5602414"/>
+            <a:ext cx="2595944" cy="391954"/>
+          </a:xfrm>
+          <a:prstGeom xmlns:a="http://schemas.openxmlformats.org/drawingml/2006/main" prst="rect">
+            <a:avLst/>
+          </a:prstGeom>
+        </p:spPr>
+        <p:txBody>
+          <a:bodyPr xmlns:a="http://schemas.openxmlformats.org/drawingml/2006/main" lIns="91440" tIns="45720" rIns="91440" bIns="45720">
+            <a:noAutofit/>
+          </a:bodyPr>
+          <a:lstStyle xmlns:a="http://schemas.openxmlformats.org/drawingml/2006/main"/>
           <a:p xmlns:a="http://schemas.openxmlformats.org/drawingml/2006/main">
             <a:pPr algn="l">
-              <a:defRPr sz="1600">
+              <a:buNone/>
+              <a:defRPr sz="2400">
                 <a:solidFill>
                   <a:srgbClr val="000000"/>
                 </a:solidFill>
@@ -3882,7 +4052,7 @@
                 <a:ea typeface="Helvetica Neue"/>
                 <a:cs typeface="Helvetica Neue"/>
               </a:rPr>
-              <a:t>Built from primary sources and a named audience brief.</a:t>
+              <a:t>publication decision</a:t>
             </a:r>
           </a:p>
         </p:txBody>
@@ -3890,7 +4060,7 @@
     </p:spTree>
     <p:extLst>
       <p:ext uri="{BB962C8B-B14F-4D97-AF65-F5344CB8AC3E}">
-        <p14:creationId xmlns:p14="http://schemas.microsoft.com/office/powerpoint/2010/main" val="1748398193"/>
+        <p14:creationId xmlns:p14="http://schemas.microsoft.com/office/powerpoint/2010/main" val="1727701032"/>
       </p:ext>
     </p:extLst>
   </p:cSld>
@@ -3911,10 +4081,935 @@
       </p:grpSpPr>
       <p:sp>
         <p:nvSpPr>
-          <p:cNvPr id="5" name="Title-3-1">
-            <a:extLst xmlns:a="http://schemas.openxmlformats.org/drawingml/2006/main">
-              <a:ext uri="{FF2B5EF4-FFF2-40B4-BE49-F238E27FC236}">
-                <a16:creationId xmlns:a16="http://schemas.microsoft.com/office/drawing/2014/main" id="{719F3077-BB57-4574-A1C5-D479A04FBA95}"/>
+          <p:cNvPr id="13" name="Google-Shape-532-p58-2">
+            <a:extLst xmlns:a="http://schemas.openxmlformats.org/drawingml/2006/main">
+              <a:ext uri="{FF2B5EF4-FFF2-40B4-BE49-F238E27FC236}">
+                <a16:creationId xmlns:a16="http://schemas.microsoft.com/office/drawing/2014/main" id="{84ABE108-BF7A-491C-AB2A-CDF3712C1E0F}"/>
+              </a:ext>
+            </a:extLst>
+          </p:cNvPr>
+          <p:cNvSpPr>
+            <a:spLocks xmlns:a="http://schemas.openxmlformats.org/drawingml/2006/main" noGrp="1"/>
+          </p:cNvSpPr>
+          <p:nvPr/>
+        </p:nvSpPr>
+        <p:spPr>
+          <a:xfrm xmlns:a="http://schemas.openxmlformats.org/drawingml/2006/main">
+            <a:off x="11279315" y="6279261"/>
+            <a:ext cx="518922" cy="241268"/>
+          </a:xfrm>
+          <a:prstGeom xmlns:a="http://schemas.openxmlformats.org/drawingml/2006/main" prst="rect">
+            <a:avLst/>
+          </a:prstGeom>
+        </p:spPr>
+        <p:txBody>
+          <a:bodyPr xmlns:a="http://schemas.openxmlformats.org/drawingml/2006/main" wrap="square" lIns="0" tIns="0" rIns="0" bIns="0" anchor="b">
+            <a:noAutofit/>
+          </a:bodyPr>
+          <a:lstStyle xmlns:a="http://schemas.openxmlformats.org/drawingml/2006/main"/>
+          <a:p xmlns:a="http://schemas.openxmlformats.org/drawingml/2006/main">
+            <a:pPr algn="r">
+              <a:buNone/>
+              <a:defRPr sz="1000">
+                <a:solidFill>
+                  <a:srgbClr val="000000"/>
+                </a:solidFill>
+                <a:latin typeface="Helvetica Neue"/>
+                <a:ea typeface="Helvetica Neue"/>
+                <a:cs typeface="Helvetica Neue"/>
+              </a:defRPr>
+            </a:pPr>
+            <a:r>
+              <a:rPr sz="1000">
+                <a:solidFill>
+                  <a:srgbClr val="000000"/>
+                </a:solidFill>
+                <a:latin typeface="Helvetica Neue"/>
+                <a:ea typeface="Helvetica Neue"/>
+                <a:cs typeface="Helvetica Neue"/>
+              </a:rPr>
+              <a:t>5</a:t>
+            </a:r>
+          </a:p>
+        </p:txBody>
+      </p:sp>
+      <p:sp>
+        <p:nvSpPr>
+          <p:cNvPr id="2" name="Google-Shape-533-p58-3">
+            <a:extLst xmlns:a="http://schemas.openxmlformats.org/drawingml/2006/main">
+              <a:ext uri="{FF2B5EF4-FFF2-40B4-BE49-F238E27FC236}">
+                <a16:creationId xmlns:a16="http://schemas.microsoft.com/office/drawing/2014/main" id="{A99E2CF9-8D2C-459A-9D0A-DB21089B6201}"/>
+              </a:ext>
+            </a:extLst>
+          </p:cNvPr>
+          <p:cNvSpPr>
+            <a:spLocks xmlns:a="http://schemas.openxmlformats.org/drawingml/2006/main" noGrp="1"/>
+          </p:cNvSpPr>
+          <p:nvPr/>
+        </p:nvSpPr>
+        <p:spPr>
+          <a:xfrm xmlns:a="http://schemas.openxmlformats.org/drawingml/2006/main">
+            <a:off x="393668" y="344519"/>
+            <a:ext cx="11404568" cy="1283018"/>
+          </a:xfrm>
+          <a:prstGeom xmlns:a="http://schemas.openxmlformats.org/drawingml/2006/main" prst="rect">
+            <a:avLst/>
+          </a:prstGeom>
+        </p:spPr>
+        <p:txBody>
+          <a:bodyPr xmlns:a="http://schemas.openxmlformats.org/drawingml/2006/main" wrap="square" lIns="0" tIns="0" rIns="0" bIns="0" anchor="t">
+            <a:noAutofit/>
+          </a:bodyPr>
+          <a:lstStyle xmlns:a="http://schemas.openxmlformats.org/drawingml/2006/main"/>
+          <a:p xmlns:a="http://schemas.openxmlformats.org/drawingml/2006/main">
+            <a:pPr algn="l">
+              <a:buNone/>
+              <a:defRPr sz="2900">
+                <a:solidFill>
+                  <a:srgbClr val="000000"/>
+                </a:solidFill>
+                <a:latin typeface="Helvetica Neue"/>
+                <a:ea typeface="Helvetica Neue"/>
+                <a:cs typeface="Helvetica Neue"/>
+              </a:defRPr>
+            </a:pPr>
+            <a:r>
+              <a:rPr sz="2900">
+                <a:solidFill>
+                  <a:srgbClr val="000000"/>
+                </a:solidFill>
+                <a:latin typeface="Helvetica Neue"/>
+                <a:ea typeface="Helvetica Neue"/>
+                <a:cs typeface="Helvetica Neue"/>
+              </a:rPr>
+              <a:t>Three skills share one evidence-preserving handoff.</a:t>
+            </a:r>
+          </a:p>
+        </p:txBody>
+      </p:sp>
+      <p:sp>
+        <p:nvSpPr>
+          <p:cNvPr id="3" name="Rounded-Rectangle-9-4">
+            <a:extLst xmlns:a="http://schemas.openxmlformats.org/drawingml/2006/main">
+              <a:ext uri="{FF2B5EF4-FFF2-40B4-BE49-F238E27FC236}">
+                <a16:creationId xmlns:a16="http://schemas.microsoft.com/office/drawing/2014/main" id="{77AE61A2-45DC-43BB-8675-E62A1552551F}"/>
+              </a:ext>
+            </a:extLst>
+          </p:cNvPr>
+          <p:cNvSpPr>
+            <a:spLocks xmlns:a="http://schemas.openxmlformats.org/drawingml/2006/main" noGrp="1"/>
+          </p:cNvSpPr>
+          <p:nvPr/>
+        </p:nvSpPr>
+        <p:spPr>
+          <a:xfrm xmlns:a="http://schemas.openxmlformats.org/drawingml/2006/main">
+            <a:off x="4308920" y="3365468"/>
+            <a:ext cx="3568732" cy="2628900"/>
+          </a:xfrm>
+          <a:prstGeom xmlns:a="http://schemas.openxmlformats.org/drawingml/2006/main" prst="roundRect">
+            <a:avLst>
+              <a:gd name="adj" fmla="val 2899"/>
+            </a:avLst>
+          </a:prstGeom>
+          <a:solidFill xmlns:a="http://schemas.openxmlformats.org/drawingml/2006/main">
+            <a:srgbClr val="F2F2F2"/>
+          </a:solidFill>
+        </p:spPr>
+      </p:sp>
+      <p:sp>
+        <p:nvSpPr>
+          <p:cNvPr id="4" name="Rounded-Rectangle-10-5">
+            <a:extLst xmlns:a="http://schemas.openxmlformats.org/drawingml/2006/main">
+              <a:ext uri="{FF2B5EF4-FFF2-40B4-BE49-F238E27FC236}">
+                <a16:creationId xmlns:a16="http://schemas.microsoft.com/office/drawing/2014/main" id="{B378CC50-C05F-4A83-8A2F-F1F16F63D989}"/>
+              </a:ext>
+            </a:extLst>
+          </p:cNvPr>
+          <p:cNvSpPr>
+            <a:spLocks xmlns:a="http://schemas.openxmlformats.org/drawingml/2006/main" noGrp="1"/>
+          </p:cNvSpPr>
+          <p:nvPr/>
+        </p:nvSpPr>
+        <p:spPr>
+          <a:xfrm xmlns:a="http://schemas.openxmlformats.org/drawingml/2006/main">
+            <a:off x="8229600" y="3365468"/>
+            <a:ext cx="3568732" cy="2628900"/>
+          </a:xfrm>
+          <a:prstGeom xmlns:a="http://schemas.openxmlformats.org/drawingml/2006/main" prst="roundRect">
+            <a:avLst>
+              <a:gd name="adj" fmla="val 2899"/>
+            </a:avLst>
+          </a:prstGeom>
+          <a:solidFill xmlns:a="http://schemas.openxmlformats.org/drawingml/2006/main">
+            <a:srgbClr val="F2F2F2"/>
+          </a:solidFill>
+        </p:spPr>
+      </p:sp>
+      <p:sp>
+        <p:nvSpPr>
+          <p:cNvPr id="5" name="Content-Placeholder-9-6">
+            <a:extLst xmlns:a="http://schemas.openxmlformats.org/drawingml/2006/main">
+              <a:ext uri="{FF2B5EF4-FFF2-40B4-BE49-F238E27FC236}">
+                <a16:creationId xmlns:a16="http://schemas.microsoft.com/office/drawing/2014/main" id="{CBAF5CA4-63A0-40AE-86A8-7C1185111798}"/>
+              </a:ext>
+            </a:extLst>
+          </p:cNvPr>
+          <p:cNvSpPr>
+            <a:spLocks xmlns:a="http://schemas.openxmlformats.org/drawingml/2006/main" noGrp="1"/>
+          </p:cNvSpPr>
+          <p:nvPr/>
+        </p:nvSpPr>
+        <p:spPr>
+          <a:xfrm xmlns:a="http://schemas.openxmlformats.org/drawingml/2006/main">
+            <a:off x="4621816" y="4146137"/>
+            <a:ext cx="2949321" cy="1432846"/>
+          </a:xfrm>
+          <a:prstGeom xmlns:a="http://schemas.openxmlformats.org/drawingml/2006/main" prst="rect">
+            <a:avLst/>
+          </a:prstGeom>
+        </p:spPr>
+        <p:txBody>
+          <a:bodyPr xmlns:a="http://schemas.openxmlformats.org/drawingml/2006/main" lIns="0" tIns="0" rIns="0" bIns="0">
+            <a:noAutofit/>
+          </a:bodyPr>
+          <a:lstStyle xmlns:a="http://schemas.openxmlformats.org/drawingml/2006/main"/>
+          <a:p xmlns:a="http://schemas.openxmlformats.org/drawingml/2006/main">
+            <a:pPr algn="l">
+              <a:buNone/>
+              <a:defRPr sz="2400">
+                <a:solidFill>
+                  <a:srgbClr val="000000"/>
+                </a:solidFill>
+                <a:latin typeface="Helvetica Neue"/>
+                <a:ea typeface="Helvetica Neue"/>
+                <a:cs typeface="Helvetica Neue"/>
+              </a:defRPr>
+            </a:pPr>
+            <a:r>
+              <a:rPr sz="1600">
+                <a:solidFill>
+                  <a:srgbClr val="000000"/>
+                </a:solidFill>
+                <a:latin typeface="Helvetica Neue"/>
+                <a:ea typeface="Helvetica Neue"/>
+                <a:cs typeface="Helvetica Neue"/>
+              </a:rPr>
+              <a:t>comm-audit</a:t>
+            </a:r>
+          </a:p>
+          <a:p xmlns:a="http://schemas.openxmlformats.org/drawingml/2006/main">
+            <a:pPr algn="l">
+              <a:buNone/>
+              <a:defRPr sz="2400">
+                <a:solidFill>
+                  <a:srgbClr val="000000"/>
+                </a:solidFill>
+                <a:latin typeface="Helvetica Neue"/>
+                <a:ea typeface="Helvetica Neue"/>
+                <a:cs typeface="Helvetica Neue"/>
+              </a:defRPr>
+            </a:pPr>
+            <a:r>
+              <a:rPr sz="1600">
+                <a:solidFill>
+                  <a:srgbClr val="000000"/>
+                </a:solidFill>
+                <a:latin typeface="Helvetica Neue"/>
+                <a:ea typeface="Helvetica Neue"/>
+                <a:cs typeface="Helvetica Neue"/>
+              </a:rPr>
+              <a:t>Rapid core-claim checks during drafting; full publication or corpus audits when risk and reuse justify them.</a:t>
+            </a:r>
+          </a:p>
+        </p:txBody>
+      </p:sp>
+      <p:sp>
+        <p:nvSpPr>
+          <p:cNvPr id="6" name="Content-Placeholder-10-7">
+            <a:extLst xmlns:a="http://schemas.openxmlformats.org/drawingml/2006/main">
+              <a:ext uri="{FF2B5EF4-FFF2-40B4-BE49-F238E27FC236}">
+                <a16:creationId xmlns:a16="http://schemas.microsoft.com/office/drawing/2014/main" id="{FB3B1F57-ADC7-4C9B-A176-F651A39BD88B}"/>
+              </a:ext>
+            </a:extLst>
+          </p:cNvPr>
+          <p:cNvSpPr>
+            <a:spLocks xmlns:a="http://schemas.openxmlformats.org/drawingml/2006/main" noGrp="1"/>
+          </p:cNvSpPr>
+          <p:nvPr/>
+        </p:nvSpPr>
+        <p:spPr>
+          <a:xfrm xmlns:a="http://schemas.openxmlformats.org/drawingml/2006/main">
+            <a:off x="8536115" y="4146137"/>
+            <a:ext cx="2949321" cy="1432846"/>
+          </a:xfrm>
+          <a:prstGeom xmlns:a="http://schemas.openxmlformats.org/drawingml/2006/main" prst="rect">
+            <a:avLst/>
+          </a:prstGeom>
+        </p:spPr>
+        <p:txBody>
+          <a:bodyPr xmlns:a="http://schemas.openxmlformats.org/drawingml/2006/main" lIns="0" tIns="0" rIns="0" bIns="0">
+            <a:noAutofit/>
+          </a:bodyPr>
+          <a:lstStyle xmlns:a="http://schemas.openxmlformats.org/drawingml/2006/main"/>
+          <a:p xmlns:a="http://schemas.openxmlformats.org/drawingml/2006/main">
+            <a:pPr algn="l">
+              <a:buNone/>
+              <a:defRPr sz="2400">
+                <a:solidFill>
+                  <a:srgbClr val="000000"/>
+                </a:solidFill>
+                <a:latin typeface="Helvetica Neue"/>
+                <a:ea typeface="Helvetica Neue"/>
+                <a:cs typeface="Helvetica Neue"/>
+              </a:defRPr>
+            </a:pPr>
+            <a:r>
+              <a:rPr sz="1600">
+                <a:solidFill>
+                  <a:srgbClr val="000000"/>
+                </a:solidFill>
+                <a:latin typeface="Helvetica Neue"/>
+                <a:ea typeface="Helvetica Neue"/>
+                <a:cs typeface="Helvetica Neue"/>
+              </a:rPr>
+              <a:t>One enforceable rule</a:t>
+            </a:r>
+          </a:p>
+          <a:p xmlns:a="http://schemas.openxmlformats.org/drawingml/2006/main">
+            <a:pPr algn="l">
+              <a:buNone/>
+              <a:defRPr sz="2400">
+                <a:solidFill>
+                  <a:srgbClr val="000000"/>
+                </a:solidFill>
+                <a:latin typeface="Helvetica Neue"/>
+                <a:ea typeface="Helvetica Neue"/>
+                <a:cs typeface="Helvetica Neue"/>
+              </a:defRPr>
+            </a:pPr>
+            <a:r>
+              <a:rPr sz="1600">
+                <a:solidFill>
+                  <a:srgbClr val="000000"/>
+                </a:solidFill>
+                <a:latin typeface="Helvetica Neue"/>
+                <a:ea typeface="Helvetica Neue"/>
+                <a:cs typeface="Helvetica Neue"/>
+              </a:rPr>
+              <a:t>Drafts can arrive early. “Audited,” “final,” and “publishable” wait for human approval and resolved material findings.</a:t>
+            </a:r>
+          </a:p>
+        </p:txBody>
+      </p:sp>
+      <p:sp>
+        <p:nvSpPr>
+          <p:cNvPr id="7" name="Google-Shape-340-p61-8">
+            <a:extLst xmlns:a="http://schemas.openxmlformats.org/drawingml/2006/main">
+              <a:ext uri="{FF2B5EF4-FFF2-40B4-BE49-F238E27FC236}">
+                <a16:creationId xmlns:a16="http://schemas.microsoft.com/office/drawing/2014/main" id="{3C7BD552-A471-40C2-9394-9C73AB928185}"/>
+              </a:ext>
+            </a:extLst>
+          </p:cNvPr>
+          <p:cNvSpPr>
+            <a:spLocks xmlns:a="http://schemas.openxmlformats.org/drawingml/2006/main" noGrp="1"/>
+          </p:cNvSpPr>
+          <p:nvPr/>
+        </p:nvSpPr>
+        <p:spPr>
+          <a:xfrm xmlns:a="http://schemas.openxmlformats.org/drawingml/2006/main">
+            <a:off x="4627626" y="3694081"/>
+            <a:ext cx="233839" cy="233744"/>
+          </a:xfrm>
+          <a:custGeom xmlns:a="http://schemas.openxmlformats.org/drawingml/2006/main">
+            <a:pathLst>
+              <a:path w="205740000" h="205740000">
+                <a:moveTo>
+                  <a:pt x="102870000" y="20574000"/>
+                </a:moveTo>
+                <a:cubicBezTo>
+                  <a:pt x="57426225" y="20574000"/>
+                  <a:pt x="20574000" y="57426225"/>
+                  <a:pt x="20574000" y="102870000"/>
+                </a:cubicBezTo>
+                <a:cubicBezTo>
+                  <a:pt x="20574000" y="148313775"/>
+                  <a:pt x="57426225" y="185166000"/>
+                  <a:pt x="102870000" y="185166000"/>
+                </a:cubicBezTo>
+                <a:cubicBezTo>
+                  <a:pt x="148313775" y="185166000"/>
+                  <a:pt x="185166000" y="148313775"/>
+                  <a:pt x="185166000" y="102870000"/>
+                </a:cubicBezTo>
+                <a:cubicBezTo>
+                  <a:pt x="185166000" y="57426225"/>
+                  <a:pt x="148313775" y="20574000"/>
+                  <a:pt x="102870000" y="20574000"/>
+                </a:cubicBezTo>
+                <a:close/>
+                <a:moveTo>
+                  <a:pt x="0" y="102870000"/>
+                </a:moveTo>
+                <a:cubicBezTo>
+                  <a:pt x="0" y="46053375"/>
+                  <a:pt x="46053375" y="0"/>
+                  <a:pt x="102870000" y="0"/>
+                </a:cubicBezTo>
+                <a:cubicBezTo>
+                  <a:pt x="159686625" y="0"/>
+                  <a:pt x="205740000" y="46053375"/>
+                  <a:pt x="205740000" y="102870000"/>
+                </a:cubicBezTo>
+                <a:cubicBezTo>
+                  <a:pt x="205740000" y="159686625"/>
+                  <a:pt x="159686625" y="205740000"/>
+                  <a:pt x="102870000" y="205740000"/>
+                </a:cubicBezTo>
+                <a:cubicBezTo>
+                  <a:pt x="46053375" y="205740000"/>
+                  <a:pt x="0" y="159686625"/>
+                  <a:pt x="0" y="102870000"/>
+                </a:cubicBezTo>
+                <a:close/>
+                <a:moveTo>
+                  <a:pt x="144789525" y="61026675"/>
+                </a:moveTo>
+                <a:cubicBezTo>
+                  <a:pt x="149437725" y="64293750"/>
+                  <a:pt x="150561675" y="70713600"/>
+                  <a:pt x="147285075" y="75352275"/>
+                </a:cubicBezTo>
+                <a:lnTo>
+                  <a:pt x="98421825" y="144789525"/>
+                </a:lnTo>
+                <a:cubicBezTo>
+                  <a:pt x="96621600" y="147351750"/>
+                  <a:pt x="93764100" y="148942425"/>
+                  <a:pt x="90649425" y="149142450"/>
+                </a:cubicBezTo>
+                <a:cubicBezTo>
+                  <a:pt x="87534750" y="149332950"/>
+                  <a:pt x="84496275" y="148104225"/>
+                  <a:pt x="82400775" y="145799175"/>
+                </a:cubicBezTo>
+                <a:lnTo>
+                  <a:pt x="56683275" y="117509925"/>
+                </a:lnTo>
+                <a:cubicBezTo>
+                  <a:pt x="52863750" y="113299875"/>
+                  <a:pt x="53178075" y="106803825"/>
+                  <a:pt x="57369075" y="102974775"/>
+                </a:cubicBezTo>
+                <a:cubicBezTo>
+                  <a:pt x="61579125" y="99155250"/>
+                  <a:pt x="68075175" y="99469575"/>
+                  <a:pt x="71904225" y="103660575"/>
+                </a:cubicBezTo>
+                <a:lnTo>
+                  <a:pt x="88982550" y="122453400"/>
+                </a:lnTo>
+                <a:lnTo>
+                  <a:pt x="130463925" y="63522225"/>
+                </a:lnTo>
+                <a:cubicBezTo>
+                  <a:pt x="133731000" y="58874025"/>
+                  <a:pt x="140150850" y="57750075"/>
+                  <a:pt x="144789525" y="61026675"/>
+                </a:cubicBezTo>
+                <a:close/>
+              </a:path>
+            </a:pathLst>
+          </a:custGeom>
+          <a:solidFill xmlns:a="http://schemas.openxmlformats.org/drawingml/2006/main">
+            <a:srgbClr val="000000"/>
+          </a:solidFill>
+        </p:spPr>
+      </p:sp>
+      <p:sp>
+        <p:nvSpPr>
+          <p:cNvPr id="8" name="Google-Shape-340-p61-9">
+            <a:extLst xmlns:a="http://schemas.openxmlformats.org/drawingml/2006/main">
+              <a:ext uri="{FF2B5EF4-FFF2-40B4-BE49-F238E27FC236}">
+                <a16:creationId xmlns:a16="http://schemas.microsoft.com/office/drawing/2014/main" id="{EEA6CFB4-4183-4F67-93B1-CED7096376B4}"/>
+              </a:ext>
+            </a:extLst>
+          </p:cNvPr>
+          <p:cNvSpPr>
+            <a:spLocks xmlns:a="http://schemas.openxmlformats.org/drawingml/2006/main" noGrp="1"/>
+          </p:cNvSpPr>
+          <p:nvPr/>
+        </p:nvSpPr>
+        <p:spPr>
+          <a:xfrm xmlns:a="http://schemas.openxmlformats.org/drawingml/2006/main">
+            <a:off x="8533257" y="3694081"/>
+            <a:ext cx="233839" cy="233744"/>
+          </a:xfrm>
+          <a:custGeom xmlns:a="http://schemas.openxmlformats.org/drawingml/2006/main">
+            <a:pathLst>
+              <a:path w="205740000" h="205740000">
+                <a:moveTo>
+                  <a:pt x="102870000" y="20574000"/>
+                </a:moveTo>
+                <a:cubicBezTo>
+                  <a:pt x="57426225" y="20574000"/>
+                  <a:pt x="20574000" y="57426225"/>
+                  <a:pt x="20574000" y="102870000"/>
+                </a:cubicBezTo>
+                <a:cubicBezTo>
+                  <a:pt x="20574000" y="148313775"/>
+                  <a:pt x="57426225" y="185166000"/>
+                  <a:pt x="102870000" y="185166000"/>
+                </a:cubicBezTo>
+                <a:cubicBezTo>
+                  <a:pt x="148313775" y="185166000"/>
+                  <a:pt x="185166000" y="148313775"/>
+                  <a:pt x="185166000" y="102870000"/>
+                </a:cubicBezTo>
+                <a:cubicBezTo>
+                  <a:pt x="185166000" y="57426225"/>
+                  <a:pt x="148313775" y="20574000"/>
+                  <a:pt x="102870000" y="20574000"/>
+                </a:cubicBezTo>
+                <a:close/>
+                <a:moveTo>
+                  <a:pt x="0" y="102870000"/>
+                </a:moveTo>
+                <a:cubicBezTo>
+                  <a:pt x="0" y="46053375"/>
+                  <a:pt x="46053375" y="0"/>
+                  <a:pt x="102870000" y="0"/>
+                </a:cubicBezTo>
+                <a:cubicBezTo>
+                  <a:pt x="159686625" y="0"/>
+                  <a:pt x="205740000" y="46053375"/>
+                  <a:pt x="205740000" y="102870000"/>
+                </a:cubicBezTo>
+                <a:cubicBezTo>
+                  <a:pt x="205740000" y="159686625"/>
+                  <a:pt x="159686625" y="205740000"/>
+                  <a:pt x="102870000" y="205740000"/>
+                </a:cubicBezTo>
+                <a:cubicBezTo>
+                  <a:pt x="46053375" y="205740000"/>
+                  <a:pt x="0" y="159686625"/>
+                  <a:pt x="0" y="102870000"/>
+                </a:cubicBezTo>
+                <a:close/>
+                <a:moveTo>
+                  <a:pt x="144789525" y="61026675"/>
+                </a:moveTo>
+                <a:cubicBezTo>
+                  <a:pt x="149437725" y="64293750"/>
+                  <a:pt x="150561675" y="70713600"/>
+                  <a:pt x="147285075" y="75352275"/>
+                </a:cubicBezTo>
+                <a:lnTo>
+                  <a:pt x="98421825" y="144789525"/>
+                </a:lnTo>
+                <a:cubicBezTo>
+                  <a:pt x="96621600" y="147351750"/>
+                  <a:pt x="93764100" y="148942425"/>
+                  <a:pt x="90649425" y="149142450"/>
+                </a:cubicBezTo>
+                <a:cubicBezTo>
+                  <a:pt x="87534750" y="149332950"/>
+                  <a:pt x="84496275" y="148104225"/>
+                  <a:pt x="82400775" y="145799175"/>
+                </a:cubicBezTo>
+                <a:lnTo>
+                  <a:pt x="56683275" y="117509925"/>
+                </a:lnTo>
+                <a:cubicBezTo>
+                  <a:pt x="52863750" y="113299875"/>
+                  <a:pt x="53178075" y="106803825"/>
+                  <a:pt x="57369075" y="102974775"/>
+                </a:cubicBezTo>
+                <a:cubicBezTo>
+                  <a:pt x="61579125" y="99155250"/>
+                  <a:pt x="68075175" y="99469575"/>
+                  <a:pt x="71904225" y="103660575"/>
+                </a:cubicBezTo>
+                <a:lnTo>
+                  <a:pt x="88982550" y="122453400"/>
+                </a:lnTo>
+                <a:lnTo>
+                  <a:pt x="130463925" y="63522225"/>
+                </a:lnTo>
+                <a:cubicBezTo>
+                  <a:pt x="133731000" y="58874025"/>
+                  <a:pt x="140150850" y="57750075"/>
+                  <a:pt x="144789525" y="61026675"/>
+                </a:cubicBezTo>
+                <a:close/>
+              </a:path>
+            </a:pathLst>
+          </a:custGeom>
+          <a:solidFill xmlns:a="http://schemas.openxmlformats.org/drawingml/2006/main">
+            <a:srgbClr val="000000"/>
+          </a:solidFill>
+        </p:spPr>
+      </p:sp>
+      <p:sp>
+        <p:nvSpPr>
+          <p:cNvPr id="9" name="Rounded-Rectangle-5-10">
+            <a:extLst xmlns:a="http://schemas.openxmlformats.org/drawingml/2006/main">
+              <a:ext uri="{FF2B5EF4-FFF2-40B4-BE49-F238E27FC236}">
+                <a16:creationId xmlns:a16="http://schemas.microsoft.com/office/drawing/2014/main" id="{4EE79339-07AC-4278-B951-0F897B8ECB8C}"/>
+              </a:ext>
+            </a:extLst>
+          </p:cNvPr>
+          <p:cNvSpPr>
+            <a:spLocks xmlns:a="http://schemas.openxmlformats.org/drawingml/2006/main" noGrp="1"/>
+          </p:cNvSpPr>
+          <p:nvPr/>
+        </p:nvSpPr>
+        <p:spPr>
+          <a:xfrm xmlns:a="http://schemas.openxmlformats.org/drawingml/2006/main">
+            <a:off x="388334" y="3365468"/>
+            <a:ext cx="3568732" cy="2628900"/>
+          </a:xfrm>
+          <a:prstGeom xmlns:a="http://schemas.openxmlformats.org/drawingml/2006/main" prst="roundRect">
+            <a:avLst>
+              <a:gd name="adj" fmla="val 2899"/>
+            </a:avLst>
+          </a:prstGeom>
+          <a:solidFill xmlns:a="http://schemas.openxmlformats.org/drawingml/2006/main">
+            <a:srgbClr val="F2F2F2"/>
+          </a:solidFill>
+        </p:spPr>
+      </p:sp>
+      <p:sp>
+        <p:nvSpPr>
+          <p:cNvPr id="10" name="Content-Placeholder-9-11">
+            <a:extLst xmlns:a="http://schemas.openxmlformats.org/drawingml/2006/main">
+              <a:ext uri="{FF2B5EF4-FFF2-40B4-BE49-F238E27FC236}">
+                <a16:creationId xmlns:a16="http://schemas.microsoft.com/office/drawing/2014/main" id="{C885B357-6091-4014-B2DF-06422E1C2259}"/>
+              </a:ext>
+            </a:extLst>
+          </p:cNvPr>
+          <p:cNvSpPr>
+            <a:spLocks xmlns:a="http://schemas.openxmlformats.org/drawingml/2006/main" noGrp="1"/>
+          </p:cNvSpPr>
+          <p:nvPr/>
+        </p:nvSpPr>
+        <p:spPr>
+          <a:xfrm xmlns:a="http://schemas.openxmlformats.org/drawingml/2006/main">
+            <a:off x="701135" y="4146137"/>
+            <a:ext cx="2949321" cy="1432846"/>
+          </a:xfrm>
+          <a:prstGeom xmlns:a="http://schemas.openxmlformats.org/drawingml/2006/main" prst="rect">
+            <a:avLst/>
+          </a:prstGeom>
+        </p:spPr>
+        <p:txBody>
+          <a:bodyPr xmlns:a="http://schemas.openxmlformats.org/drawingml/2006/main" lIns="0" tIns="0" rIns="0" bIns="0">
+            <a:noAutofit/>
+          </a:bodyPr>
+          <a:lstStyle xmlns:a="http://schemas.openxmlformats.org/drawingml/2006/main"/>
+          <a:p xmlns:a="http://schemas.openxmlformats.org/drawingml/2006/main">
+            <a:pPr algn="l">
+              <a:buNone/>
+              <a:defRPr sz="2400">
+                <a:solidFill>
+                  <a:srgbClr val="000000"/>
+                </a:solidFill>
+                <a:latin typeface="Helvetica Neue"/>
+                <a:ea typeface="Helvetica Neue"/>
+                <a:cs typeface="Helvetica Neue"/>
+              </a:defRPr>
+            </a:pPr>
+            <a:r>
+              <a:rPr sz="1600">
+                <a:solidFill>
+                  <a:srgbClr val="000000"/>
+                </a:solidFill>
+                <a:latin typeface="Helvetica Neue"/>
+                <a:ea typeface="Helvetica Neue"/>
+                <a:cs typeface="Helvetica Neue"/>
+              </a:rPr>
+              <a:t>comm-press</a:t>
+            </a:r>
+          </a:p>
+          <a:p xmlns:a="http://schemas.openxmlformats.org/drawingml/2006/main">
+            <a:pPr algn="l">
+              <a:buNone/>
+              <a:defRPr sz="2400">
+                <a:solidFill>
+                  <a:srgbClr val="000000"/>
+                </a:solidFill>
+                <a:latin typeface="Helvetica Neue"/>
+                <a:ea typeface="Helvetica Neue"/>
+                <a:cs typeface="Helvetica Neue"/>
+              </a:defRPr>
+            </a:pPr>
+            <a:r>
+              <a:rPr sz="1600">
+                <a:solidFill>
+                  <a:srgbClr val="000000"/>
+                </a:solidFill>
+                <a:latin typeface="Helvetica Neue"/>
+                <a:ea typeface="Helvetica Neue"/>
+                <a:cs typeface="Helvetica Neue"/>
+              </a:rPr>
+              <a:t>Working releases, briefs, pitches, and journalist FAQs with independent context, quote approval, and rights checks.</a:t>
+            </a:r>
+          </a:p>
+        </p:txBody>
+      </p:sp>
+      <p:sp>
+        <p:nvSpPr>
+          <p:cNvPr id="11" name="Google-Shape-340-p61-12">
+            <a:extLst xmlns:a="http://schemas.openxmlformats.org/drawingml/2006/main">
+              <a:ext uri="{FF2B5EF4-FFF2-40B4-BE49-F238E27FC236}">
+                <a16:creationId xmlns:a16="http://schemas.microsoft.com/office/drawing/2014/main" id="{875F1972-37AC-47DC-8D1F-C0FB8C87A7AC}"/>
+              </a:ext>
+            </a:extLst>
+          </p:cNvPr>
+          <p:cNvSpPr>
+            <a:spLocks xmlns:a="http://schemas.openxmlformats.org/drawingml/2006/main" noGrp="1"/>
+          </p:cNvSpPr>
+          <p:nvPr/>
+        </p:nvSpPr>
+        <p:spPr>
+          <a:xfrm xmlns:a="http://schemas.openxmlformats.org/drawingml/2006/main">
+            <a:off x="707041" y="3694081"/>
+            <a:ext cx="233839" cy="233744"/>
+          </a:xfrm>
+          <a:custGeom xmlns:a="http://schemas.openxmlformats.org/drawingml/2006/main">
+            <a:pathLst>
+              <a:path w="205740000" h="205740000">
+                <a:moveTo>
+                  <a:pt x="102870000" y="20574000"/>
+                </a:moveTo>
+                <a:cubicBezTo>
+                  <a:pt x="57426225" y="20574000"/>
+                  <a:pt x="20574000" y="57426225"/>
+                  <a:pt x="20574000" y="102870000"/>
+                </a:cubicBezTo>
+                <a:cubicBezTo>
+                  <a:pt x="20574000" y="148313775"/>
+                  <a:pt x="57426225" y="185166000"/>
+                  <a:pt x="102870000" y="185166000"/>
+                </a:cubicBezTo>
+                <a:cubicBezTo>
+                  <a:pt x="148313775" y="185166000"/>
+                  <a:pt x="185166000" y="148313775"/>
+                  <a:pt x="185166000" y="102870000"/>
+                </a:cubicBezTo>
+                <a:cubicBezTo>
+                  <a:pt x="185166000" y="57426225"/>
+                  <a:pt x="148313775" y="20574000"/>
+                  <a:pt x="102870000" y="20574000"/>
+                </a:cubicBezTo>
+                <a:close/>
+                <a:moveTo>
+                  <a:pt x="0" y="102870000"/>
+                </a:moveTo>
+                <a:cubicBezTo>
+                  <a:pt x="0" y="46053375"/>
+                  <a:pt x="46053375" y="0"/>
+                  <a:pt x="102870000" y="0"/>
+                </a:cubicBezTo>
+                <a:cubicBezTo>
+                  <a:pt x="159686625" y="0"/>
+                  <a:pt x="205740000" y="46053375"/>
+                  <a:pt x="205740000" y="102870000"/>
+                </a:cubicBezTo>
+                <a:cubicBezTo>
+                  <a:pt x="205740000" y="159686625"/>
+                  <a:pt x="159686625" y="205740000"/>
+                  <a:pt x="102870000" y="205740000"/>
+                </a:cubicBezTo>
+                <a:cubicBezTo>
+                  <a:pt x="46053375" y="205740000"/>
+                  <a:pt x="0" y="159686625"/>
+                  <a:pt x="0" y="102870000"/>
+                </a:cubicBezTo>
+                <a:close/>
+                <a:moveTo>
+                  <a:pt x="144789525" y="61026675"/>
+                </a:moveTo>
+                <a:cubicBezTo>
+                  <a:pt x="149437725" y="64293750"/>
+                  <a:pt x="150561675" y="70713600"/>
+                  <a:pt x="147285075" y="75352275"/>
+                </a:cubicBezTo>
+                <a:lnTo>
+                  <a:pt x="98421825" y="144789525"/>
+                </a:lnTo>
+                <a:cubicBezTo>
+                  <a:pt x="96621600" y="147351750"/>
+                  <a:pt x="93764100" y="148942425"/>
+                  <a:pt x="90649425" y="149142450"/>
+                </a:cubicBezTo>
+                <a:cubicBezTo>
+                  <a:pt x="87534750" y="149332950"/>
+                  <a:pt x="84496275" y="148104225"/>
+                  <a:pt x="82400775" y="145799175"/>
+                </a:cubicBezTo>
+                <a:lnTo>
+                  <a:pt x="56683275" y="117509925"/>
+                </a:lnTo>
+                <a:cubicBezTo>
+                  <a:pt x="52863750" y="113299875"/>
+                  <a:pt x="53178075" y="106803825"/>
+                  <a:pt x="57369075" y="102974775"/>
+                </a:cubicBezTo>
+                <a:cubicBezTo>
+                  <a:pt x="61579125" y="99155250"/>
+                  <a:pt x="68075175" y="99469575"/>
+                  <a:pt x="71904225" y="103660575"/>
+                </a:cubicBezTo>
+                <a:lnTo>
+                  <a:pt x="88982550" y="122453400"/>
+                </a:lnTo>
+                <a:lnTo>
+                  <a:pt x="130463925" y="63522225"/>
+                </a:lnTo>
+                <a:cubicBezTo>
+                  <a:pt x="133731000" y="58874025"/>
+                  <a:pt x="140150850" y="57750075"/>
+                  <a:pt x="144789525" y="61026675"/>
+                </a:cubicBezTo>
+                <a:close/>
+              </a:path>
+            </a:pathLst>
+          </a:custGeom>
+          <a:solidFill xmlns:a="http://schemas.openxmlformats.org/drawingml/2006/main">
+            <a:srgbClr val="000000"/>
+          </a:solidFill>
+        </p:spPr>
+      </p:sp>
+      <p:sp>
+        <p:nvSpPr>
+          <p:cNvPr id="12" name="Content-Placeholder-15-13">
+            <a:extLst xmlns:a="http://schemas.openxmlformats.org/drawingml/2006/main">
+              <a:ext uri="{FF2B5EF4-FFF2-40B4-BE49-F238E27FC236}">
+                <a16:creationId xmlns:a16="http://schemas.microsoft.com/office/drawing/2014/main" id="{464DDC0B-A0A7-44B7-B249-132D2189E40D}"/>
+              </a:ext>
+            </a:extLst>
+          </p:cNvPr>
+          <p:cNvSpPr>
+            <a:spLocks xmlns:a="http://schemas.openxmlformats.org/drawingml/2006/main" noGrp="1"/>
+          </p:cNvSpPr>
+          <p:nvPr/>
+        </p:nvSpPr>
+        <p:spPr>
+          <a:xfrm xmlns:a="http://schemas.openxmlformats.org/drawingml/2006/main">
+            <a:off x="393668" y="1450562"/>
+            <a:ext cx="11404568" cy="1629251"/>
+          </a:xfrm>
+          <a:prstGeom xmlns:a="http://schemas.openxmlformats.org/drawingml/2006/main" prst="rect">
+            <a:avLst/>
+          </a:prstGeom>
+        </p:spPr>
+        <p:txBody>
+          <a:bodyPr xmlns:a="http://schemas.openxmlformats.org/drawingml/2006/main" lIns="0" tIns="0" rIns="0" bIns="0">
+            <a:noAutofit/>
+          </a:bodyPr>
+          <a:lstStyle xmlns:a="http://schemas.openxmlformats.org/drawingml/2006/main"/>
+          <a:p xmlns:a="http://schemas.openxmlformats.org/drawingml/2006/main">
+            <a:pPr algn="l">
+              <a:buNone/>
+              <a:defRPr sz="1600">
+                <a:solidFill>
+                  <a:srgbClr val="000000"/>
+                </a:solidFill>
+                <a:latin typeface="Helvetica Neue"/>
+                <a:ea typeface="Helvetica Neue"/>
+                <a:cs typeface="Helvetica Neue"/>
+              </a:defRPr>
+            </a:pPr>
+            <a:r>
+              <a:rPr sz="1600">
+                <a:solidFill>
+                  <a:srgbClr val="000000"/>
+                </a:solidFill>
+                <a:latin typeface="Helvetica Neue"/>
+                <a:ea typeface="Helvetica Neue"/>
+                <a:cs typeface="Helvetica Neue"/>
+              </a:rPr>
+              <a:t>comm-public</a:t>
+            </a:r>
+          </a:p>
+          <a:p xmlns:a="http://schemas.openxmlformats.org/drawingml/2006/main">
+            <a:pPr algn="l">
+              <a:buNone/>
+              <a:defRPr sz="1600">
+                <a:solidFill>
+                  <a:srgbClr val="000000"/>
+                </a:solidFill>
+                <a:latin typeface="Helvetica Neue"/>
+                <a:ea typeface="Helvetica Neue"/>
+                <a:cs typeface="Helvetica Neue"/>
+              </a:defRPr>
+            </a:pPr>
+            <a:r>
+              <a:rPr sz="1600">
+                <a:solidFill>
+                  <a:srgbClr val="000000"/>
+                </a:solidFill>
+                <a:latin typeface="Helvetica Neue"/>
+                <a:ea typeface="Helvetica Neue"/>
+                <a:cs typeface="Helvetica Neue"/>
+              </a:rPr>
+              <a:t>Fast explainers, FAQs, social copy, visuals, and safer demo briefs for one named audience.</a:t>
+            </a:r>
+          </a:p>
+          <a:p xmlns:a="http://schemas.openxmlformats.org/drawingml/2006/main">
+            <a:pPr algn="l">
+              <a:buNone/>
+              <a:defRPr sz="1600">
+                <a:solidFill>
+                  <a:srgbClr val="000000"/>
+                </a:solidFill>
+                <a:latin typeface="Helvetica Neue"/>
+                <a:ea typeface="Helvetica Neue"/>
+                <a:cs typeface="Helvetica Neue"/>
+              </a:defRPr>
+            </a:pPr>
+            <a:r>
+              <a:rPr sz="1600">
+                <a:solidFill>
+                  <a:srgbClr val="000000"/>
+                </a:solidFill>
+                <a:latin typeface="Helvetica Neue"/>
+                <a:ea typeface="Helvetica Neue"/>
+                <a:cs typeface="Helvetica Neue"/>
+              </a:rPr>
+              <a:t>Audience copy stays separate from evidence and workflow notes.</a:t>
+            </a:r>
+          </a:p>
+        </p:txBody>
+      </p:sp>
+    </p:spTree>
+    <p:extLst>
+      <p:ext uri="{BB962C8B-B14F-4D97-AF65-F5344CB8AC3E}">
+        <p14:creationId xmlns:p14="http://schemas.microsoft.com/office/powerpoint/2010/main" val="1748398193"/>
+      </p:ext>
+    </p:extLst>
+  </p:cSld>
+</p:sld>
+</file>
+
+<file path=ppt/slides/slide6.xml><?xml version="1.0" encoding="utf-8"?>
+<p:sld xmlns:p="http://schemas.openxmlformats.org/presentationml/2006/main">
+  <p:cSld>
+    <p:spTree>
+      <p:nvGrpSpPr>
+        <p:cNvPr id="1" name=""/>
+        <p:cNvGrpSpPr/>
+        <p:nvPr/>
+      </p:nvGrpSpPr>
+      <p:grpSpPr>
+        <a:xfrm xmlns:a="http://schemas.openxmlformats.org/drawingml/2006/main"/>
+      </p:grpSpPr>
+      <p:sp>
+        <p:nvSpPr>
+          <p:cNvPr id="4" name="Title-3-1">
+            <a:extLst xmlns:a="http://schemas.openxmlformats.org/drawingml/2006/main">
+              <a:ext uri="{FF2B5EF4-FFF2-40B4-BE49-F238E27FC236}">
+                <a16:creationId xmlns:a16="http://schemas.microsoft.com/office/drawing/2014/main" id="{996E5D39-115C-4B06-A203-35560FA59E7E}"/>
               </a:ext>
             </a:extLst>
           </p:cNvPr>
@@ -3939,6 +5034,7 @@
           <a:lstStyle xmlns:a="http://schemas.openxmlformats.org/drawingml/2006/main"/>
           <a:p xmlns:a="http://schemas.openxmlformats.org/drawingml/2006/main">
             <a:pPr algn="l">
+              <a:buNone/>
               <a:defRPr sz="6000">
                 <a:solidFill>
                   <a:srgbClr val="000000"/>
@@ -3949,7 +5045,7 @@
               </a:defRPr>
             </a:pPr>
             <a:r>
-              <a:rPr sz="5400">
+              <a:rPr sz="6000">
                 <a:solidFill>
                   <a:srgbClr val="000000"/>
                 </a:solidFill>
@@ -3957,7 +5053,7 @@
                 <a:ea typeface="Helvetica Neue"/>
                 <a:cs typeface="Helvetica Neue"/>
               </a:rPr>
-              <a:t>Install the skills. Start with the worked demo. Make a public claim easier to verify.</a:t>
+              <a:t>Expand to new audiences with human experts.</a:t>
             </a:r>
           </a:p>
         </p:txBody>
@@ -3967,19 +5063,19 @@
           <p:cNvPr id="2" name="Subtitle-4-2">
             <a:extLst xmlns:a="http://schemas.openxmlformats.org/drawingml/2006/main">
               <a:ext uri="{FF2B5EF4-FFF2-40B4-BE49-F238E27FC236}">
-                <a16:creationId xmlns:a16="http://schemas.microsoft.com/office/drawing/2014/main" id="{592F3EDF-31E5-420A-9109-7D6EFB643188}"/>
-              </a:ext>
-            </a:extLst>
-          </p:cNvPr>
-          <p:cNvSpPr>
-            <a:spLocks xmlns:a="http://schemas.openxmlformats.org/drawingml/2006/main" noGrp="1"/>
-          </p:cNvSpPr>
-          <p:nvPr/>
-        </p:nvSpPr>
-        <p:spPr>
-          <a:xfrm xmlns:a="http://schemas.openxmlformats.org/drawingml/2006/main">
-            <a:off x="393668" y="4973288"/>
-            <a:ext cx="3568732" cy="1080230"/>
+                <a16:creationId xmlns:a16="http://schemas.microsoft.com/office/drawing/2014/main" id="{85FCDEE1-E3B8-4D16-B03B-3FFC5A79147F}"/>
+              </a:ext>
+            </a:extLst>
+          </p:cNvPr>
+          <p:cNvSpPr>
+            <a:spLocks xmlns:a="http://schemas.openxmlformats.org/drawingml/2006/main" noGrp="1"/>
+          </p:cNvSpPr>
+          <p:nvPr/>
+        </p:nvSpPr>
+        <p:spPr>
+          <a:xfrm xmlns:a="http://schemas.openxmlformats.org/drawingml/2006/main">
+            <a:off x="393668" y="4742212"/>
+            <a:ext cx="5702332" cy="1080230"/>
           </a:xfrm>
           <a:prstGeom xmlns:a="http://schemas.openxmlformats.org/drawingml/2006/main" prst="rect">
             <a:avLst/>
@@ -3992,6 +5088,7 @@
           <a:lstStyle xmlns:a="http://schemas.openxmlformats.org/drawingml/2006/main"/>
           <a:p xmlns:a="http://schemas.openxmlformats.org/drawingml/2006/main">
             <a:pPr algn="l">
+              <a:buNone/>
               <a:defRPr sz="2400">
                 <a:solidFill>
                   <a:srgbClr val="000000"/>
@@ -4002,7 +5099,7 @@
               </a:defRPr>
             </a:pPr>
             <a:r>
-              <a:rPr sz="2000">
+              <a:rPr sz="1800">
                 <a:solidFill>
                   <a:srgbClr val="000000"/>
                 </a:solidFill>
@@ -4010,53 +5107,7 @@
                 <a:ea typeface="Helvetica Neue"/>
                 <a:cs typeface="Helvetica Neue"/>
               </a:rPr>
-              <a:t>Scan for the GitHub repo</a:t>
-            </a:r>
-          </a:p>
-          <a:p xmlns:a="http://schemas.openxmlformats.org/drawingml/2006/main">
-            <a:pPr algn="l">
-              <a:defRPr sz="2400">
-                <a:solidFill>
-                  <a:srgbClr val="000000"/>
-                </a:solidFill>
-                <a:latin typeface="Helvetica Neue"/>
-                <a:ea typeface="Helvetica Neue"/>
-                <a:cs typeface="Helvetica Neue"/>
-              </a:defRPr>
-            </a:pPr>
-            <a:r>
-              <a:rPr sz="2000">
-                <a:solidFill>
-                  <a:srgbClr val="000000"/>
-                </a:solidFill>
-                <a:latin typeface="Helvetica Neue"/>
-                <a:ea typeface="Helvetica Neue"/>
-                <a:cs typeface="Helvetica Neue"/>
-              </a:rPr>
-              <a:t>Worked demo included</a:t>
-            </a:r>
-          </a:p>
-          <a:p xmlns:a="http://schemas.openxmlformats.org/drawingml/2006/main">
-            <a:pPr algn="l">
-              <a:defRPr sz="2400">
-                <a:solidFill>
-                  <a:srgbClr val="000000"/>
-                </a:solidFill>
-                <a:latin typeface="Helvetica Neue"/>
-                <a:ea typeface="Helvetica Neue"/>
-                <a:cs typeface="Helvetica Neue"/>
-              </a:defRPr>
-            </a:pPr>
-            <a:r>
-              <a:rPr sz="2000">
-                <a:solidFill>
-                  <a:srgbClr val="000000"/>
-                </a:solidFill>
-                <a:latin typeface="Helvetica Neue"/>
-                <a:ea typeface="Helvetica Neue"/>
-                <a:cs typeface="Helvetica Neue"/>
-              </a:rPr>
-              <a:t>Human-reviewed claims</a:t>
+              <a:t>Next: add dedicated skills for policymakers and grantors; co-design and test them with human experts in communication, policy, funding, accessibility, and safety.</a:t>
             </a:r>
           </a:p>
         </p:txBody>
@@ -4066,7 +5117,7 @@
           <p:cNvPr id="3" name="Subtitle-4-3">
             <a:extLst xmlns:a="http://schemas.openxmlformats.org/drawingml/2006/main">
               <a:ext uri="{FF2B5EF4-FFF2-40B4-BE49-F238E27FC236}">
-                <a16:creationId xmlns:a16="http://schemas.microsoft.com/office/drawing/2014/main" id="{27F33065-D539-4843-9A5F-30B32BCCF50D}"/>
+                <a16:creationId xmlns:a16="http://schemas.microsoft.com/office/drawing/2014/main" id="{48EF8B7C-71BC-4BA8-94F6-438DC6DC003A}"/>
               </a:ext>
             </a:extLst>
           </p:cNvPr>
@@ -4078,7 +5129,7 @@
         <p:spPr>
           <a:xfrm xmlns:a="http://schemas.openxmlformats.org/drawingml/2006/main">
             <a:off x="393668" y="392240"/>
-            <a:ext cx="1612868" cy="649129"/>
+            <a:ext cx="5702332" cy="649129"/>
           </a:xfrm>
           <a:prstGeom xmlns:a="http://schemas.openxmlformats.org/drawingml/2006/main" prst="rect">
             <a:avLst/>
@@ -4091,6 +5142,239 @@
           <a:lstStyle xmlns:a="http://schemas.openxmlformats.org/drawingml/2006/main"/>
           <a:p xmlns:a="http://schemas.openxmlformats.org/drawingml/2006/main">
             <a:pPr algn="l">
+              <a:buNone/>
+              <a:defRPr sz="2400">
+                <a:solidFill>
+                  <a:srgbClr val="000000"/>
+                </a:solidFill>
+                <a:latin typeface="Helvetica Neue"/>
+                <a:ea typeface="Helvetica Neue"/>
+                <a:cs typeface="Helvetica Neue"/>
+              </a:defRPr>
+            </a:pPr>
+            <a:r>
+              <a:rPr sz="1800">
+                <a:solidFill>
+                  <a:srgbClr val="000000"/>
+                </a:solidFill>
+                <a:latin typeface="Helvetica Neue"/>
+                <a:ea typeface="Helvetica Neue"/>
+                <a:cs typeface="Helvetica Neue"/>
+              </a:rPr>
+              <a:t>Future plan</a:t>
+            </a:r>
+          </a:p>
+        </p:txBody>
+      </p:sp>
+    </p:spTree>
+    <p:extLst>
+      <p:ext uri="{BB962C8B-B14F-4D97-AF65-F5344CB8AC3E}">
+        <p14:creationId xmlns:p14="http://schemas.microsoft.com/office/powerpoint/2010/main" val="1170619017"/>
+      </p:ext>
+    </p:extLst>
+  </p:cSld>
+</p:sld>
+</file>
+
+<file path=ppt/slides/slide7.xml><?xml version="1.0" encoding="utf-8"?>
+<p:sld xmlns:p="http://schemas.openxmlformats.org/presentationml/2006/main">
+  <p:cSld>
+    <p:spTree>
+      <p:nvGrpSpPr>
+        <p:cNvPr id="1" name=""/>
+        <p:cNvGrpSpPr/>
+        <p:nvPr/>
+      </p:nvGrpSpPr>
+      <p:grpSpPr>
+        <a:xfrm xmlns:a="http://schemas.openxmlformats.org/drawingml/2006/main"/>
+      </p:grpSpPr>
+      <p:sp>
+        <p:nvSpPr>
+          <p:cNvPr id="5" name="Title-3-1">
+            <a:extLst xmlns:a="http://schemas.openxmlformats.org/drawingml/2006/main">
+              <a:ext uri="{FF2B5EF4-FFF2-40B4-BE49-F238E27FC236}">
+                <a16:creationId xmlns:a16="http://schemas.microsoft.com/office/drawing/2014/main" id="{719F3077-BB57-4574-A1C5-D479A04FBA95}"/>
+              </a:ext>
+            </a:extLst>
+          </p:cNvPr>
+          <p:cNvSpPr>
+            <a:spLocks xmlns:a="http://schemas.openxmlformats.org/drawingml/2006/main" noGrp="1"/>
+          </p:cNvSpPr>
+          <p:nvPr/>
+        </p:nvSpPr>
+        <p:spPr>
+          <a:xfrm xmlns:a="http://schemas.openxmlformats.org/drawingml/2006/main">
+            <a:off x="393668" y="1738789"/>
+            <a:ext cx="9448800" cy="2491454"/>
+          </a:xfrm>
+          <a:prstGeom xmlns:a="http://schemas.openxmlformats.org/drawingml/2006/main" prst="rect">
+            <a:avLst/>
+          </a:prstGeom>
+        </p:spPr>
+        <p:txBody>
+          <a:bodyPr xmlns:a="http://schemas.openxmlformats.org/drawingml/2006/main" lIns="0" tIns="0" rIns="0" bIns="0" anchor="b">
+            <a:noAutofit/>
+          </a:bodyPr>
+          <a:lstStyle xmlns:a="http://schemas.openxmlformats.org/drawingml/2006/main"/>
+          <a:p xmlns:a="http://schemas.openxmlformats.org/drawingml/2006/main">
+            <a:pPr algn="l">
+              <a:buNone/>
+              <a:defRPr sz="6000">
+                <a:solidFill>
+                  <a:srgbClr val="000000"/>
+                </a:solidFill>
+                <a:latin typeface="Helvetica Neue"/>
+                <a:ea typeface="Helvetica Neue"/>
+                <a:cs typeface="Helvetica Neue"/>
+              </a:defRPr>
+            </a:pPr>
+            <a:r>
+              <a:rPr sz="5400">
+                <a:solidFill>
+                  <a:srgbClr val="000000"/>
+                </a:solidFill>
+                <a:latin typeface="Helvetica Neue"/>
+                <a:ea typeface="Helvetica Neue"/>
+                <a:cs typeface="Helvetica Neue"/>
+              </a:rPr>
+              <a:t>Install the skills. Start with the worked demo. Make a public claim easier to verify.</a:t>
+            </a:r>
+          </a:p>
+        </p:txBody>
+      </p:sp>
+      <p:sp>
+        <p:nvSpPr>
+          <p:cNvPr id="2" name="Subtitle-4-2">
+            <a:extLst xmlns:a="http://schemas.openxmlformats.org/drawingml/2006/main">
+              <a:ext uri="{FF2B5EF4-FFF2-40B4-BE49-F238E27FC236}">
+                <a16:creationId xmlns:a16="http://schemas.microsoft.com/office/drawing/2014/main" id="{592F3EDF-31E5-420A-9109-7D6EFB643188}"/>
+              </a:ext>
+            </a:extLst>
+          </p:cNvPr>
+          <p:cNvSpPr>
+            <a:spLocks xmlns:a="http://schemas.openxmlformats.org/drawingml/2006/main" noGrp="1"/>
+          </p:cNvSpPr>
+          <p:nvPr/>
+        </p:nvSpPr>
+        <p:spPr>
+          <a:xfrm xmlns:a="http://schemas.openxmlformats.org/drawingml/2006/main">
+            <a:off x="393668" y="4973288"/>
+            <a:ext cx="3568732" cy="1080230"/>
+          </a:xfrm>
+          <a:prstGeom xmlns:a="http://schemas.openxmlformats.org/drawingml/2006/main" prst="rect">
+            <a:avLst/>
+          </a:prstGeom>
+        </p:spPr>
+        <p:txBody>
+          <a:bodyPr xmlns:a="http://schemas.openxmlformats.org/drawingml/2006/main" lIns="0" tIns="0" rIns="0" bIns="0">
+            <a:noAutofit/>
+          </a:bodyPr>
+          <a:lstStyle xmlns:a="http://schemas.openxmlformats.org/drawingml/2006/main"/>
+          <a:p xmlns:a="http://schemas.openxmlformats.org/drawingml/2006/main">
+            <a:pPr algn="l">
+              <a:buNone/>
+              <a:defRPr sz="2400">
+                <a:solidFill>
+                  <a:srgbClr val="000000"/>
+                </a:solidFill>
+                <a:latin typeface="Helvetica Neue"/>
+                <a:ea typeface="Helvetica Neue"/>
+                <a:cs typeface="Helvetica Neue"/>
+              </a:defRPr>
+            </a:pPr>
+            <a:r>
+              <a:rPr sz="2000">
+                <a:solidFill>
+                  <a:srgbClr val="000000"/>
+                </a:solidFill>
+                <a:latin typeface="Helvetica Neue"/>
+                <a:ea typeface="Helvetica Neue"/>
+                <a:cs typeface="Helvetica Neue"/>
+              </a:rPr>
+              <a:t>mychiffonn/comm-ai-safety</a:t>
+            </a:r>
+          </a:p>
+          <a:p xmlns:a="http://schemas.openxmlformats.org/drawingml/2006/main">
+            <a:pPr algn="l">
+              <a:buNone/>
+              <a:defRPr sz="2400">
+                <a:solidFill>
+                  <a:srgbClr val="000000"/>
+                </a:solidFill>
+                <a:latin typeface="Helvetica Neue"/>
+                <a:ea typeface="Helvetica Neue"/>
+                <a:cs typeface="Helvetica Neue"/>
+              </a:defRPr>
+            </a:pPr>
+            <a:r>
+              <a:rPr sz="2000">
+                <a:solidFill>
+                  <a:srgbClr val="000000"/>
+                </a:solidFill>
+                <a:latin typeface="Helvetica Neue"/>
+                <a:ea typeface="Helvetica Neue"/>
+                <a:cs typeface="Helvetica Neue"/>
+              </a:rPr>
+              <a:t>Fast draft, proportionate audit</a:t>
+            </a:r>
+          </a:p>
+          <a:p xmlns:a="http://schemas.openxmlformats.org/drawingml/2006/main">
+            <a:pPr algn="l">
+              <a:buNone/>
+              <a:defRPr sz="2400">
+                <a:solidFill>
+                  <a:srgbClr val="000000"/>
+                </a:solidFill>
+                <a:latin typeface="Helvetica Neue"/>
+                <a:ea typeface="Helvetica Neue"/>
+                <a:cs typeface="Helvetica Neue"/>
+              </a:defRPr>
+            </a:pPr>
+            <a:r>
+              <a:rPr sz="2000">
+                <a:solidFill>
+                  <a:srgbClr val="000000"/>
+                </a:solidFill>
+                <a:latin typeface="Helvetica Neue"/>
+                <a:ea typeface="Helvetica Neue"/>
+                <a:cs typeface="Helvetica Neue"/>
+              </a:rPr>
+              <a:t>Worked demo included</a:t>
+            </a:r>
+          </a:p>
+        </p:txBody>
+      </p:sp>
+      <p:sp>
+        <p:nvSpPr>
+          <p:cNvPr id="3" name="Subtitle-4-3">
+            <a:extLst xmlns:a="http://schemas.openxmlformats.org/drawingml/2006/main">
+              <a:ext uri="{FF2B5EF4-FFF2-40B4-BE49-F238E27FC236}">
+                <a16:creationId xmlns:a16="http://schemas.microsoft.com/office/drawing/2014/main" id="{27F33065-D539-4843-9A5F-30B32BCCF50D}"/>
+              </a:ext>
+            </a:extLst>
+          </p:cNvPr>
+          <p:cNvSpPr>
+            <a:spLocks xmlns:a="http://schemas.openxmlformats.org/drawingml/2006/main" noGrp="1"/>
+          </p:cNvSpPr>
+          <p:nvPr/>
+        </p:nvSpPr>
+        <p:spPr>
+          <a:xfrm xmlns:a="http://schemas.openxmlformats.org/drawingml/2006/main">
+            <a:off x="393668" y="392240"/>
+            <a:ext cx="1612868" cy="649129"/>
+          </a:xfrm>
+          <a:prstGeom xmlns:a="http://schemas.openxmlformats.org/drawingml/2006/main" prst="rect">
+            <a:avLst/>
+          </a:prstGeom>
+        </p:spPr>
+        <p:txBody>
+          <a:bodyPr xmlns:a="http://schemas.openxmlformats.org/drawingml/2006/main" lIns="0" tIns="0" rIns="0" bIns="0">
+            <a:noAutofit/>
+          </a:bodyPr>
+          <a:lstStyle xmlns:a="http://schemas.openxmlformats.org/drawingml/2006/main"/>
+          <a:p xmlns:a="http://schemas.openxmlformats.org/drawingml/2006/main">
+            <a:pPr algn="l">
+              <a:buNone/>
               <a:defRPr sz="2400">
                 <a:solidFill>
                   <a:srgbClr val="000000"/>
@@ -4116,14 +5400,14 @@
       </p:sp>
       <p:pic>
         <p:nvPicPr>
-          <p:cNvPr id="8" name=""/>
+          <p:cNvPr id="10" name=""/>
           <p:cNvPicPr>
             <a:picLocks xmlns:a="http://schemas.openxmlformats.org/drawingml/2006/main" noChangeAspect="1"/>
           </p:cNvPicPr>
           <p:nvPr/>
         </p:nvPicPr>
         <p:blipFill>
-          <a:blip xmlns:r="http://schemas.openxmlformats.org/officeDocument/2006/relationships" xmlns:a="http://schemas.openxmlformats.org/drawingml/2006/main" r:embed="Rd1e73d3c3fb2441a"/>
+          <a:blip xmlns:r="http://schemas.openxmlformats.org/officeDocument/2006/relationships" xmlns:a="http://schemas.openxmlformats.org/drawingml/2006/main" r:embed="R353f1129c21a4104"/>
           <a:stretch xmlns:a="http://schemas.openxmlformats.org/drawingml/2006/main"/>
         </p:blipFill>
         <p:spPr>

</xml_diff>